<commit_message>
Full dev branch: complete project + new analyses
- Model 2 reworked: multilingual MiniLM + MLP (Kinyarwanda), F1 0.40
- Cross-lingual degradation analysis (EN 0.63 -> RW 0.53, 17% drop)
- Confidence-gate calibration (0.40 gate = 12% coverage; curve added)
- Part III -> clean Colab pointer (colab_afroxlmr_finetune.ipynb)
- Deployment: requirements.txt + README.md
- Notebook re-executed end-to-end, no errors
</commit_message>
<xml_diff>
--- a/docs/Umubyeyi_Presentation.pptx
+++ b/docs/Umubyeyi_Presentation.pptx
@@ -1,25 +1,25 @@
 
 <file path=ppt/presentation.xml><?xml version="1.0" encoding="utf-8"?>
-<p:presentation xmlns:a="http://schemas.openxmlformats.org/drawingml/2006/main" xmlns:r="http://schemas.openxmlformats.org/officeDocument/2006/relationships" xmlns:p="http://schemas.openxmlformats.org/presentationml/2006/main" saveSubsetFonts="1" autoCompressPictures="0">
+<p:presentation xmlns:a="http://schemas.openxmlformats.org/drawingml/2006/main" xmlns:r="http://schemas.openxmlformats.org/officeDocument/2006/relationships" xmlns:p="http://schemas.openxmlformats.org/presentationml/2006/main" autoCompressPictures="0">
   <p:sldMasterIdLst>
     <p:sldMasterId id="2147483648" r:id="rId1"/>
   </p:sldMasterIdLst>
   <p:sldIdLst>
-    <p:sldId id="256" r:id="rId7"/>
-    <p:sldId id="257" r:id="rId8"/>
-    <p:sldId id="258" r:id="rId9"/>
-    <p:sldId id="259" r:id="rId10"/>
-    <p:sldId id="260" r:id="rId11"/>
-    <p:sldId id="261" r:id="rId12"/>
-    <p:sldId id="262" r:id="rId13"/>
-    <p:sldId id="263" r:id="rId14"/>
-    <p:sldId id="264" r:id="rId15"/>
-    <p:sldId id="265" r:id="rId16"/>
-    <p:sldId id="266" r:id="rId17"/>
-    <p:sldId id="267" r:id="rId18"/>
-    <p:sldId id="268" r:id="rId19"/>
+    <p:sldId id="256" r:id="rId3"/>
+    <p:sldId id="257" r:id="rId4"/>
+    <p:sldId id="258" r:id="rId5"/>
+    <p:sldId id="259" r:id="rId6"/>
+    <p:sldId id="260" r:id="rId7"/>
+    <p:sldId id="261" r:id="rId8"/>
+    <p:sldId id="262" r:id="rId9"/>
+    <p:sldId id="263" r:id="rId10"/>
+    <p:sldId id="264" r:id="rId11"/>
+    <p:sldId id="265" r:id="rId12"/>
+    <p:sldId id="266" r:id="rId13"/>
+    <p:sldId id="267" r:id="rId14"/>
+    <p:sldId id="268" r:id="rId15"/>
   </p:sldIdLst>
-  <p:sldSz cx="12191695" cy="6858000" type="screen4x3"/>
+  <p:sldSz cx="12191365" cy="6858000" type="screen4x3"/>
   <p:notesSz cx="6858000" cy="9144000"/>
   <p:defaultTextStyle>
     <a:defPPr>
@@ -116,6 +116,22 @@
       </a:defRPr>
     </a:lvl9pPr>
   </p:defaultTextStyle>
+  <p:extLst>
+    <p:ext uri="{EFAFB233-063F-42B5-8137-9DF3F51BA10A}">
+      <p15:sldGuideLst xmlns:p15="http://schemas.microsoft.com/office/powerpoint/2012/main">
+        <p15:guide id="1" orient="horz" pos="2160" userDrawn="1">
+          <p15:clr>
+            <a:srgbClr val="A4A3A4"/>
+          </p15:clr>
+        </p15:guide>
+        <p15:guide id="2" pos="2880" userDrawn="1">
+          <p15:clr>
+            <a:srgbClr val="A4A3A4"/>
+          </p15:clr>
+        </p15:guide>
+      </p15:sldGuideLst>
+    </p:ext>
+  </p:extLst>
 </p:presentation>
 </file>
 
@@ -300,7 +316,6 @@
           <a:p>
             <a:fld id="{5BCAD085-E8A6-8845-BD4E-CB4CCA059FC4}" type="datetimeFigureOut">
               <a:rPr lang="en-US" smtClean="0"/>
-              <a:t>1/27/13</a:t>
             </a:fld>
             <a:endParaRPr lang="en-US"/>
           </a:p>
@@ -342,18 +357,12 @@
           <a:p>
             <a:fld id="{C1FF6DA9-008F-8B48-92A6-B652298478BF}" type="slidenum">
               <a:rPr lang="en-US" smtClean="0"/>
-              <a:t>‹#›</a:t>
             </a:fld>
             <a:endParaRPr lang="en-US"/>
           </a:p>
         </p:txBody>
       </p:sp>
     </p:spTree>
-    <p:extLst>
-      <p:ext uri="{BB962C8B-B14F-4D97-AF65-F5344CB8AC3E}">
-        <p14:creationId xmlns:p14="http://schemas.microsoft.com/office/powerpoint/2010/main" val="3168075583"/>
-      </p:ext>
-    </p:extLst>
   </p:cSld>
   <p:clrMapOvr>
     <a:masterClrMapping/>
@@ -421,6 +430,7 @@
               <a:rPr lang="en-US" smtClean="0"/>
               <a:t>Click to edit Master text styles</a:t>
             </a:r>
+            <a:endParaRPr lang="en-US" smtClean="0"/>
           </a:p>
           <a:p>
             <a:pPr lvl="1"/>
@@ -428,6 +438,7 @@
               <a:rPr lang="en-US" smtClean="0"/>
               <a:t>Second level</a:t>
             </a:r>
+            <a:endParaRPr lang="en-US" smtClean="0"/>
           </a:p>
           <a:p>
             <a:pPr lvl="2"/>
@@ -435,6 +446,7 @@
               <a:rPr lang="en-US" smtClean="0"/>
               <a:t>Third level</a:t>
             </a:r>
+            <a:endParaRPr lang="en-US" smtClean="0"/>
           </a:p>
           <a:p>
             <a:pPr lvl="3"/>
@@ -442,6 +454,7 @@
               <a:rPr lang="en-US" smtClean="0"/>
               <a:t>Fourth level</a:t>
             </a:r>
+            <a:endParaRPr lang="en-US" smtClean="0"/>
           </a:p>
           <a:p>
             <a:pPr lvl="4"/>
@@ -470,7 +483,6 @@
           <a:p>
             <a:fld id="{5BCAD085-E8A6-8845-BD4E-CB4CCA059FC4}" type="datetimeFigureOut">
               <a:rPr lang="en-US" smtClean="0"/>
-              <a:t>1/27/13</a:t>
             </a:fld>
             <a:endParaRPr lang="en-US"/>
           </a:p>
@@ -512,18 +524,12 @@
           <a:p>
             <a:fld id="{C1FF6DA9-008F-8B48-92A6-B652298478BF}" type="slidenum">
               <a:rPr lang="en-US" smtClean="0"/>
-              <a:t>‹#›</a:t>
             </a:fld>
             <a:endParaRPr lang="en-US"/>
           </a:p>
         </p:txBody>
       </p:sp>
     </p:spTree>
-    <p:extLst>
-      <p:ext uri="{BB962C8B-B14F-4D97-AF65-F5344CB8AC3E}">
-        <p14:creationId xmlns:p14="http://schemas.microsoft.com/office/powerpoint/2010/main" val="2910927964"/>
-      </p:ext>
-    </p:extLst>
   </p:cSld>
   <p:clrMapOvr>
     <a:masterClrMapping/>
@@ -601,6 +607,7 @@
               <a:rPr lang="en-US" smtClean="0"/>
               <a:t>Click to edit Master text styles</a:t>
             </a:r>
+            <a:endParaRPr lang="en-US" smtClean="0"/>
           </a:p>
           <a:p>
             <a:pPr lvl="1"/>
@@ -608,6 +615,7 @@
               <a:rPr lang="en-US" smtClean="0"/>
               <a:t>Second level</a:t>
             </a:r>
+            <a:endParaRPr lang="en-US" smtClean="0"/>
           </a:p>
           <a:p>
             <a:pPr lvl="2"/>
@@ -615,6 +623,7 @@
               <a:rPr lang="en-US" smtClean="0"/>
               <a:t>Third level</a:t>
             </a:r>
+            <a:endParaRPr lang="en-US" smtClean="0"/>
           </a:p>
           <a:p>
             <a:pPr lvl="3"/>
@@ -622,6 +631,7 @@
               <a:rPr lang="en-US" smtClean="0"/>
               <a:t>Fourth level</a:t>
             </a:r>
+            <a:endParaRPr lang="en-US" smtClean="0"/>
           </a:p>
           <a:p>
             <a:pPr lvl="4"/>
@@ -650,7 +660,6 @@
           <a:p>
             <a:fld id="{5BCAD085-E8A6-8845-BD4E-CB4CCA059FC4}" type="datetimeFigureOut">
               <a:rPr lang="en-US" smtClean="0"/>
-              <a:t>1/27/13</a:t>
             </a:fld>
             <a:endParaRPr lang="en-US"/>
           </a:p>
@@ -692,18 +701,12 @@
           <a:p>
             <a:fld id="{C1FF6DA9-008F-8B48-92A6-B652298478BF}" type="slidenum">
               <a:rPr lang="en-US" smtClean="0"/>
-              <a:t>‹#›</a:t>
             </a:fld>
             <a:endParaRPr lang="en-US"/>
           </a:p>
         </p:txBody>
       </p:sp>
     </p:spTree>
-    <p:extLst>
-      <p:ext uri="{BB962C8B-B14F-4D97-AF65-F5344CB8AC3E}">
-        <p14:creationId xmlns:p14="http://schemas.microsoft.com/office/powerpoint/2010/main" val="3612223792"/>
-      </p:ext>
-    </p:extLst>
   </p:cSld>
   <p:clrMapOvr>
     <a:masterClrMapping/>
@@ -771,6 +774,7 @@
               <a:rPr lang="en-US" smtClean="0"/>
               <a:t>Click to edit Master text styles</a:t>
             </a:r>
+            <a:endParaRPr lang="en-US" smtClean="0"/>
           </a:p>
           <a:p>
             <a:pPr lvl="1"/>
@@ -778,6 +782,7 @@
               <a:rPr lang="en-US" smtClean="0"/>
               <a:t>Second level</a:t>
             </a:r>
+            <a:endParaRPr lang="en-US" smtClean="0"/>
           </a:p>
           <a:p>
             <a:pPr lvl="2"/>
@@ -785,6 +790,7 @@
               <a:rPr lang="en-US" smtClean="0"/>
               <a:t>Third level</a:t>
             </a:r>
+            <a:endParaRPr lang="en-US" smtClean="0"/>
           </a:p>
           <a:p>
             <a:pPr lvl="3"/>
@@ -792,6 +798,7 @@
               <a:rPr lang="en-US" smtClean="0"/>
               <a:t>Fourth level</a:t>
             </a:r>
+            <a:endParaRPr lang="en-US" smtClean="0"/>
           </a:p>
           <a:p>
             <a:pPr lvl="4"/>
@@ -820,7 +827,6 @@
           <a:p>
             <a:fld id="{5BCAD085-E8A6-8845-BD4E-CB4CCA059FC4}" type="datetimeFigureOut">
               <a:rPr lang="en-US" smtClean="0"/>
-              <a:t>1/27/13</a:t>
             </a:fld>
             <a:endParaRPr lang="en-US"/>
           </a:p>
@@ -862,18 +868,12 @@
           <a:p>
             <a:fld id="{C1FF6DA9-008F-8B48-92A6-B652298478BF}" type="slidenum">
               <a:rPr lang="en-US" smtClean="0"/>
-              <a:t>‹#›</a:t>
             </a:fld>
             <a:endParaRPr lang="en-US"/>
           </a:p>
         </p:txBody>
       </p:sp>
     </p:spTree>
-    <p:extLst>
-      <p:ext uri="{BB962C8B-B14F-4D97-AF65-F5344CB8AC3E}">
-        <p14:creationId xmlns:p14="http://schemas.microsoft.com/office/powerpoint/2010/main" val="2614314258"/>
-      </p:ext>
-    </p:extLst>
   </p:cSld>
   <p:clrMapOvr>
     <a:masterClrMapping/>
@@ -1046,6 +1046,7 @@
               <a:rPr lang="en-US" smtClean="0"/>
               <a:t>Click to edit Master text styles</a:t>
             </a:r>
+            <a:endParaRPr lang="en-US" smtClean="0"/>
           </a:p>
         </p:txBody>
       </p:sp>
@@ -1066,7 +1067,6 @@
           <a:p>
             <a:fld id="{5BCAD085-E8A6-8845-BD4E-CB4CCA059FC4}" type="datetimeFigureOut">
               <a:rPr lang="en-US" smtClean="0"/>
-              <a:t>1/27/13</a:t>
             </a:fld>
             <a:endParaRPr lang="en-US"/>
           </a:p>
@@ -1108,18 +1108,12 @@
           <a:p>
             <a:fld id="{C1FF6DA9-008F-8B48-92A6-B652298478BF}" type="slidenum">
               <a:rPr lang="en-US" smtClean="0"/>
-              <a:t>‹#›</a:t>
             </a:fld>
             <a:endParaRPr lang="en-US"/>
           </a:p>
         </p:txBody>
       </p:sp>
     </p:spTree>
-    <p:extLst>
-      <p:ext uri="{BB962C8B-B14F-4D97-AF65-F5344CB8AC3E}">
-        <p14:creationId xmlns:p14="http://schemas.microsoft.com/office/powerpoint/2010/main" val="960648375"/>
-      </p:ext>
-    </p:extLst>
   </p:cSld>
   <p:clrMapOvr>
     <a:masterClrMapping/>
@@ -1220,6 +1214,7 @@
               <a:rPr lang="en-US" smtClean="0"/>
               <a:t>Click to edit Master text styles</a:t>
             </a:r>
+            <a:endParaRPr lang="en-US" smtClean="0"/>
           </a:p>
           <a:p>
             <a:pPr lvl="1"/>
@@ -1227,6 +1222,7 @@
               <a:rPr lang="en-US" smtClean="0"/>
               <a:t>Second level</a:t>
             </a:r>
+            <a:endParaRPr lang="en-US" smtClean="0"/>
           </a:p>
           <a:p>
             <a:pPr lvl="2"/>
@@ -1234,6 +1230,7 @@
               <a:rPr lang="en-US" smtClean="0"/>
               <a:t>Third level</a:t>
             </a:r>
+            <a:endParaRPr lang="en-US" smtClean="0"/>
           </a:p>
           <a:p>
             <a:pPr lvl="3"/>
@@ -1241,6 +1238,7 @@
               <a:rPr lang="en-US" smtClean="0"/>
               <a:t>Fourth level</a:t>
             </a:r>
+            <a:endParaRPr lang="en-US" smtClean="0"/>
           </a:p>
           <a:p>
             <a:pPr lvl="4"/>
@@ -1305,6 +1303,7 @@
               <a:rPr lang="en-US" smtClean="0"/>
               <a:t>Click to edit Master text styles</a:t>
             </a:r>
+            <a:endParaRPr lang="en-US" smtClean="0"/>
           </a:p>
           <a:p>
             <a:pPr lvl="1"/>
@@ -1312,6 +1311,7 @@
               <a:rPr lang="en-US" smtClean="0"/>
               <a:t>Second level</a:t>
             </a:r>
+            <a:endParaRPr lang="en-US" smtClean="0"/>
           </a:p>
           <a:p>
             <a:pPr lvl="2"/>
@@ -1319,6 +1319,7 @@
               <a:rPr lang="en-US" smtClean="0"/>
               <a:t>Third level</a:t>
             </a:r>
+            <a:endParaRPr lang="en-US" smtClean="0"/>
           </a:p>
           <a:p>
             <a:pPr lvl="3"/>
@@ -1326,6 +1327,7 @@
               <a:rPr lang="en-US" smtClean="0"/>
               <a:t>Fourth level</a:t>
             </a:r>
+            <a:endParaRPr lang="en-US" smtClean="0"/>
           </a:p>
           <a:p>
             <a:pPr lvl="4"/>
@@ -1354,7 +1356,6 @@
           <a:p>
             <a:fld id="{5BCAD085-E8A6-8845-BD4E-CB4CCA059FC4}" type="datetimeFigureOut">
               <a:rPr lang="en-US" smtClean="0"/>
-              <a:t>1/27/13</a:t>
             </a:fld>
             <a:endParaRPr lang="en-US"/>
           </a:p>
@@ -1396,18 +1397,12 @@
           <a:p>
             <a:fld id="{C1FF6DA9-008F-8B48-92A6-B652298478BF}" type="slidenum">
               <a:rPr lang="en-US" smtClean="0"/>
-              <a:t>‹#›</a:t>
             </a:fld>
             <a:endParaRPr lang="en-US"/>
           </a:p>
         </p:txBody>
       </p:sp>
     </p:spTree>
-    <p:extLst>
-      <p:ext uri="{BB962C8B-B14F-4D97-AF65-F5344CB8AC3E}">
-        <p14:creationId xmlns:p14="http://schemas.microsoft.com/office/powerpoint/2010/main" val="2782244947"/>
-      </p:ext>
-    </p:extLst>
   </p:cSld>
   <p:clrMapOvr>
     <a:masterClrMapping/>
@@ -1521,6 +1516,7 @@
               <a:rPr lang="en-US" smtClean="0"/>
               <a:t>Click to edit Master text styles</a:t>
             </a:r>
+            <a:endParaRPr lang="en-US" smtClean="0"/>
           </a:p>
         </p:txBody>
       </p:sp>
@@ -1577,6 +1573,7 @@
               <a:rPr lang="en-US" smtClean="0"/>
               <a:t>Click to edit Master text styles</a:t>
             </a:r>
+            <a:endParaRPr lang="en-US" smtClean="0"/>
           </a:p>
           <a:p>
             <a:pPr lvl="1"/>
@@ -1584,6 +1581,7 @@
               <a:rPr lang="en-US" smtClean="0"/>
               <a:t>Second level</a:t>
             </a:r>
+            <a:endParaRPr lang="en-US" smtClean="0"/>
           </a:p>
           <a:p>
             <a:pPr lvl="2"/>
@@ -1591,6 +1589,7 @@
               <a:rPr lang="en-US" smtClean="0"/>
               <a:t>Third level</a:t>
             </a:r>
+            <a:endParaRPr lang="en-US" smtClean="0"/>
           </a:p>
           <a:p>
             <a:pPr lvl="3"/>
@@ -1598,6 +1597,7 @@
               <a:rPr lang="en-US" smtClean="0"/>
               <a:t>Fourth level</a:t>
             </a:r>
+            <a:endParaRPr lang="en-US" smtClean="0"/>
           </a:p>
           <a:p>
             <a:pPr lvl="4"/>
@@ -1671,6 +1671,7 @@
               <a:rPr lang="en-US" smtClean="0"/>
               <a:t>Click to edit Master text styles</a:t>
             </a:r>
+            <a:endParaRPr lang="en-US" smtClean="0"/>
           </a:p>
         </p:txBody>
       </p:sp>
@@ -1727,6 +1728,7 @@
               <a:rPr lang="en-US" smtClean="0"/>
               <a:t>Click to edit Master text styles</a:t>
             </a:r>
+            <a:endParaRPr lang="en-US" smtClean="0"/>
           </a:p>
           <a:p>
             <a:pPr lvl="1"/>
@@ -1734,6 +1736,7 @@
               <a:rPr lang="en-US" smtClean="0"/>
               <a:t>Second level</a:t>
             </a:r>
+            <a:endParaRPr lang="en-US" smtClean="0"/>
           </a:p>
           <a:p>
             <a:pPr lvl="2"/>
@@ -1741,6 +1744,7 @@
               <a:rPr lang="en-US" smtClean="0"/>
               <a:t>Third level</a:t>
             </a:r>
+            <a:endParaRPr lang="en-US" smtClean="0"/>
           </a:p>
           <a:p>
             <a:pPr lvl="3"/>
@@ -1748,6 +1752,7 @@
               <a:rPr lang="en-US" smtClean="0"/>
               <a:t>Fourth level</a:t>
             </a:r>
+            <a:endParaRPr lang="en-US" smtClean="0"/>
           </a:p>
           <a:p>
             <a:pPr lvl="4"/>
@@ -1776,7 +1781,6 @@
           <a:p>
             <a:fld id="{5BCAD085-E8A6-8845-BD4E-CB4CCA059FC4}" type="datetimeFigureOut">
               <a:rPr lang="en-US" smtClean="0"/>
-              <a:t>1/27/13</a:t>
             </a:fld>
             <a:endParaRPr lang="en-US"/>
           </a:p>
@@ -1818,18 +1822,12 @@
           <a:p>
             <a:fld id="{C1FF6DA9-008F-8B48-92A6-B652298478BF}" type="slidenum">
               <a:rPr lang="en-US" smtClean="0"/>
-              <a:t>‹#›</a:t>
             </a:fld>
             <a:endParaRPr lang="en-US"/>
           </a:p>
         </p:txBody>
       </p:sp>
     </p:spTree>
-    <p:extLst>
-      <p:ext uri="{BB962C8B-B14F-4D97-AF65-F5344CB8AC3E}">
-        <p14:creationId xmlns:p14="http://schemas.microsoft.com/office/powerpoint/2010/main" val="990158736"/>
-      </p:ext>
-    </p:extLst>
   </p:cSld>
   <p:clrMapOvr>
     <a:masterClrMapping/>
@@ -1894,7 +1892,6 @@
           <a:p>
             <a:fld id="{5BCAD085-E8A6-8845-BD4E-CB4CCA059FC4}" type="datetimeFigureOut">
               <a:rPr lang="en-US" smtClean="0"/>
-              <a:t>1/27/13</a:t>
             </a:fld>
             <a:endParaRPr lang="en-US"/>
           </a:p>
@@ -1936,18 +1933,12 @@
           <a:p>
             <a:fld id="{C1FF6DA9-008F-8B48-92A6-B652298478BF}" type="slidenum">
               <a:rPr lang="en-US" smtClean="0"/>
-              <a:t>‹#›</a:t>
             </a:fld>
             <a:endParaRPr lang="en-US"/>
           </a:p>
         </p:txBody>
       </p:sp>
     </p:spTree>
-    <p:extLst>
-      <p:ext uri="{BB962C8B-B14F-4D97-AF65-F5344CB8AC3E}">
-        <p14:creationId xmlns:p14="http://schemas.microsoft.com/office/powerpoint/2010/main" val="727027711"/>
-      </p:ext>
-    </p:extLst>
   </p:cSld>
   <p:clrMapOvr>
     <a:masterClrMapping/>
@@ -1989,7 +1980,6 @@
           <a:p>
             <a:fld id="{5BCAD085-E8A6-8845-BD4E-CB4CCA059FC4}" type="datetimeFigureOut">
               <a:rPr lang="en-US" smtClean="0"/>
-              <a:t>1/27/13</a:t>
             </a:fld>
             <a:endParaRPr lang="en-US"/>
           </a:p>
@@ -2031,18 +2021,12 @@
           <a:p>
             <a:fld id="{C1FF6DA9-008F-8B48-92A6-B652298478BF}" type="slidenum">
               <a:rPr lang="en-US" smtClean="0"/>
-              <a:t>‹#›</a:t>
             </a:fld>
             <a:endParaRPr lang="en-US"/>
           </a:p>
         </p:txBody>
       </p:sp>
     </p:spTree>
-    <p:extLst>
-      <p:ext uri="{BB962C8B-B14F-4D97-AF65-F5344CB8AC3E}">
-        <p14:creationId xmlns:p14="http://schemas.microsoft.com/office/powerpoint/2010/main" val="1212999818"/>
-      </p:ext>
-    </p:extLst>
   </p:cSld>
   <p:clrMapOvr>
     <a:masterClrMapping/>
@@ -2152,6 +2136,7 @@
               <a:rPr lang="en-US" smtClean="0"/>
               <a:t>Click to edit Master text styles</a:t>
             </a:r>
+            <a:endParaRPr lang="en-US" smtClean="0"/>
           </a:p>
           <a:p>
             <a:pPr lvl="1"/>
@@ -2159,6 +2144,7 @@
               <a:rPr lang="en-US" smtClean="0"/>
               <a:t>Second level</a:t>
             </a:r>
+            <a:endParaRPr lang="en-US" smtClean="0"/>
           </a:p>
           <a:p>
             <a:pPr lvl="2"/>
@@ -2166,6 +2152,7 @@
               <a:rPr lang="en-US" smtClean="0"/>
               <a:t>Third level</a:t>
             </a:r>
+            <a:endParaRPr lang="en-US" smtClean="0"/>
           </a:p>
           <a:p>
             <a:pPr lvl="3"/>
@@ -2173,6 +2160,7 @@
               <a:rPr lang="en-US" smtClean="0"/>
               <a:t>Fourth level</a:t>
             </a:r>
+            <a:endParaRPr lang="en-US" smtClean="0"/>
           </a:p>
           <a:p>
             <a:pPr lvl="4"/>
@@ -2246,6 +2234,7 @@
               <a:rPr lang="en-US" smtClean="0"/>
               <a:t>Click to edit Master text styles</a:t>
             </a:r>
+            <a:endParaRPr lang="en-US" smtClean="0"/>
           </a:p>
         </p:txBody>
       </p:sp>
@@ -2266,7 +2255,6 @@
           <a:p>
             <a:fld id="{5BCAD085-E8A6-8845-BD4E-CB4CCA059FC4}" type="datetimeFigureOut">
               <a:rPr lang="en-US" smtClean="0"/>
-              <a:t>1/27/13</a:t>
             </a:fld>
             <a:endParaRPr lang="en-US"/>
           </a:p>
@@ -2308,18 +2296,12 @@
           <a:p>
             <a:fld id="{C1FF6DA9-008F-8B48-92A6-B652298478BF}" type="slidenum">
               <a:rPr lang="en-US" smtClean="0"/>
-              <a:t>‹#›</a:t>
             </a:fld>
             <a:endParaRPr lang="en-US"/>
           </a:p>
         </p:txBody>
       </p:sp>
     </p:spTree>
-    <p:extLst>
-      <p:ext uri="{BB962C8B-B14F-4D97-AF65-F5344CB8AC3E}">
-        <p14:creationId xmlns:p14="http://schemas.microsoft.com/office/powerpoint/2010/main" val="1840726560"/>
-      </p:ext>
-    </p:extLst>
   </p:cSld>
   <p:clrMapOvr>
     <a:masterClrMapping/>
@@ -2499,6 +2481,7 @@
               <a:rPr lang="en-US" smtClean="0"/>
               <a:t>Click to edit Master text styles</a:t>
             </a:r>
+            <a:endParaRPr lang="en-US" smtClean="0"/>
           </a:p>
         </p:txBody>
       </p:sp>
@@ -2519,7 +2502,6 @@
           <a:p>
             <a:fld id="{5BCAD085-E8A6-8845-BD4E-CB4CCA059FC4}" type="datetimeFigureOut">
               <a:rPr lang="en-US" smtClean="0"/>
-              <a:t>1/27/13</a:t>
             </a:fld>
             <a:endParaRPr lang="en-US"/>
           </a:p>
@@ -2561,18 +2543,12 @@
           <a:p>
             <a:fld id="{C1FF6DA9-008F-8B48-92A6-B652298478BF}" type="slidenum">
               <a:rPr lang="en-US" smtClean="0"/>
-              <a:t>‹#›</a:t>
             </a:fld>
             <a:endParaRPr lang="en-US"/>
           </a:p>
         </p:txBody>
       </p:sp>
     </p:spTree>
-    <p:extLst>
-      <p:ext uri="{BB962C8B-B14F-4D97-AF65-F5344CB8AC3E}">
-        <p14:creationId xmlns:p14="http://schemas.microsoft.com/office/powerpoint/2010/main" val="3889236939"/>
-      </p:ext>
-    </p:extLst>
   </p:cSld>
   <p:clrMapOvr>
     <a:masterClrMapping/>
@@ -2665,6 +2641,7 @@
               <a:rPr lang="en-US" smtClean="0"/>
               <a:t>Click to edit Master text styles</a:t>
             </a:r>
+            <a:endParaRPr lang="en-US" smtClean="0"/>
           </a:p>
           <a:p>
             <a:pPr lvl="1"/>
@@ -2672,6 +2649,7 @@
               <a:rPr lang="en-US" smtClean="0"/>
               <a:t>Second level</a:t>
             </a:r>
+            <a:endParaRPr lang="en-US" smtClean="0"/>
           </a:p>
           <a:p>
             <a:pPr lvl="2"/>
@@ -2679,6 +2657,7 @@
               <a:rPr lang="en-US" smtClean="0"/>
               <a:t>Third level</a:t>
             </a:r>
+            <a:endParaRPr lang="en-US" smtClean="0"/>
           </a:p>
           <a:p>
             <a:pPr lvl="3"/>
@@ -2686,6 +2665,7 @@
               <a:rPr lang="en-US" smtClean="0"/>
               <a:t>Fourth level</a:t>
             </a:r>
+            <a:endParaRPr lang="en-US" smtClean="0"/>
           </a:p>
           <a:p>
             <a:pPr lvl="4"/>
@@ -2732,7 +2712,6 @@
           <a:p>
             <a:fld id="{5BCAD085-E8A6-8845-BD4E-CB4CCA059FC4}" type="datetimeFigureOut">
               <a:rPr lang="en-US" smtClean="0"/>
-              <a:t>1/27/13</a:t>
             </a:fld>
             <a:endParaRPr lang="en-US"/>
           </a:p>
@@ -2810,18 +2789,12 @@
           <a:p>
             <a:fld id="{C1FF6DA9-008F-8B48-92A6-B652298478BF}" type="slidenum">
               <a:rPr lang="en-US" smtClean="0"/>
-              <a:t>‹#›</a:t>
             </a:fld>
             <a:endParaRPr lang="en-US"/>
           </a:p>
         </p:txBody>
       </p:sp>
     </p:spTree>
-    <p:extLst>
-      <p:ext uri="{BB962C8B-B14F-4D97-AF65-F5344CB8AC3E}">
-        <p14:creationId xmlns:p14="http://schemas.microsoft.com/office/powerpoint/2010/main" val="2209977519"/>
-      </p:ext>
-    </p:extLst>
   </p:cSld>
   <p:clrMap bg1="lt1" tx1="dk1" bg2="lt2" tx2="dk2" accent1="accent1" accent2="accent2" accent3="accent3" accent4="accent4" accent5="accent5" accent6="accent6" hlink="hlink" folHlink="folHlink"/>
   <p:sldLayoutIdLst>
@@ -2859,7 +2832,7 @@
         <a:spcBef>
           <a:spcPct val="20000"/>
         </a:spcBef>
-        <a:buFont typeface="Arial"/>
+        <a:buFont typeface="Arial" panose="020B0604020202020204"/>
         <a:buChar char="•"/>
         <a:defRPr sz="3200" kern="1200">
           <a:solidFill>
@@ -2874,7 +2847,7 @@
         <a:spcBef>
           <a:spcPct val="20000"/>
         </a:spcBef>
-        <a:buFont typeface="Arial"/>
+        <a:buFont typeface="Arial" panose="020B0604020202020204"/>
         <a:buChar char="–"/>
         <a:defRPr sz="2800" kern="1200">
           <a:solidFill>
@@ -2889,7 +2862,7 @@
         <a:spcBef>
           <a:spcPct val="20000"/>
         </a:spcBef>
-        <a:buFont typeface="Arial"/>
+        <a:buFont typeface="Arial" panose="020B0604020202020204"/>
         <a:buChar char="•"/>
         <a:defRPr sz="2400" kern="1200">
           <a:solidFill>
@@ -2904,7 +2877,7 @@
         <a:spcBef>
           <a:spcPct val="20000"/>
         </a:spcBef>
-        <a:buFont typeface="Arial"/>
+        <a:buFont typeface="Arial" panose="020B0604020202020204"/>
         <a:buChar char="–"/>
         <a:defRPr sz="2000" kern="1200">
           <a:solidFill>
@@ -2919,7 +2892,7 @@
         <a:spcBef>
           <a:spcPct val="20000"/>
         </a:spcBef>
-        <a:buFont typeface="Arial"/>
+        <a:buFont typeface="Arial" panose="020B0604020202020204"/>
         <a:buChar char="»"/>
         <a:defRPr sz="2000" kern="1200">
           <a:solidFill>
@@ -2934,7 +2907,7 @@
         <a:spcBef>
           <a:spcPct val="20000"/>
         </a:spcBef>
-        <a:buFont typeface="Arial"/>
+        <a:buFont typeface="Arial" panose="020B0604020202020204"/>
         <a:buChar char="•"/>
         <a:defRPr sz="2000" kern="1200">
           <a:solidFill>
@@ -2949,7 +2922,7 @@
         <a:spcBef>
           <a:spcPct val="20000"/>
         </a:spcBef>
-        <a:buFont typeface="Arial"/>
+        <a:buFont typeface="Arial" panose="020B0604020202020204"/>
         <a:buChar char="•"/>
         <a:defRPr sz="2000" kern="1200">
           <a:solidFill>
@@ -2964,7 +2937,7 @@
         <a:spcBef>
           <a:spcPct val="20000"/>
         </a:spcBef>
-        <a:buFont typeface="Arial"/>
+        <a:buFont typeface="Arial" panose="020B0604020202020204"/>
         <a:buChar char="•"/>
         <a:defRPr sz="2000" kern="1200">
           <a:solidFill>
@@ -2979,7 +2952,7 @@
         <a:spcBef>
           <a:spcPct val="20000"/>
         </a:spcBef>
-        <a:buFont typeface="Arial"/>
+        <a:buFont typeface="Arial" panose="020B0604020202020204"/>
         <a:buChar char="•"/>
         <a:defRPr sz="2000" kern="1200">
           <a:solidFill>
@@ -3091,7 +3064,7 @@
 </file>
 
 <file path=ppt/slides/slide1.xml><?xml version="1.0" encoding="utf-8"?>
-<p:sld xmlns:a="http://schemas.openxmlformats.org/drawingml/2006/main" xmlns:p="http://schemas.openxmlformats.org/presentationml/2006/main" xmlns:r="http://schemas.openxmlformats.org/officeDocument/2006/relationships">
+<p:sld xmlns:a="http://schemas.openxmlformats.org/drawingml/2006/main" xmlns:r="http://schemas.openxmlformats.org/officeDocument/2006/relationships" xmlns:p="http://schemas.openxmlformats.org/presentationml/2006/main">
   <p:cSld>
     <p:spTree>
       <p:nvGrpSpPr>
@@ -3259,10 +3232,16 @@
                 <a:solidFill>
                   <a:srgbClr val="9B8BC4"/>
                 </a:solidFill>
-                <a:latin typeface="Calibri"/>
+                <a:latin typeface="Calibri" panose="020F0502020204030204"/>
               </a:rPr>
               <a:t>BSc Software Engineering Capstone — Progress Review</a:t>
             </a:r>
+            <a:endParaRPr sz="1600" b="1" i="0">
+              <a:solidFill>
+                <a:srgbClr val="9B8BC4"/>
+              </a:solidFill>
+              <a:latin typeface="Calibri" panose="020F0502020204030204"/>
+            </a:endParaRPr>
           </a:p>
         </p:txBody>
       </p:sp>
@@ -3293,10 +3272,16 @@
                 <a:solidFill>
                   <a:srgbClr val="FFFFFF"/>
                 </a:solidFill>
-                <a:latin typeface="Calibri"/>
+                <a:latin typeface="Calibri" panose="020F0502020204030204"/>
               </a:rPr>
               <a:t>Umubyeyi</a:t>
             </a:r>
+            <a:endParaRPr sz="5400" b="1" i="0">
+              <a:solidFill>
+                <a:srgbClr val="FFFFFF"/>
+              </a:solidFill>
+              <a:latin typeface="Calibri" panose="020F0502020204030204"/>
+            </a:endParaRPr>
           </a:p>
         </p:txBody>
       </p:sp>
@@ -3327,10 +3312,16 @@
                 <a:solidFill>
                   <a:srgbClr val="FFFFFF"/>
                 </a:solidFill>
-                <a:latin typeface="Calibri"/>
+                <a:latin typeface="Calibri" panose="020F0502020204030204"/>
               </a:rPr>
               <a:t>A Kinyarwanda-Language AI Chatbot for Maternal Mental Wellness in the Postpartum Window</a:t>
             </a:r>
+            <a:endParaRPr sz="2400" b="0" i="0">
+              <a:solidFill>
+                <a:srgbClr val="FFFFFF"/>
+              </a:solidFill>
+              <a:latin typeface="Calibri" panose="020F0502020204030204"/>
+            </a:endParaRPr>
           </a:p>
         </p:txBody>
       </p:sp>
@@ -3361,10 +3352,16 @@
                 <a:solidFill>
                   <a:srgbClr val="FFFFFF"/>
                 </a:solidFill>
-                <a:latin typeface="Calibri"/>
+                <a:latin typeface="Calibri" panose="020F0502020204030204"/>
               </a:rPr>
               <a:t>Raissa Irutingabo  ·  African Leadership University</a:t>
             </a:r>
+            <a:endParaRPr sz="1500" b="1" i="0">
+              <a:solidFill>
+                <a:srgbClr val="FFFFFF"/>
+              </a:solidFill>
+              <a:latin typeface="Calibri" panose="020F0502020204030204"/>
+            </a:endParaRPr>
           </a:p>
           <a:p>
             <a:r>
@@ -3372,10 +3369,16 @@
                 <a:solidFill>
                   <a:srgbClr val="9B8BC4"/>
                 </a:solidFill>
-                <a:latin typeface="Calibri"/>
+                <a:latin typeface="Calibri" panose="020F0502020204030204"/>
               </a:rPr>
               <a:t>Supervisor: Samiratu Ntohsi</a:t>
             </a:r>
+            <a:endParaRPr sz="1500" b="0" i="0">
+              <a:solidFill>
+                <a:srgbClr val="9B8BC4"/>
+              </a:solidFill>
+              <a:latin typeface="Calibri" panose="020F0502020204030204"/>
+            </a:endParaRPr>
           </a:p>
           <a:p>
             <a:r>
@@ -3383,10 +3386,16 @@
                 <a:solidFill>
                   <a:srgbClr val="55576B"/>
                 </a:solidFill>
-                <a:latin typeface="Calibri"/>
+                <a:latin typeface="Calibri" panose="020F0502020204030204"/>
               </a:rPr>
               <a:t>Progress presentation — June 2026</a:t>
             </a:r>
+            <a:endParaRPr sz="1500" b="0" i="0">
+              <a:solidFill>
+                <a:srgbClr val="55576B"/>
+              </a:solidFill>
+              <a:latin typeface="Calibri" panose="020F0502020204030204"/>
+            </a:endParaRPr>
           </a:p>
         </p:txBody>
       </p:sp>
@@ -3399,7 +3408,7 @@
 </file>
 
 <file path=ppt/slides/slide10.xml><?xml version="1.0" encoding="utf-8"?>
-<p:sld xmlns:a="http://schemas.openxmlformats.org/drawingml/2006/main" xmlns:p="http://schemas.openxmlformats.org/presentationml/2006/main" xmlns:r="http://schemas.openxmlformats.org/officeDocument/2006/relationships">
+<p:sld xmlns:a="http://schemas.openxmlformats.org/drawingml/2006/main" xmlns:r="http://schemas.openxmlformats.org/officeDocument/2006/relationships" xmlns:p="http://schemas.openxmlformats.org/presentationml/2006/main">
   <p:cSld>
     <p:spTree>
       <p:nvGrpSpPr>
@@ -3523,10 +3532,16 @@
                 <a:solidFill>
                   <a:srgbClr val="E76F51"/>
                 </a:solidFill>
-                <a:latin typeface="Calibri"/>
+                <a:latin typeface="Calibri" panose="020F0502020204030204"/>
               </a:rPr>
               <a:t>RESULTS</a:t>
             </a:r>
+            <a:endParaRPr sz="1200" b="1" i="0">
+              <a:solidFill>
+                <a:srgbClr val="E76F51"/>
+              </a:solidFill>
+              <a:latin typeface="Calibri" panose="020F0502020204030204"/>
+            </a:endParaRPr>
           </a:p>
         </p:txBody>
       </p:sp>
@@ -3557,10 +3572,16 @@
                 <a:solidFill>
                   <a:srgbClr val="2B2D42"/>
                 </a:solidFill>
-                <a:latin typeface="Calibri"/>
+                <a:latin typeface="Calibri" panose="020F0502020204030204"/>
               </a:rPr>
               <a:t>The core scientific contribution</a:t>
             </a:r>
+            <a:endParaRPr sz="3000" b="1" i="0">
+              <a:solidFill>
+                <a:srgbClr val="2B2D42"/>
+              </a:solidFill>
+              <a:latin typeface="Calibri" panose="020F0502020204030204"/>
+            </a:endParaRPr>
           </a:p>
         </p:txBody>
       </p:sp>
@@ -3643,10 +3664,16 @@
                 <a:solidFill>
                   <a:srgbClr val="2B2D42"/>
                 </a:solidFill>
-                <a:latin typeface="Calibri"/>
+                <a:latin typeface="Calibri" panose="020F0502020204030204"/>
               </a:rPr>
               <a:t>•  Central research question: how much accuracy do we lose to translation?</a:t>
             </a:r>
+            <a:endParaRPr sz="1500" b="1" i="0">
+              <a:solidFill>
+                <a:srgbClr val="2B2D42"/>
+              </a:solidFill>
+              <a:latin typeface="Calibri" panose="020F0502020204030204"/>
+            </a:endParaRPr>
           </a:p>
           <a:p>
             <a:pPr>
@@ -3662,10 +3689,16 @@
                 <a:solidFill>
                   <a:srgbClr val="2B2D42"/>
                 </a:solidFill>
-                <a:latin typeface="Calibri"/>
+                <a:latin typeface="Calibri" panose="020F0502020204030204"/>
               </a:rPr>
               <a:t>•  Method: classify the English test set directly vs. after an EN→Kinyarwanda→EN round-trip through NLLB-200 — the gap is the degradation coefficient.</a:t>
             </a:r>
+            <a:endParaRPr sz="1500" b="1" i="0">
+              <a:solidFill>
+                <a:srgbClr val="2B2D42"/>
+              </a:solidFill>
+              <a:latin typeface="Calibri" panose="020F0502020204030204"/>
+            </a:endParaRPr>
           </a:p>
           <a:p>
             <a:pPr>
@@ -3681,10 +3714,16 @@
                 <a:solidFill>
                   <a:srgbClr val="2B2D42"/>
                 </a:solidFill>
-                <a:latin typeface="Calibri"/>
+                <a:latin typeface="Calibri" panose="020F0502020204030204"/>
               </a:rPr>
               <a:t>•  This would be the first published Kinyarwanda mental-wellness classification benchmark.</a:t>
             </a:r>
+            <a:endParaRPr sz="1500" b="1" i="0">
+              <a:solidFill>
+                <a:srgbClr val="2B2D42"/>
+              </a:solidFill>
+              <a:latin typeface="Calibri" panose="020F0502020204030204"/>
+            </a:endParaRPr>
           </a:p>
         </p:txBody>
       </p:sp>
@@ -3759,10 +3798,16 @@
                 <a:solidFill>
                   <a:srgbClr val="E76F51"/>
                 </a:solidFill>
-                <a:latin typeface="Calibri"/>
+                <a:latin typeface="Calibri" panose="020F0502020204030204"/>
               </a:rPr>
               <a:t>Live demo finding</a:t>
             </a:r>
+            <a:endParaRPr sz="1400" b="1" i="0">
+              <a:solidFill>
+                <a:srgbClr val="E76F51"/>
+              </a:solidFill>
+              <a:latin typeface="Calibri" panose="020F0502020204030204"/>
+            </a:endParaRPr>
           </a:p>
           <a:p>
             <a:pPr>
@@ -3775,10 +3820,16 @@
                 <a:solidFill>
                   <a:srgbClr val="9B8BC4"/>
                 </a:solidFill>
-                <a:latin typeface="Calibri"/>
+                <a:latin typeface="Calibri" panose="020F0502020204030204"/>
               </a:rPr>
               <a:t>Input (Kinyarwanda):</a:t>
             </a:r>
+            <a:endParaRPr sz="1200" b="1" i="0">
+              <a:solidFill>
+                <a:srgbClr val="9B8BC4"/>
+              </a:solidFill>
+              <a:latin typeface="Calibri" panose="020F0502020204030204"/>
+            </a:endParaRPr>
           </a:p>
           <a:p>
             <a:r>
@@ -3786,10 +3837,16 @@
                 <a:solidFill>
                   <a:srgbClr val="FFFFFF"/>
                 </a:solidFill>
-                <a:latin typeface="Calibri"/>
+                <a:latin typeface="Calibri" panose="020F0502020204030204"/>
               </a:rPr>
               <a:t>“umugabo wanjye ntamfasha”  (my husband does NOT help me)</a:t>
             </a:r>
+            <a:endParaRPr sz="1300" b="0" i="1">
+              <a:solidFill>
+                <a:srgbClr val="FFFFFF"/>
+              </a:solidFill>
+              <a:latin typeface="Calibri" panose="020F0502020204030204"/>
+            </a:endParaRPr>
           </a:p>
           <a:p>
             <a:pPr>
@@ -3802,10 +3859,16 @@
                 <a:solidFill>
                   <a:srgbClr val="9B8BC4"/>
                 </a:solidFill>
-                <a:latin typeface="Calibri"/>
+                <a:latin typeface="Calibri" panose="020F0502020204030204"/>
               </a:rPr>
               <a:t>NLLB dropped the negation →</a:t>
             </a:r>
+            <a:endParaRPr sz="1200" b="1" i="0">
+              <a:solidFill>
+                <a:srgbClr val="9B8BC4"/>
+              </a:solidFill>
+              <a:latin typeface="Calibri" panose="020F0502020204030204"/>
+            </a:endParaRPr>
           </a:p>
           <a:p>
             <a:r>
@@ -3813,10 +3876,16 @@
                 <a:solidFill>
                   <a:srgbClr val="FFFFFF"/>
                 </a:solidFill>
-                <a:latin typeface="Calibri"/>
+                <a:latin typeface="Calibri" panose="020F0502020204030204"/>
               </a:rPr>
               <a:t>“my husband is helping me”  — meaning inverted</a:t>
             </a:r>
+            <a:endParaRPr sz="1300" b="0" i="1">
+              <a:solidFill>
+                <a:srgbClr val="FFFFFF"/>
+              </a:solidFill>
+              <a:latin typeface="Calibri" panose="020F0502020204030204"/>
+            </a:endParaRPr>
           </a:p>
           <a:p>
             <a:pPr>
@@ -3829,10 +3898,16 @@
                 <a:solidFill>
                   <a:srgbClr val="FFFFFF"/>
                 </a:solidFill>
-                <a:latin typeface="Calibri"/>
+                <a:latin typeface="Calibri" panose="020F0502020204030204"/>
               </a:rPr>
               <a:t>Confidence fell to 0.31 → the safety gate caught it → safe fallback. Live proof of both the risk AND the mitigation.</a:t>
             </a:r>
+            <a:endParaRPr sz="1300" b="0" i="0">
+              <a:solidFill>
+                <a:srgbClr val="FFFFFF"/>
+              </a:solidFill>
+              <a:latin typeface="Calibri" panose="020F0502020204030204"/>
+            </a:endParaRPr>
           </a:p>
         </p:txBody>
       </p:sp>
@@ -3907,10 +3982,16 @@
                 <a:solidFill>
                   <a:srgbClr val="FFFFFF"/>
                 </a:solidFill>
-                <a:latin typeface="Calibri"/>
+                <a:latin typeface="Calibri" panose="020F0502020204030204"/>
               </a:rPr>
               <a:t>Umubyeyi  ·  Kinyarwanda Maternal Mental-Wellness Chatbot  ·  R. Irutingabo (ALU)</a:t>
             </a:r>
+            <a:endParaRPr sz="900" b="0" i="0">
+              <a:solidFill>
+                <a:srgbClr val="FFFFFF"/>
+              </a:solidFill>
+              <a:latin typeface="Calibri" panose="020F0502020204030204"/>
+            </a:endParaRPr>
           </a:p>
         </p:txBody>
       </p:sp>
@@ -3942,10 +4023,16 @@
                 <a:solidFill>
                   <a:srgbClr val="FFFFFF"/>
                 </a:solidFill>
-                <a:latin typeface="Calibri"/>
+                <a:latin typeface="Calibri" panose="020F0502020204030204"/>
               </a:rPr>
               <a:t>10</a:t>
             </a:r>
+            <a:endParaRPr sz="900" b="0" i="0">
+              <a:solidFill>
+                <a:srgbClr val="FFFFFF"/>
+              </a:solidFill>
+              <a:latin typeface="Calibri" panose="020F0502020204030204"/>
+            </a:endParaRPr>
           </a:p>
         </p:txBody>
       </p:sp>
@@ -3958,7 +4045,7 @@
 </file>
 
 <file path=ppt/slides/slide11.xml><?xml version="1.0" encoding="utf-8"?>
-<p:sld xmlns:a="http://schemas.openxmlformats.org/drawingml/2006/main" xmlns:p="http://schemas.openxmlformats.org/presentationml/2006/main" xmlns:r="http://schemas.openxmlformats.org/officeDocument/2006/relationships">
+<p:sld xmlns:a="http://schemas.openxmlformats.org/drawingml/2006/main" xmlns:r="http://schemas.openxmlformats.org/officeDocument/2006/relationships" xmlns:p="http://schemas.openxmlformats.org/presentationml/2006/main">
   <p:cSld>
     <p:spTree>
       <p:nvGrpSpPr>
@@ -4082,10 +4169,16 @@
                 <a:solidFill>
                   <a:srgbClr val="E76F51"/>
                 </a:solidFill>
-                <a:latin typeface="Calibri"/>
+                <a:latin typeface="Calibri" panose="020F0502020204030204"/>
               </a:rPr>
               <a:t>DISCUSSION</a:t>
             </a:r>
+            <a:endParaRPr sz="1200" b="1" i="0">
+              <a:solidFill>
+                <a:srgbClr val="E76F51"/>
+              </a:solidFill>
+              <a:latin typeface="Calibri" panose="020F0502020204030204"/>
+            </a:endParaRPr>
           </a:p>
         </p:txBody>
       </p:sp>
@@ -4116,10 +4209,16 @@
                 <a:solidFill>
                   <a:srgbClr val="2B2D42"/>
                 </a:solidFill>
-                <a:latin typeface="Calibri"/>
+                <a:latin typeface="Calibri" panose="020F0502020204030204"/>
               </a:rPr>
               <a:t>Discussion</a:t>
             </a:r>
+            <a:endParaRPr sz="3000" b="1" i="0">
+              <a:solidFill>
+                <a:srgbClr val="2B2D42"/>
+              </a:solidFill>
+              <a:latin typeface="Calibri" panose="020F0502020204030204"/>
+            </a:endParaRPr>
           </a:p>
         </p:txBody>
       </p:sp>
@@ -4202,10 +4301,16 @@
                 <a:solidFill>
                   <a:srgbClr val="2B2D42"/>
                 </a:solidFill>
-                <a:latin typeface="Calibri"/>
+                <a:latin typeface="Calibri" panose="020F0502020204030204"/>
               </a:rPr>
               <a:t>•  Translation hallucination is the real risk — not classifier accuracy. Dropped negations can invert meaning.</a:t>
             </a:r>
+            <a:endParaRPr sz="1600" b="1" i="0">
+              <a:solidFill>
+                <a:srgbClr val="2B2D42"/>
+              </a:solidFill>
+              <a:latin typeface="Calibri" panose="020F0502020204030204"/>
+            </a:endParaRPr>
           </a:p>
           <a:p>
             <a:pPr>
@@ -4221,10 +4326,16 @@
                 <a:solidFill>
                   <a:srgbClr val="2B2D42"/>
                 </a:solidFill>
-                <a:latin typeface="Calibri"/>
+                <a:latin typeface="Calibri" panose="020F0502020204030204"/>
               </a:rPr>
               <a:t>•  The two-gate design (calibrated confidence + danger-sign override) turns that risk into a controlled, safe fallback rather than a wrong answer.</a:t>
             </a:r>
+            <a:endParaRPr sz="1600" b="1" i="0">
+              <a:solidFill>
+                <a:srgbClr val="2B2D42"/>
+              </a:solidFill>
+              <a:latin typeface="Calibri" panose="020F0502020204030204"/>
+            </a:endParaRPr>
           </a:p>
           <a:p>
             <a:pPr>
@@ -4240,10 +4351,16 @@
                 <a:solidFill>
                   <a:srgbClr val="2B2D42"/>
                 </a:solidFill>
-                <a:latin typeface="Calibri"/>
+                <a:latin typeface="Calibri" panose="020F0502020204030204"/>
               </a:rPr>
               <a:t>•  Open finding: the proposed fixed 0.40 confidence threshold abstains ~88% of the time — it needs empirical tuning, not assumption.</a:t>
             </a:r>
+            <a:endParaRPr sz="1600" b="1" i="0">
+              <a:solidFill>
+                <a:srgbClr val="2B2D42"/>
+              </a:solidFill>
+              <a:latin typeface="Calibri" panose="020F0502020204030204"/>
+            </a:endParaRPr>
           </a:p>
           <a:p>
             <a:pPr>
@@ -4259,10 +4376,16 @@
                 <a:solidFill>
                   <a:srgbClr val="2B2D42"/>
                 </a:solidFill>
-                <a:latin typeface="Calibri"/>
+                <a:latin typeface="Calibri" panose="020F0502020204030204"/>
               </a:rPr>
               <a:t>•  “Strong ML” here = rigor + a genuinely novel measurement, not model size. Classical models are the right call for low-resource deployment.</a:t>
             </a:r>
+            <a:endParaRPr sz="1600" b="1" i="0">
+              <a:solidFill>
+                <a:srgbClr val="2B2D42"/>
+              </a:solidFill>
+              <a:latin typeface="Calibri" panose="020F0502020204030204"/>
+            </a:endParaRPr>
           </a:p>
         </p:txBody>
       </p:sp>
@@ -4337,10 +4460,16 @@
                 <a:solidFill>
                   <a:srgbClr val="FFFFFF"/>
                 </a:solidFill>
-                <a:latin typeface="Calibri"/>
+                <a:latin typeface="Calibri" panose="020F0502020204030204"/>
               </a:rPr>
               <a:t>Umubyeyi  ·  Kinyarwanda Maternal Mental-Wellness Chatbot  ·  R. Irutingabo (ALU)</a:t>
             </a:r>
+            <a:endParaRPr sz="900" b="0" i="0">
+              <a:solidFill>
+                <a:srgbClr val="FFFFFF"/>
+              </a:solidFill>
+              <a:latin typeface="Calibri" panose="020F0502020204030204"/>
+            </a:endParaRPr>
           </a:p>
         </p:txBody>
       </p:sp>
@@ -4372,10 +4501,16 @@
                 <a:solidFill>
                   <a:srgbClr val="FFFFFF"/>
                 </a:solidFill>
-                <a:latin typeface="Calibri"/>
+                <a:latin typeface="Calibri" panose="020F0502020204030204"/>
               </a:rPr>
               <a:t>11</a:t>
             </a:r>
+            <a:endParaRPr sz="900" b="0" i="0">
+              <a:solidFill>
+                <a:srgbClr val="FFFFFF"/>
+              </a:solidFill>
+              <a:latin typeface="Calibri" panose="020F0502020204030204"/>
+            </a:endParaRPr>
           </a:p>
         </p:txBody>
       </p:sp>
@@ -4388,7 +4523,7 @@
 </file>
 
 <file path=ppt/slides/slide12.xml><?xml version="1.0" encoding="utf-8"?>
-<p:sld xmlns:a="http://schemas.openxmlformats.org/drawingml/2006/main" xmlns:p="http://schemas.openxmlformats.org/presentationml/2006/main" xmlns:r="http://schemas.openxmlformats.org/officeDocument/2006/relationships">
+<p:sld xmlns:a="http://schemas.openxmlformats.org/drawingml/2006/main" xmlns:r="http://schemas.openxmlformats.org/officeDocument/2006/relationships" xmlns:p="http://schemas.openxmlformats.org/presentationml/2006/main">
   <p:cSld>
     <p:spTree>
       <p:nvGrpSpPr>
@@ -4512,10 +4647,16 @@
                 <a:solidFill>
                   <a:srgbClr val="E76F51"/>
                 </a:solidFill>
-                <a:latin typeface="Calibri"/>
+                <a:latin typeface="Calibri" panose="020F0502020204030204"/>
               </a:rPr>
               <a:t>CONCLUSIONS</a:t>
             </a:r>
+            <a:endParaRPr sz="1200" b="1" i="0">
+              <a:solidFill>
+                <a:srgbClr val="E76F51"/>
+              </a:solidFill>
+              <a:latin typeface="Calibri" panose="020F0502020204030204"/>
+            </a:endParaRPr>
           </a:p>
         </p:txBody>
       </p:sp>
@@ -4546,10 +4687,16 @@
                 <a:solidFill>
                   <a:srgbClr val="2B2D42"/>
                 </a:solidFill>
-                <a:latin typeface="Calibri"/>
+                <a:latin typeface="Calibri" panose="020F0502020204030204"/>
               </a:rPr>
               <a:t>Conclusions &amp; Next Steps</a:t>
             </a:r>
+            <a:endParaRPr sz="3000" b="1" i="0">
+              <a:solidFill>
+                <a:srgbClr val="2B2D42"/>
+              </a:solidFill>
+              <a:latin typeface="Calibri" panose="020F0502020204030204"/>
+            </a:endParaRPr>
           </a:p>
         </p:txBody>
       </p:sp>
@@ -4624,10 +4771,16 @@
                 <a:solidFill>
                   <a:srgbClr val="1A9988"/>
                 </a:solidFill>
-                <a:latin typeface="Calibri"/>
+                <a:latin typeface="Calibri" panose="020F0502020204030204"/>
               </a:rPr>
               <a:t>Where we are</a:t>
             </a:r>
+            <a:endParaRPr sz="1600" b="1" i="0">
+              <a:solidFill>
+                <a:srgbClr val="1A9988"/>
+              </a:solidFill>
+              <a:latin typeface="Calibri" panose="020F0502020204030204"/>
+            </a:endParaRPr>
           </a:p>
         </p:txBody>
       </p:sp>
@@ -4640,7 +4793,7 @@
         <p:spPr>
           <a:xfrm>
             <a:off x="548640" y="2103120"/>
-            <a:ext cx="5486400" cy="4480560"/>
+            <a:ext cx="5486400" cy="1260475"/>
           </a:xfrm>
           <a:prstGeom prst="rect">
             <a:avLst/>
@@ -4666,10 +4819,16 @@
                 <a:solidFill>
                   <a:srgbClr val="2B2D42"/>
                 </a:solidFill>
-                <a:latin typeface="Calibri"/>
+                <a:latin typeface="Calibri" panose="020F0502020204030204"/>
               </a:rPr>
               <a:t>•  End-to-end Kinyarwanda pipeline works (NLLB + classifier + response templates + safety).</a:t>
             </a:r>
+            <a:endParaRPr sz="1400" b="1" i="0">
+              <a:solidFill>
+                <a:srgbClr val="2B2D42"/>
+              </a:solidFill>
+              <a:latin typeface="Calibri" panose="020F0502020204030204"/>
+            </a:endParaRPr>
           </a:p>
           <a:p>
             <a:pPr>
@@ -4685,10 +4844,16 @@
                 <a:solidFill>
                   <a:srgbClr val="2B2D42"/>
                 </a:solidFill>
-                <a:latin typeface="Calibri"/>
+                <a:latin typeface="Calibri" panose="020F0502020204030204"/>
               </a:rPr>
               <a:t>•  Floor baseline established: 0.61 acc / 0.60 F1 (Model 1).</a:t>
             </a:r>
+            <a:endParaRPr sz="1400" b="1" i="0">
+              <a:solidFill>
+                <a:srgbClr val="2B2D42"/>
+              </a:solidFill>
+              <a:latin typeface="Calibri" panose="020F0502020204030204"/>
+            </a:endParaRPr>
           </a:p>
           <a:p>
             <a:pPr>
@@ -4704,11 +4869,80 @@
                 <a:solidFill>
                   <a:srgbClr val="2B2D42"/>
                 </a:solidFill>
-                <a:latin typeface="Calibri"/>
-              </a:rPr>
-              <a:t>•  Principled model ladder designed; embedding + transformer arms coded.</a:t>
-            </a:r>
-          </a:p>
+                <a:latin typeface="Calibri" panose="020F0502020204030204"/>
+              </a:rPr>
+              <a:t>.</a:t>
+            </a:r>
+            <a:endParaRPr sz="1400" b="1" i="0">
+              <a:solidFill>
+                <a:srgbClr val="2B2D42"/>
+              </a:solidFill>
+              <a:latin typeface="Calibri" panose="020F0502020204030204"/>
+            </a:endParaRPr>
+          </a:p>
+        </p:txBody>
+      </p:sp>
+      <p:sp>
+        <p:nvSpPr>
+          <p:cNvPr id="9" name="TextBox 8"/>
+          <p:cNvSpPr txBox="1"/>
+          <p:nvPr/>
+        </p:nvSpPr>
+        <p:spPr>
+          <a:xfrm>
+            <a:off x="6309360" y="1691640"/>
+            <a:ext cx="5486400" cy="457200"/>
+          </a:xfrm>
+          <a:prstGeom prst="rect">
+            <a:avLst/>
+          </a:prstGeom>
+          <a:noFill/>
+        </p:spPr>
+        <p:txBody>
+          <a:bodyPr wrap="square" anchor="t">
+            <a:spAutoFit/>
+          </a:bodyPr>
+          <a:lstStyle/>
+          <a:p>
+            <a:r>
+              <a:rPr sz="1600" b="1" i="0">
+                <a:solidFill>
+                  <a:srgbClr val="E76F51"/>
+                </a:solidFill>
+                <a:latin typeface="Calibri" panose="020F0502020204030204"/>
+              </a:rPr>
+              <a:t>Next steps</a:t>
+            </a:r>
+            <a:endParaRPr sz="1600" b="1" i="0">
+              <a:solidFill>
+                <a:srgbClr val="E76F51"/>
+              </a:solidFill>
+              <a:latin typeface="Calibri" panose="020F0502020204030204"/>
+            </a:endParaRPr>
+          </a:p>
+        </p:txBody>
+      </p:sp>
+      <p:sp>
+        <p:nvSpPr>
+          <p:cNvPr id="10" name="TextBox 9"/>
+          <p:cNvSpPr txBox="1"/>
+          <p:nvPr/>
+        </p:nvSpPr>
+        <p:spPr>
+          <a:xfrm>
+            <a:off x="6309360" y="2103120"/>
+            <a:ext cx="5486400" cy="675640"/>
+          </a:xfrm>
+          <a:prstGeom prst="rect">
+            <a:avLst/>
+          </a:prstGeom>
+          <a:noFill/>
+        </p:spPr>
+        <p:txBody>
+          <a:bodyPr wrap="square" anchor="t">
+            <a:spAutoFit/>
+          </a:bodyPr>
+          <a:lstStyle/>
           <a:p>
             <a:pPr>
               <a:spcBef>
@@ -4723,68 +4957,17 @@
                 <a:solidFill>
                   <a:srgbClr val="2B2D42"/>
                 </a:solidFill>
-                <a:latin typeface="Calibri"/>
-              </a:rPr>
-              <a:t>•  Translation-risk demonstrated live, and contained by the safety gate.</a:t>
-            </a:r>
-          </a:p>
-        </p:txBody>
-      </p:sp>
-      <p:sp>
-        <p:nvSpPr>
-          <p:cNvPr id="9" name="TextBox 8"/>
-          <p:cNvSpPr txBox="1"/>
-          <p:nvPr/>
-        </p:nvSpPr>
-        <p:spPr>
-          <a:xfrm>
-            <a:off x="6309360" y="1691640"/>
-            <a:ext cx="5486400" cy="457200"/>
-          </a:xfrm>
-          <a:prstGeom prst="rect">
-            <a:avLst/>
-          </a:prstGeom>
-          <a:noFill/>
-        </p:spPr>
-        <p:txBody>
-          <a:bodyPr wrap="square" anchor="t">
-            <a:spAutoFit/>
-          </a:bodyPr>
-          <a:lstStyle/>
-          <a:p>
-            <a:r>
-              <a:rPr sz="1600" b="1" i="0">
-                <a:solidFill>
-                  <a:srgbClr val="E76F51"/>
-                </a:solidFill>
-                <a:latin typeface="Calibri"/>
-              </a:rPr>
-              <a:t>Next steps</a:t>
-            </a:r>
-          </a:p>
-        </p:txBody>
-      </p:sp>
-      <p:sp>
-        <p:nvSpPr>
-          <p:cNvPr id="10" name="TextBox 9"/>
-          <p:cNvSpPr txBox="1"/>
-          <p:nvPr/>
-        </p:nvSpPr>
-        <p:spPr>
-          <a:xfrm>
-            <a:off x="6309360" y="2103120"/>
-            <a:ext cx="5486400" cy="4480560"/>
-          </a:xfrm>
-          <a:prstGeom prst="rect">
-            <a:avLst/>
-          </a:prstGeom>
-          <a:noFill/>
-        </p:spPr>
-        <p:txBody>
-          <a:bodyPr wrap="square" anchor="t">
-            <a:spAutoFit/>
-          </a:bodyPr>
-          <a:lstStyle/>
+                <a:latin typeface="Calibri" panose="020F0502020204030204"/>
+              </a:rPr>
+              <a:t>•  Measure the cross-lingual degradation coefficient.</a:t>
+            </a:r>
+            <a:endParaRPr sz="1400" b="1" i="0">
+              <a:solidFill>
+                <a:srgbClr val="2B2D42"/>
+              </a:solidFill>
+              <a:latin typeface="Calibri" panose="020F0502020204030204"/>
+            </a:endParaRPr>
+          </a:p>
           <a:p>
             <a:pPr>
               <a:spcBef>
@@ -4799,67 +4982,16 @@
                 <a:solidFill>
                   <a:srgbClr val="2B2D42"/>
                 </a:solidFill>
-                <a:latin typeface="Calibri"/>
-              </a:rPr>
-              <a:t>•  Measure the cross-lingual degradation coefficient.</a:t>
-            </a:r>
-          </a:p>
-          <a:p>
-            <a:pPr>
-              <a:spcBef>
-                <a:spcPts val="200"/>
-              </a:spcBef>
-              <a:spcAft>
-                <a:spcPts val="1000"/>
-              </a:spcAft>
-            </a:pPr>
-            <a:r>
-              <a:rPr sz="1400" b="1" i="0">
-                <a:solidFill>
-                  <a:srgbClr val="2B2D42"/>
-                </a:solidFill>
-                <a:latin typeface="Calibri"/>
+                <a:latin typeface="Calibri" panose="020F0502020204030204"/>
               </a:rPr>
               <a:t>•  AfroXLMR fine-tune as a comparison arm.</a:t>
             </a:r>
-          </a:p>
-          <a:p>
-            <a:pPr>
-              <a:spcBef>
-                <a:spcPts val="200"/>
-              </a:spcBef>
-              <a:spcAft>
-                <a:spcPts val="1000"/>
-              </a:spcAft>
-            </a:pPr>
-            <a:r>
-              <a:rPr sz="1400" b="1" i="0">
-                <a:solidFill>
-                  <a:srgbClr val="2B2D42"/>
-                </a:solidFill>
-                <a:latin typeface="Calibri"/>
-              </a:rPr>
-              <a:t>•  Future: build a true evidence-sourced retrieval KB (beyond the 6 templates).</a:t>
-            </a:r>
-          </a:p>
-          <a:p>
-            <a:pPr>
-              <a:spcBef>
-                <a:spcPts val="200"/>
-              </a:spcBef>
-              <a:spcAft>
-                <a:spcPts val="1000"/>
-              </a:spcAft>
-            </a:pPr>
-            <a:r>
-              <a:rPr sz="1400" b="1" i="0">
-                <a:solidFill>
-                  <a:srgbClr val="2B2D42"/>
-                </a:solidFill>
-                <a:latin typeface="Calibri"/>
-              </a:rPr>
-              <a:t>•  SUS usability study with 10 proxy users (target &gt; 70).</a:t>
-            </a:r>
+            <a:endParaRPr sz="1400" b="1" i="0">
+              <a:solidFill>
+                <a:srgbClr val="2B2D42"/>
+              </a:solidFill>
+              <a:latin typeface="Calibri" panose="020F0502020204030204"/>
+            </a:endParaRPr>
           </a:p>
         </p:txBody>
       </p:sp>
@@ -4871,7 +5003,7 @@
         </p:nvSpPr>
         <p:spPr>
           <a:xfrm>
-            <a:off x="548640" y="5349240"/>
+            <a:off x="457200" y="4241800"/>
             <a:ext cx="11155680" cy="594360"/>
           </a:xfrm>
           <a:prstGeom prst="rect">
@@ -4915,7 +5047,7 @@
         </p:nvSpPr>
         <p:spPr>
           <a:xfrm>
-            <a:off x="777240" y="5394960"/>
+            <a:off x="579120" y="4241800"/>
             <a:ext cx="10698480" cy="502920"/>
           </a:xfrm>
           <a:prstGeom prst="rect">
@@ -4934,10 +5066,16 @@
                 <a:solidFill>
                   <a:srgbClr val="FFFFFF"/>
                 </a:solidFill>
-                <a:latin typeface="Calibri"/>
+                <a:latin typeface="Calibri" panose="020F0502020204030204"/>
               </a:rPr>
               <a:t>Contribution: the first Kinyarwanda maternal mental-wellness classifier + a quantified benchmark of what translation costs.</a:t>
             </a:r>
+            <a:endParaRPr sz="1500" b="1" i="0">
+              <a:solidFill>
+                <a:srgbClr val="FFFFFF"/>
+              </a:solidFill>
+              <a:latin typeface="Calibri" panose="020F0502020204030204"/>
+            </a:endParaRPr>
           </a:p>
         </p:txBody>
       </p:sp>
@@ -5012,10 +5150,16 @@
                 <a:solidFill>
                   <a:srgbClr val="FFFFFF"/>
                 </a:solidFill>
-                <a:latin typeface="Calibri"/>
+                <a:latin typeface="Calibri" panose="020F0502020204030204"/>
               </a:rPr>
               <a:t>Umubyeyi  ·  Kinyarwanda Maternal Mental-Wellness Chatbot  ·  R. Irutingabo (ALU)</a:t>
             </a:r>
+            <a:endParaRPr sz="900" b="0" i="0">
+              <a:solidFill>
+                <a:srgbClr val="FFFFFF"/>
+              </a:solidFill>
+              <a:latin typeface="Calibri" panose="020F0502020204030204"/>
+            </a:endParaRPr>
           </a:p>
         </p:txBody>
       </p:sp>
@@ -5047,10 +5191,16 @@
                 <a:solidFill>
                   <a:srgbClr val="FFFFFF"/>
                 </a:solidFill>
-                <a:latin typeface="Calibri"/>
+                <a:latin typeface="Calibri" panose="020F0502020204030204"/>
               </a:rPr>
               <a:t>12</a:t>
             </a:r>
+            <a:endParaRPr sz="900" b="0" i="0">
+              <a:solidFill>
+                <a:srgbClr val="FFFFFF"/>
+              </a:solidFill>
+              <a:latin typeface="Calibri" panose="020F0502020204030204"/>
+            </a:endParaRPr>
           </a:p>
         </p:txBody>
       </p:sp>
@@ -5063,7 +5213,7 @@
 </file>
 
 <file path=ppt/slides/slide13.xml><?xml version="1.0" encoding="utf-8"?>
-<p:sld xmlns:a="http://schemas.openxmlformats.org/drawingml/2006/main" xmlns:p="http://schemas.openxmlformats.org/presentationml/2006/main" xmlns:r="http://schemas.openxmlformats.org/officeDocument/2006/relationships">
+<p:sld xmlns:a="http://schemas.openxmlformats.org/drawingml/2006/main" xmlns:r="http://schemas.openxmlformats.org/officeDocument/2006/relationships" xmlns:p="http://schemas.openxmlformats.org/presentationml/2006/main">
   <p:cSld>
     <p:spTree>
       <p:nvGrpSpPr>
@@ -5169,7 +5319,7 @@
         <p:spPr>
           <a:xfrm>
             <a:off x="822960" y="2194560"/>
-            <a:ext cx="10515600" cy="1097280"/>
+            <a:ext cx="10515600" cy="768350"/>
           </a:xfrm>
           <a:prstGeom prst="rect">
             <a:avLst/>
@@ -5187,10 +5337,16 @@
                 <a:solidFill>
                   <a:srgbClr val="FFFFFF"/>
                 </a:solidFill>
-                <a:latin typeface="Calibri"/>
-              </a:rPr>
-              <a:t>Murakoze — Thank you</a:t>
-            </a:r>
+                <a:latin typeface="Calibri" panose="020F0502020204030204"/>
+              </a:rPr>
+              <a:t>Murakoze  Thank you</a:t>
+            </a:r>
+            <a:endParaRPr sz="4400" b="1" i="0">
+              <a:solidFill>
+                <a:srgbClr val="FFFFFF"/>
+              </a:solidFill>
+              <a:latin typeface="Calibri" panose="020F0502020204030204"/>
+            </a:endParaRPr>
           </a:p>
         </p:txBody>
       </p:sp>
@@ -5221,10 +5377,16 @@
                 <a:solidFill>
                   <a:srgbClr val="9B8BC4"/>
                 </a:solidFill>
-                <a:latin typeface="Calibri"/>
+                <a:latin typeface="Calibri" panose="020F0502020204030204"/>
               </a:rPr>
               <a:t>Questions &amp; discussion</a:t>
             </a:r>
+            <a:endParaRPr sz="2200" b="0" i="0">
+              <a:solidFill>
+                <a:srgbClr val="9B8BC4"/>
+              </a:solidFill>
+              <a:latin typeface="Calibri" panose="020F0502020204030204"/>
+            </a:endParaRPr>
           </a:p>
         </p:txBody>
       </p:sp>
@@ -5255,10 +5417,16 @@
                 <a:solidFill>
                   <a:srgbClr val="55576B"/>
                 </a:solidFill>
-                <a:latin typeface="Calibri"/>
+                <a:latin typeface="Calibri" panose="020F0502020204030204"/>
               </a:rPr>
               <a:t>Raissa Irutingabo  ·  github.com/IrutingaboRaissa/UMUBYEYI</a:t>
             </a:r>
+            <a:endParaRPr sz="1400" b="0" i="0">
+              <a:solidFill>
+                <a:srgbClr val="55576B"/>
+              </a:solidFill>
+              <a:latin typeface="Calibri" panose="020F0502020204030204"/>
+            </a:endParaRPr>
           </a:p>
         </p:txBody>
       </p:sp>
@@ -5271,7 +5439,7 @@
 </file>
 
 <file path=ppt/slides/slide2.xml><?xml version="1.0" encoding="utf-8"?>
-<p:sld xmlns:a="http://schemas.openxmlformats.org/drawingml/2006/main" xmlns:p="http://schemas.openxmlformats.org/presentationml/2006/main" xmlns:r="http://schemas.openxmlformats.org/officeDocument/2006/relationships">
+<p:sld xmlns:a="http://schemas.openxmlformats.org/drawingml/2006/main" xmlns:r="http://schemas.openxmlformats.org/officeDocument/2006/relationships" xmlns:p="http://schemas.openxmlformats.org/presentationml/2006/main">
   <p:cSld>
     <p:spTree>
       <p:nvGrpSpPr>
@@ -5395,10 +5563,16 @@
                 <a:solidFill>
                   <a:srgbClr val="E76F51"/>
                 </a:solidFill>
-                <a:latin typeface="Calibri"/>
+                <a:latin typeface="Calibri" panose="020F0502020204030204"/>
               </a:rPr>
               <a:t>AGENDA</a:t>
             </a:r>
+            <a:endParaRPr sz="1200" b="1" i="0">
+              <a:solidFill>
+                <a:srgbClr val="E76F51"/>
+              </a:solidFill>
+              <a:latin typeface="Calibri" panose="020F0502020204030204"/>
+            </a:endParaRPr>
           </a:p>
         </p:txBody>
       </p:sp>
@@ -5429,10 +5603,16 @@
                 <a:solidFill>
                   <a:srgbClr val="2B2D42"/>
                 </a:solidFill>
-                <a:latin typeface="Calibri"/>
+                <a:latin typeface="Calibri" panose="020F0502020204030204"/>
               </a:rPr>
               <a:t>Outline</a:t>
             </a:r>
+            <a:endParaRPr sz="3000" b="1" i="0">
+              <a:solidFill>
+                <a:srgbClr val="2B2D42"/>
+              </a:solidFill>
+              <a:latin typeface="Calibri" panose="020F0502020204030204"/>
+            </a:endParaRPr>
           </a:p>
         </p:txBody>
       </p:sp>
@@ -5488,8 +5668,8 @@
         </p:nvSpPr>
         <p:spPr>
           <a:xfrm>
-            <a:off x="548640" y="1737360"/>
-            <a:ext cx="10058400" cy="4480560"/>
+            <a:off x="502920" y="1705610"/>
+            <a:ext cx="10058400" cy="3384550"/>
           </a:xfrm>
           <a:prstGeom prst="rect">
             <a:avLst/>
@@ -5515,10 +5695,16 @@
                 <a:solidFill>
                   <a:srgbClr val="2B2D42"/>
                 </a:solidFill>
-                <a:latin typeface="Calibri"/>
+                <a:latin typeface="Calibri" panose="020F0502020204030204"/>
               </a:rPr>
               <a:t>•  Introduction</a:t>
             </a:r>
+            <a:endParaRPr sz="1800" b="1" i="0">
+              <a:solidFill>
+                <a:srgbClr val="2B2D42"/>
+              </a:solidFill>
+              <a:latin typeface="Calibri" panose="020F0502020204030204"/>
+            </a:endParaRPr>
           </a:p>
           <a:p>
             <a:pPr>
@@ -5534,10 +5720,16 @@
                 <a:solidFill>
                   <a:srgbClr val="2B2D42"/>
                 </a:solidFill>
-                <a:latin typeface="Calibri"/>
+                <a:latin typeface="Calibri" panose="020F0502020204030204"/>
               </a:rPr>
               <a:t>•  The Need</a:t>
             </a:r>
+            <a:endParaRPr sz="1800" b="1" i="0">
+              <a:solidFill>
+                <a:srgbClr val="2B2D42"/>
+              </a:solidFill>
+              <a:latin typeface="Calibri" panose="020F0502020204030204"/>
+            </a:endParaRPr>
           </a:p>
           <a:p>
             <a:pPr>
@@ -5553,29 +5745,16 @@
                 <a:solidFill>
                   <a:srgbClr val="2B2D42"/>
                 </a:solidFill>
-                <a:latin typeface="Calibri"/>
+                <a:latin typeface="Calibri" panose="020F0502020204030204"/>
               </a:rPr>
               <a:t>•  Data</a:t>
             </a:r>
-          </a:p>
-          <a:p>
-            <a:pPr lvl="1">
-              <a:spcBef>
-                <a:spcPts val="200"/>
-              </a:spcBef>
-              <a:spcAft>
-                <a:spcPts val="1000"/>
-              </a:spcAft>
-            </a:pPr>
-            <a:r>
-              <a:rPr sz="1600" b="0" i="0">
-                <a:solidFill>
-                  <a:srgbClr val="55576B"/>
-                </a:solidFill>
-                <a:latin typeface="Calibri"/>
-              </a:rPr>
-              <a:t>    –  Training corpus, framing dataset, response templates</a:t>
-            </a:r>
+            <a:endParaRPr sz="1800" b="1" i="0">
+              <a:solidFill>
+                <a:srgbClr val="2B2D42"/>
+              </a:solidFill>
+              <a:latin typeface="Calibri" panose="020F0502020204030204"/>
+            </a:endParaRPr>
           </a:p>
           <a:p>
             <a:pPr>
@@ -5591,10 +5770,16 @@
                 <a:solidFill>
                   <a:srgbClr val="2B2D42"/>
                 </a:solidFill>
-                <a:latin typeface="Calibri"/>
+                <a:latin typeface="Calibri" panose="020F0502020204030204"/>
               </a:rPr>
               <a:t>•  Data Preprocessing &amp; Exploration</a:t>
             </a:r>
+            <a:endParaRPr sz="1800" b="1" i="0">
+              <a:solidFill>
+                <a:srgbClr val="2B2D42"/>
+              </a:solidFill>
+              <a:latin typeface="Calibri" panose="020F0502020204030204"/>
+            </a:endParaRPr>
           </a:p>
           <a:p>
             <a:pPr>
@@ -5610,29 +5795,16 @@
                 <a:solidFill>
                   <a:srgbClr val="2B2D42"/>
                 </a:solidFill>
-                <a:latin typeface="Calibri"/>
+                <a:latin typeface="Calibri" panose="020F0502020204030204"/>
               </a:rPr>
               <a:t>•  The Approach</a:t>
             </a:r>
-          </a:p>
-          <a:p>
-            <a:pPr lvl="1">
-              <a:spcBef>
-                <a:spcPts val="200"/>
-              </a:spcBef>
-              <a:spcAft>
-                <a:spcPts val="1000"/>
-              </a:spcAft>
-            </a:pPr>
-            <a:r>
-              <a:rPr sz="1600" b="0" i="0">
-                <a:solidFill>
-                  <a:srgbClr val="55576B"/>
-                </a:solidFill>
-                <a:latin typeface="Calibri"/>
-              </a:rPr>
-              <a:t>    –  System pipeline + the model ladder (floor → embeddings → transformer)</a:t>
-            </a:r>
+            <a:endParaRPr sz="1800" b="1" i="0">
+              <a:solidFill>
+                <a:srgbClr val="2B2D42"/>
+              </a:solidFill>
+              <a:latin typeface="Calibri" panose="020F0502020204030204"/>
+            </a:endParaRPr>
           </a:p>
           <a:p>
             <a:pPr>
@@ -5648,29 +5820,16 @@
                 <a:solidFill>
                   <a:srgbClr val="2B2D42"/>
                 </a:solidFill>
-                <a:latin typeface="Calibri"/>
+                <a:latin typeface="Calibri" panose="020F0502020204030204"/>
               </a:rPr>
               <a:t>•  Results</a:t>
             </a:r>
-          </a:p>
-          <a:p>
-            <a:pPr lvl="1">
-              <a:spcBef>
-                <a:spcPts val="200"/>
-              </a:spcBef>
-              <a:spcAft>
-                <a:spcPts val="1000"/>
-              </a:spcAft>
-            </a:pPr>
-            <a:r>
-              <a:rPr sz="1600" b="0" i="0">
-                <a:solidFill>
-                  <a:srgbClr val="55576B"/>
-                </a:solidFill>
-                <a:latin typeface="Calibri"/>
-              </a:rPr>
-              <a:t>    –  Baseline &amp; the cross-lingual degradation finding</a:t>
-            </a:r>
+            <a:endParaRPr sz="1800" b="1" i="0">
+              <a:solidFill>
+                <a:srgbClr val="2B2D42"/>
+              </a:solidFill>
+              <a:latin typeface="Calibri" panose="020F0502020204030204"/>
+            </a:endParaRPr>
           </a:p>
           <a:p>
             <a:pPr>
@@ -5686,10 +5845,16 @@
                 <a:solidFill>
                   <a:srgbClr val="2B2D42"/>
                 </a:solidFill>
-                <a:latin typeface="Calibri"/>
+                <a:latin typeface="Calibri" panose="020F0502020204030204"/>
               </a:rPr>
               <a:t>•  Discussion</a:t>
             </a:r>
+            <a:endParaRPr sz="1800" b="1" i="0">
+              <a:solidFill>
+                <a:srgbClr val="2B2D42"/>
+              </a:solidFill>
+              <a:latin typeface="Calibri" panose="020F0502020204030204"/>
+            </a:endParaRPr>
           </a:p>
           <a:p>
             <a:pPr>
@@ -5705,10 +5870,16 @@
                 <a:solidFill>
                   <a:srgbClr val="2B2D42"/>
                 </a:solidFill>
-                <a:latin typeface="Calibri"/>
+                <a:latin typeface="Calibri" panose="020F0502020204030204"/>
               </a:rPr>
               <a:t>•  Conclusions &amp; Next Steps</a:t>
             </a:r>
+            <a:endParaRPr sz="1800" b="1" i="0">
+              <a:solidFill>
+                <a:srgbClr val="2B2D42"/>
+              </a:solidFill>
+              <a:latin typeface="Calibri" panose="020F0502020204030204"/>
+            </a:endParaRPr>
           </a:p>
         </p:txBody>
       </p:sp>
@@ -5783,10 +5954,16 @@
                 <a:solidFill>
                   <a:srgbClr val="FFFFFF"/>
                 </a:solidFill>
-                <a:latin typeface="Calibri"/>
+                <a:latin typeface="Calibri" panose="020F0502020204030204"/>
               </a:rPr>
               <a:t>Umubyeyi  ·  Kinyarwanda Maternal Mental-Wellness Chatbot  ·  R. Irutingabo (ALU)</a:t>
             </a:r>
+            <a:endParaRPr sz="900" b="0" i="0">
+              <a:solidFill>
+                <a:srgbClr val="FFFFFF"/>
+              </a:solidFill>
+              <a:latin typeface="Calibri" panose="020F0502020204030204"/>
+            </a:endParaRPr>
           </a:p>
         </p:txBody>
       </p:sp>
@@ -5818,10 +5995,16 @@
                 <a:solidFill>
                   <a:srgbClr val="FFFFFF"/>
                 </a:solidFill>
-                <a:latin typeface="Calibri"/>
+                <a:latin typeface="Calibri" panose="020F0502020204030204"/>
               </a:rPr>
               <a:t>2</a:t>
             </a:r>
+            <a:endParaRPr sz="900" b="0" i="0">
+              <a:solidFill>
+                <a:srgbClr val="FFFFFF"/>
+              </a:solidFill>
+              <a:latin typeface="Calibri" panose="020F0502020204030204"/>
+            </a:endParaRPr>
           </a:p>
         </p:txBody>
       </p:sp>
@@ -5834,7 +6017,7 @@
 </file>
 
 <file path=ppt/slides/slide3.xml><?xml version="1.0" encoding="utf-8"?>
-<p:sld xmlns:a="http://schemas.openxmlformats.org/drawingml/2006/main" xmlns:p="http://schemas.openxmlformats.org/presentationml/2006/main" xmlns:r="http://schemas.openxmlformats.org/officeDocument/2006/relationships">
+<p:sld xmlns:a="http://schemas.openxmlformats.org/drawingml/2006/main" xmlns:r="http://schemas.openxmlformats.org/officeDocument/2006/relationships" xmlns:p="http://schemas.openxmlformats.org/presentationml/2006/main">
   <p:cSld>
     <p:spTree>
       <p:nvGrpSpPr>
@@ -5958,10 +6141,16 @@
                 <a:solidFill>
                   <a:srgbClr val="E76F51"/>
                 </a:solidFill>
-                <a:latin typeface="Calibri"/>
+                <a:latin typeface="Calibri" panose="020F0502020204030204"/>
               </a:rPr>
               <a:t>INTRODUCTION</a:t>
             </a:r>
+            <a:endParaRPr sz="1200" b="1" i="0">
+              <a:solidFill>
+                <a:srgbClr val="E76F51"/>
+              </a:solidFill>
+              <a:latin typeface="Calibri" panose="020F0502020204030204"/>
+            </a:endParaRPr>
           </a:p>
         </p:txBody>
       </p:sp>
@@ -5992,10 +6181,16 @@
                 <a:solidFill>
                   <a:srgbClr val="2B2D42"/>
                 </a:solidFill>
-                <a:latin typeface="Calibri"/>
+                <a:latin typeface="Calibri" panose="020F0502020204030204"/>
               </a:rPr>
               <a:t>What is Umubyeyi?</a:t>
             </a:r>
+            <a:endParaRPr sz="3000" b="1" i="0">
+              <a:solidFill>
+                <a:srgbClr val="2B2D42"/>
+              </a:solidFill>
+              <a:latin typeface="Calibri" panose="020F0502020204030204"/>
+            </a:endParaRPr>
           </a:p>
         </p:txBody>
       </p:sp>
@@ -6052,7 +6247,7 @@
         <p:spPr>
           <a:xfrm>
             <a:off x="548640" y="1783080"/>
-            <a:ext cx="6675120" cy="4480560"/>
+            <a:ext cx="6675120" cy="2384425"/>
           </a:xfrm>
           <a:prstGeom prst="rect">
             <a:avLst/>
@@ -6078,10 +6273,16 @@
                 <a:solidFill>
                   <a:srgbClr val="2B2D42"/>
                 </a:solidFill>
-                <a:latin typeface="Calibri"/>
+                <a:latin typeface="Calibri" panose="020F0502020204030204"/>
               </a:rPr>
               <a:t>•  A browser-based chatbot that talks to first-time Rwandan mothers in Kinyarwanda about their mental wellbeing.</a:t>
             </a:r>
+            <a:endParaRPr sz="1700" b="1" i="0">
+              <a:solidFill>
+                <a:srgbClr val="2B2D42"/>
+              </a:solidFill>
+              <a:latin typeface="Calibri" panose="020F0502020204030204"/>
+            </a:endParaRPr>
           </a:p>
           <a:p>
             <a:pPr>
@@ -6097,10 +6298,16 @@
                 <a:solidFill>
                   <a:srgbClr val="2B2D42"/>
                 </a:solidFill>
-                <a:latin typeface="Calibri"/>
-              </a:rPr>
-              <a:t>•  Scope: the 0–6 month postpartum window — when low mood, anxiety and feeling overwhelmed peak.</a:t>
-            </a:r>
+                <a:latin typeface="Calibri" panose="020F0502020204030204"/>
+              </a:rPr>
+              <a:t>•  Scope: the 0–6 month postpartum window </a:t>
+            </a:r>
+            <a:endParaRPr sz="1700" b="1" i="0">
+              <a:solidFill>
+                <a:srgbClr val="2B2D42"/>
+              </a:solidFill>
+              <a:latin typeface="Calibri" panose="020F0502020204030204"/>
+            </a:endParaRPr>
           </a:p>
           <a:p>
             <a:pPr>
@@ -6116,10 +6323,34 @@
                 <a:solidFill>
                   <a:srgbClr val="2B2D42"/>
                 </a:solidFill>
-                <a:latin typeface="Calibri"/>
-              </a:rPr>
-              <a:t>•  Informational and supportive — never diagnostic. Every reply carries a disclaimer and a safety pathway.</a:t>
-            </a:r>
+                <a:latin typeface="Calibri" panose="020F0502020204030204"/>
+              </a:rPr>
+              <a:t>•  Informational and supportive</a:t>
+            </a:r>
+            <a:r>
+              <a:rPr lang="en-US" sz="1700" b="1" i="0">
+                <a:solidFill>
+                  <a:srgbClr val="2B2D42"/>
+                </a:solidFill>
+                <a:latin typeface="Calibri" panose="020F0502020204030204"/>
+              </a:rPr>
+              <a:t> </a:t>
+            </a:r>
+            <a:r>
+              <a:rPr sz="1700" b="1" i="0">
+                <a:solidFill>
+                  <a:srgbClr val="2B2D42"/>
+                </a:solidFill>
+                <a:latin typeface="Calibri" panose="020F0502020204030204"/>
+              </a:rPr>
+              <a:t>never diagnostic. Every reply carries a disclaimer and a safety pathway.</a:t>
+            </a:r>
+            <a:endParaRPr sz="1700" b="1" i="0">
+              <a:solidFill>
+                <a:srgbClr val="2B2D42"/>
+              </a:solidFill>
+              <a:latin typeface="Calibri" panose="020F0502020204030204"/>
+            </a:endParaRPr>
           </a:p>
           <a:p>
             <a:pPr>
@@ -6135,29 +6366,16 @@
                 <a:solidFill>
                   <a:srgbClr val="2B2D42"/>
                 </a:solidFill>
-                <a:latin typeface="Calibri"/>
+                <a:latin typeface="Calibri" panose="020F0502020204030204"/>
               </a:rPr>
               <a:t>•  Template-based, not generative: each intent maps to one guideline-sourced, human-reviewed response template (avoids LLM hallucination).</a:t>
             </a:r>
-          </a:p>
-          <a:p>
-            <a:pPr>
-              <a:spcBef>
-                <a:spcPts val="200"/>
-              </a:spcBef>
-              <a:spcAft>
-                <a:spcPts val="1000"/>
-              </a:spcAft>
-            </a:pPr>
-            <a:r>
-              <a:rPr sz="1700" b="1" i="0">
-                <a:solidFill>
-                  <a:srgbClr val="2B2D42"/>
-                </a:solidFill>
-                <a:latin typeface="Calibri"/>
-              </a:rPr>
-              <a:t>•  Designed for low-resource deployment — classical ML, no GPU at inference, runs on Streamlit Community Cloud.</a:t>
-            </a:r>
+            <a:endParaRPr sz="1700" b="1" i="0">
+              <a:solidFill>
+                <a:srgbClr val="2B2D42"/>
+              </a:solidFill>
+              <a:latin typeface="Calibri" panose="020F0502020204030204"/>
+            </a:endParaRPr>
           </a:p>
         </p:txBody>
       </p:sp>
@@ -6232,10 +6450,16 @@
                 <a:solidFill>
                   <a:srgbClr val="E76F51"/>
                 </a:solidFill>
-                <a:latin typeface="Calibri"/>
+                <a:latin typeface="Calibri" panose="020F0502020204030204"/>
               </a:rPr>
               <a:t>In one sentence</a:t>
             </a:r>
+            <a:endParaRPr sz="1400" b="1" i="0">
+              <a:solidFill>
+                <a:srgbClr val="E76F51"/>
+              </a:solidFill>
+              <a:latin typeface="Calibri" panose="020F0502020204030204"/>
+            </a:endParaRPr>
           </a:p>
           <a:p>
             <a:pPr>
@@ -6248,10 +6472,16 @@
                 <a:solidFill>
                   <a:srgbClr val="2B2D42"/>
                 </a:solidFill>
-                <a:latin typeface="Calibri"/>
+                <a:latin typeface="Calibri" panose="020F0502020204030204"/>
               </a:rPr>
               <a:t>“Meet mothers in their own language, route them to safe, expert-validated guidance, and measure exactly what translation costs us along the way.”</a:t>
             </a:r>
+            <a:endParaRPr sz="1600" b="0" i="1">
+              <a:solidFill>
+                <a:srgbClr val="2B2D42"/>
+              </a:solidFill>
+              <a:latin typeface="Calibri" panose="020F0502020204030204"/>
+            </a:endParaRPr>
           </a:p>
         </p:txBody>
       </p:sp>
@@ -6326,10 +6556,16 @@
                 <a:solidFill>
                   <a:srgbClr val="FFFFFF"/>
                 </a:solidFill>
-                <a:latin typeface="Calibri"/>
+                <a:latin typeface="Calibri" panose="020F0502020204030204"/>
               </a:rPr>
               <a:t>Umubyeyi  ·  Kinyarwanda Maternal Mental-Wellness Chatbot  ·  R. Irutingabo (ALU)</a:t>
             </a:r>
+            <a:endParaRPr sz="900" b="0" i="0">
+              <a:solidFill>
+                <a:srgbClr val="FFFFFF"/>
+              </a:solidFill>
+              <a:latin typeface="Calibri" panose="020F0502020204030204"/>
+            </a:endParaRPr>
           </a:p>
         </p:txBody>
       </p:sp>
@@ -6361,10 +6597,16 @@
                 <a:solidFill>
                   <a:srgbClr val="FFFFFF"/>
                 </a:solidFill>
-                <a:latin typeface="Calibri"/>
+                <a:latin typeface="Calibri" panose="020F0502020204030204"/>
               </a:rPr>
               <a:t>3</a:t>
             </a:r>
+            <a:endParaRPr sz="900" b="0" i="0">
+              <a:solidFill>
+                <a:srgbClr val="FFFFFF"/>
+              </a:solidFill>
+              <a:latin typeface="Calibri" panose="020F0502020204030204"/>
+            </a:endParaRPr>
           </a:p>
         </p:txBody>
       </p:sp>
@@ -6377,7 +6619,7 @@
 </file>
 
 <file path=ppt/slides/slide4.xml><?xml version="1.0" encoding="utf-8"?>
-<p:sld xmlns:a="http://schemas.openxmlformats.org/drawingml/2006/main" xmlns:p="http://schemas.openxmlformats.org/presentationml/2006/main" xmlns:r="http://schemas.openxmlformats.org/officeDocument/2006/relationships">
+<p:sld xmlns:a="http://schemas.openxmlformats.org/drawingml/2006/main" xmlns:r="http://schemas.openxmlformats.org/officeDocument/2006/relationships" xmlns:p="http://schemas.openxmlformats.org/presentationml/2006/main">
   <p:cSld>
     <p:spTree>
       <p:nvGrpSpPr>
@@ -6501,10 +6743,16 @@
                 <a:solidFill>
                   <a:srgbClr val="E76F51"/>
                 </a:solidFill>
-                <a:latin typeface="Calibri"/>
+                <a:latin typeface="Calibri" panose="020F0502020204030204"/>
               </a:rPr>
               <a:t>THE NEED</a:t>
             </a:r>
+            <a:endParaRPr sz="1200" b="1" i="0">
+              <a:solidFill>
+                <a:srgbClr val="E76F51"/>
+              </a:solidFill>
+              <a:latin typeface="Calibri" panose="020F0502020204030204"/>
+            </a:endParaRPr>
           </a:p>
         </p:txBody>
       </p:sp>
@@ -6535,10 +6783,16 @@
                 <a:solidFill>
                   <a:srgbClr val="2B2D42"/>
                 </a:solidFill>
-                <a:latin typeface="Calibri"/>
+                <a:latin typeface="Calibri" panose="020F0502020204030204"/>
               </a:rPr>
               <a:t>Why this matters</a:t>
             </a:r>
+            <a:endParaRPr sz="3000" b="1" i="0">
+              <a:solidFill>
+                <a:srgbClr val="2B2D42"/>
+              </a:solidFill>
+              <a:latin typeface="Calibri" panose="020F0502020204030204"/>
+            </a:endParaRPr>
           </a:p>
         </p:txBody>
       </p:sp>
@@ -6595,7 +6849,7 @@
         <p:spPr>
           <a:xfrm>
             <a:off x="548640" y="1783080"/>
-            <a:ext cx="10515600" cy="4480560"/>
+            <a:ext cx="10515600" cy="2122805"/>
           </a:xfrm>
           <a:prstGeom prst="rect">
             <a:avLst/>
@@ -6621,10 +6875,16 @@
                 <a:solidFill>
                   <a:srgbClr val="2B2D42"/>
                 </a:solidFill>
-                <a:latin typeface="Calibri"/>
+                <a:latin typeface="Calibri" panose="020F0502020204030204"/>
               </a:rPr>
               <a:t>•  Perinatal mental-health conditions are common and under-served in sub-Saharan Africa, yet rarely screened in routine postpartum care.</a:t>
             </a:r>
+            <a:endParaRPr sz="1700" b="1" i="0">
+              <a:solidFill>
+                <a:srgbClr val="2B2D42"/>
+              </a:solidFill>
+              <a:latin typeface="Calibri" panose="020F0502020204030204"/>
+            </a:endParaRPr>
           </a:p>
           <a:p>
             <a:pPr>
@@ -6640,10 +6900,16 @@
                 <a:solidFill>
                   <a:srgbClr val="2B2D42"/>
                 </a:solidFill>
-                <a:latin typeface="Calibri"/>
+                <a:latin typeface="Calibri" panose="020F0502020204030204"/>
               </a:rPr>
               <a:t>•  First-time mothers face the steepest adjustment, often in isolation and without a safe, private place to ask questions.</a:t>
             </a:r>
+            <a:endParaRPr sz="1700" b="1" i="0">
+              <a:solidFill>
+                <a:srgbClr val="2B2D42"/>
+              </a:solidFill>
+              <a:latin typeface="Calibri" panose="020F0502020204030204"/>
+            </a:endParaRPr>
           </a:p>
           <a:p>
             <a:pPr>
@@ -6659,10 +6925,16 @@
                 <a:solidFill>
                   <a:srgbClr val="2B2D42"/>
                 </a:solidFill>
-                <a:latin typeface="Calibri"/>
+                <a:latin typeface="Calibri" panose="020F0502020204030204"/>
               </a:rPr>
               <a:t>•  Language is the barrier: almost all digital maternal-health tools are English-only.</a:t>
             </a:r>
+            <a:endParaRPr sz="1700" b="1" i="0">
+              <a:solidFill>
+                <a:srgbClr val="2B2D42"/>
+              </a:solidFill>
+              <a:latin typeface="Calibri" panose="020F0502020204030204"/>
+            </a:endParaRPr>
           </a:p>
           <a:p>
             <a:pPr>
@@ -6678,29 +6950,16 @@
                 <a:solidFill>
                   <a:srgbClr val="2B2D42"/>
                 </a:solidFill>
-                <a:latin typeface="Calibri"/>
-              </a:rPr>
-              <a:t>•  Kinyarwanda is severely under-resourced in NLP — no public mental-wellness intent dataset exists.</a:t>
-            </a:r>
-          </a:p>
-          <a:p>
-            <a:pPr>
-              <a:spcBef>
-                <a:spcPts val="200"/>
-              </a:spcBef>
-              <a:spcAft>
-                <a:spcPts val="1000"/>
-              </a:spcAft>
-            </a:pPr>
-            <a:r>
-              <a:rPr sz="1700" b="1" i="0">
-                <a:solidFill>
-                  <a:srgbClr val="2B2D42"/>
-                </a:solidFill>
-                <a:latin typeface="Calibri"/>
-              </a:rPr>
-              <a:t>•  Prior work (e.g. the MOTHER dataset, Uganda) is English-only and physical health only, and names “translation needed” as its own limitation.</a:t>
-            </a:r>
+                <a:latin typeface="Calibri" panose="020F0502020204030204"/>
+              </a:rPr>
+              <a:t>.</a:t>
+            </a:r>
+            <a:endParaRPr sz="1700" b="1" i="0">
+              <a:solidFill>
+                <a:srgbClr val="2B2D42"/>
+              </a:solidFill>
+              <a:latin typeface="Calibri" panose="020F0502020204030204"/>
+            </a:endParaRPr>
           </a:p>
         </p:txBody>
       </p:sp>
@@ -6775,10 +7034,16 @@
                 <a:solidFill>
                   <a:srgbClr val="FFFFFF"/>
                 </a:solidFill>
-                <a:latin typeface="Calibri"/>
+                <a:latin typeface="Calibri" panose="020F0502020204030204"/>
               </a:rPr>
               <a:t>The gap = Kinyarwanda  ×  mental wellness  ×  Rwanda  —  exactly where Umubyeyi sits.</a:t>
             </a:r>
+            <a:endParaRPr sz="1600" b="1" i="0">
+              <a:solidFill>
+                <a:srgbClr val="FFFFFF"/>
+              </a:solidFill>
+              <a:latin typeface="Calibri" panose="020F0502020204030204"/>
+            </a:endParaRPr>
           </a:p>
         </p:txBody>
       </p:sp>
@@ -6853,10 +7118,16 @@
                 <a:solidFill>
                   <a:srgbClr val="FFFFFF"/>
                 </a:solidFill>
-                <a:latin typeface="Calibri"/>
+                <a:latin typeface="Calibri" panose="020F0502020204030204"/>
               </a:rPr>
               <a:t>Umubyeyi  ·  Kinyarwanda Maternal Mental-Wellness Chatbot  ·  R. Irutingabo (ALU)</a:t>
             </a:r>
+            <a:endParaRPr sz="900" b="0" i="0">
+              <a:solidFill>
+                <a:srgbClr val="FFFFFF"/>
+              </a:solidFill>
+              <a:latin typeface="Calibri" panose="020F0502020204030204"/>
+            </a:endParaRPr>
           </a:p>
         </p:txBody>
       </p:sp>
@@ -6888,10 +7159,16 @@
                 <a:solidFill>
                   <a:srgbClr val="FFFFFF"/>
                 </a:solidFill>
-                <a:latin typeface="Calibri"/>
+                <a:latin typeface="Calibri" panose="020F0502020204030204"/>
               </a:rPr>
               <a:t>4</a:t>
             </a:r>
+            <a:endParaRPr sz="900" b="0" i="0">
+              <a:solidFill>
+                <a:srgbClr val="FFFFFF"/>
+              </a:solidFill>
+              <a:latin typeface="Calibri" panose="020F0502020204030204"/>
+            </a:endParaRPr>
           </a:p>
         </p:txBody>
       </p:sp>
@@ -6904,7 +7181,7 @@
 </file>
 
 <file path=ppt/slides/slide5.xml><?xml version="1.0" encoding="utf-8"?>
-<p:sld xmlns:a="http://schemas.openxmlformats.org/drawingml/2006/main" xmlns:p="http://schemas.openxmlformats.org/presentationml/2006/main" xmlns:r="http://schemas.openxmlformats.org/officeDocument/2006/relationships">
+<p:sld xmlns:a="http://schemas.openxmlformats.org/drawingml/2006/main" xmlns:r="http://schemas.openxmlformats.org/officeDocument/2006/relationships" xmlns:p="http://schemas.openxmlformats.org/presentationml/2006/main">
   <p:cSld>
     <p:spTree>
       <p:nvGrpSpPr>
@@ -7028,10 +7305,16 @@
                 <a:solidFill>
                   <a:srgbClr val="E76F51"/>
                 </a:solidFill>
-                <a:latin typeface="Calibri"/>
+                <a:latin typeface="Calibri" panose="020F0502020204030204"/>
               </a:rPr>
               <a:t>DATA</a:t>
             </a:r>
+            <a:endParaRPr sz="1200" b="1" i="0">
+              <a:solidFill>
+                <a:srgbClr val="E76F51"/>
+              </a:solidFill>
+              <a:latin typeface="Calibri" panose="020F0502020204030204"/>
+            </a:endParaRPr>
           </a:p>
         </p:txBody>
       </p:sp>
@@ -7062,10 +7345,16 @@
                 <a:solidFill>
                   <a:srgbClr val="2B2D42"/>
                 </a:solidFill>
-                <a:latin typeface="Calibri"/>
+                <a:latin typeface="Calibri" panose="020F0502020204030204"/>
               </a:rPr>
               <a:t>Three data sources, three distinct roles</a:t>
             </a:r>
+            <a:endParaRPr sz="3000" b="1" i="0">
+              <a:solidFill>
+                <a:srgbClr val="2B2D42"/>
+              </a:solidFill>
+              <a:latin typeface="Calibri" panose="020F0502020204030204"/>
+            </a:endParaRPr>
           </a:p>
         </p:txBody>
       </p:sp>
@@ -7228,10 +7517,16 @@
                 <a:solidFill>
                   <a:srgbClr val="FFFFFF"/>
                 </a:solidFill>
-                <a:latin typeface="Calibri"/>
+                <a:latin typeface="Calibri" panose="020F0502020204030204"/>
               </a:rPr>
               <a:t>TRAINING DATA</a:t>
             </a:r>
+            <a:endParaRPr sz="1100" b="1" i="0">
+              <a:solidFill>
+                <a:srgbClr val="FFFFFF"/>
+              </a:solidFill>
+              <a:latin typeface="Calibri" panose="020F0502020204030204"/>
+            </a:endParaRPr>
           </a:p>
         </p:txBody>
       </p:sp>
@@ -7262,10 +7557,16 @@
                 <a:solidFill>
                   <a:srgbClr val="2B2D42"/>
                 </a:solidFill>
-                <a:latin typeface="Calibri"/>
+                <a:latin typeface="Calibri" panose="020F0502020204030204"/>
               </a:rPr>
               <a:t>Amod counseling Q&amp;A</a:t>
             </a:r>
+            <a:endParaRPr sz="1600" b="1" i="0">
+              <a:solidFill>
+                <a:srgbClr val="2B2D42"/>
+              </a:solidFill>
+              <a:latin typeface="Calibri" panose="020F0502020204030204"/>
+            </a:endParaRPr>
           </a:p>
         </p:txBody>
       </p:sp>
@@ -7301,10 +7602,16 @@
                 <a:solidFill>
                   <a:srgbClr val="55576B"/>
                 </a:solidFill>
-                <a:latin typeface="Calibri"/>
+                <a:latin typeface="Calibri" panose="020F0502020204030204"/>
               </a:rPr>
               <a:t>•  3,512 rows of real therapist Q&amp;A</a:t>
             </a:r>
+            <a:endParaRPr sz="1300" b="0" i="0">
+              <a:solidFill>
+                <a:srgbClr val="55576B"/>
+              </a:solidFill>
+              <a:latin typeface="Calibri" panose="020F0502020204030204"/>
+            </a:endParaRPr>
           </a:p>
           <a:p>
             <a:pPr>
@@ -7317,10 +7624,16 @@
                 <a:solidFill>
                   <a:srgbClr val="55576B"/>
                 </a:solidFill>
-                <a:latin typeface="Calibri"/>
+                <a:latin typeface="Calibri" panose="020F0502020204030204"/>
               </a:rPr>
               <a:t>•  995 unique questions (heavy duplication)</a:t>
             </a:r>
+            <a:endParaRPr sz="1300" b="0" i="0">
+              <a:solidFill>
+                <a:srgbClr val="55576B"/>
+              </a:solidFill>
+              <a:latin typeface="Calibri" panose="020F0502020204030204"/>
+            </a:endParaRPr>
           </a:p>
           <a:p>
             <a:pPr>
@@ -7333,10 +7646,16 @@
                 <a:solidFill>
                   <a:srgbClr val="55576B"/>
                 </a:solidFill>
-                <a:latin typeface="Calibri"/>
+                <a:latin typeface="Calibri" panose="020F0502020204030204"/>
               </a:rPr>
               <a:t>•  Filtered to maternal-relevant subset</a:t>
             </a:r>
+            <a:endParaRPr sz="1300" b="0" i="0">
+              <a:solidFill>
+                <a:srgbClr val="55576B"/>
+              </a:solidFill>
+              <a:latin typeface="Calibri" panose="020F0502020204030204"/>
+            </a:endParaRPr>
           </a:p>
           <a:p>
             <a:pPr>
@@ -7349,10 +7668,16 @@
                 <a:solidFill>
                   <a:srgbClr val="55576B"/>
                 </a:solidFill>
-                <a:latin typeface="Calibri"/>
+                <a:latin typeface="Calibri" panose="020F0502020204030204"/>
               </a:rPr>
               <a:t>•  Labeled into 6 wellness intents</a:t>
             </a:r>
+            <a:endParaRPr sz="1300" b="0" i="0">
+              <a:solidFill>
+                <a:srgbClr val="55576B"/>
+              </a:solidFill>
+              <a:latin typeface="Calibri" panose="020F0502020204030204"/>
+            </a:endParaRPr>
           </a:p>
         </p:txBody>
       </p:sp>
@@ -7471,10 +7796,16 @@
                 <a:solidFill>
                   <a:srgbClr val="FFFFFF"/>
                 </a:solidFill>
-                <a:latin typeface="Calibri"/>
+                <a:latin typeface="Calibri" panose="020F0502020204030204"/>
               </a:rPr>
               <a:t>FRAMING / LIT REVIEW</a:t>
             </a:r>
+            <a:endParaRPr sz="1100" b="1" i="0">
+              <a:solidFill>
+                <a:srgbClr val="FFFFFF"/>
+              </a:solidFill>
+              <a:latin typeface="Calibri" panose="020F0502020204030204"/>
+            </a:endParaRPr>
           </a:p>
         </p:txBody>
       </p:sp>
@@ -7505,10 +7836,16 @@
                 <a:solidFill>
                   <a:srgbClr val="2B2D42"/>
                 </a:solidFill>
-                <a:latin typeface="Calibri"/>
+                <a:latin typeface="Calibri" panose="020F0502020204030204"/>
               </a:rPr>
               <a:t>MOTHER dataset (Uganda)</a:t>
             </a:r>
+            <a:endParaRPr sz="1600" b="1" i="0">
+              <a:solidFill>
+                <a:srgbClr val="2B2D42"/>
+              </a:solidFill>
+              <a:latin typeface="Calibri" panose="020F0502020204030204"/>
+            </a:endParaRPr>
           </a:p>
         </p:txBody>
       </p:sp>
@@ -7544,10 +7881,16 @@
                 <a:solidFill>
                   <a:srgbClr val="55576B"/>
                 </a:solidFill>
-                <a:latin typeface="Calibri"/>
+                <a:latin typeface="Calibri" panose="020F0502020204030204"/>
               </a:rPr>
               <a:t>•  503 maternal-health Q&amp;A, CC BY 4.0</a:t>
             </a:r>
+            <a:endParaRPr sz="1300" b="0" i="0">
+              <a:solidFill>
+                <a:srgbClr val="55576B"/>
+              </a:solidFill>
+              <a:latin typeface="Calibri" panose="020F0502020204030204"/>
+            </a:endParaRPr>
           </a:p>
           <a:p>
             <a:pPr>
@@ -7560,10 +7903,16 @@
                 <a:solidFill>
                   <a:srgbClr val="55576B"/>
                 </a:solidFill>
-                <a:latin typeface="Calibri"/>
+                <a:latin typeface="Calibri" panose="020F0502020204030204"/>
               </a:rPr>
               <a:t>•  English-only, physical health only</a:t>
             </a:r>
+            <a:endParaRPr sz="1300" b="0" i="0">
+              <a:solidFill>
+                <a:srgbClr val="55576B"/>
+              </a:solidFill>
+              <a:latin typeface="Calibri" panose="020F0502020204030204"/>
+            </a:endParaRPr>
           </a:p>
           <a:p>
             <a:pPr>
@@ -7576,10 +7925,16 @@
                 <a:solidFill>
                   <a:srgbClr val="55576B"/>
                 </a:solidFill>
-                <a:latin typeface="Calibri"/>
+                <a:latin typeface="Calibri" panose="020F0502020204030204"/>
               </a:rPr>
               <a:t>•  Cited to frame the research gap</a:t>
             </a:r>
+            <a:endParaRPr sz="1300" b="0" i="0">
+              <a:solidFill>
+                <a:srgbClr val="55576B"/>
+              </a:solidFill>
+              <a:latin typeface="Calibri" panose="020F0502020204030204"/>
+            </a:endParaRPr>
           </a:p>
           <a:p>
             <a:pPr>
@@ -7592,10 +7947,16 @@
                 <a:solidFill>
                   <a:srgbClr val="55576B"/>
                 </a:solidFill>
-                <a:latin typeface="Calibri"/>
+                <a:latin typeface="Calibri" panose="020F0502020204030204"/>
               </a:rPr>
               <a:t>•  NOT used for training or the KB</a:t>
             </a:r>
+            <a:endParaRPr sz="1300" b="0" i="0">
+              <a:solidFill>
+                <a:srgbClr val="55576B"/>
+              </a:solidFill>
+              <a:latin typeface="Calibri" panose="020F0502020204030204"/>
+            </a:endParaRPr>
           </a:p>
         </p:txBody>
       </p:sp>
@@ -7714,10 +8075,16 @@
                 <a:solidFill>
                   <a:srgbClr val="FFFFFF"/>
                 </a:solidFill>
-                <a:latin typeface="Calibri"/>
+                <a:latin typeface="Calibri" panose="020F0502020204030204"/>
               </a:rPr>
               <a:t>RESPONSE TEMPLATES</a:t>
             </a:r>
+            <a:endParaRPr sz="1100" b="1" i="0">
+              <a:solidFill>
+                <a:srgbClr val="FFFFFF"/>
+              </a:solidFill>
+              <a:latin typeface="Calibri" panose="020F0502020204030204"/>
+            </a:endParaRPr>
           </a:p>
         </p:txBody>
       </p:sp>
@@ -7748,10 +8115,16 @@
                 <a:solidFill>
                   <a:srgbClr val="2B2D42"/>
                 </a:solidFill>
-                <a:latin typeface="Calibri"/>
+                <a:latin typeface="Calibri" panose="020F0502020204030204"/>
               </a:rPr>
               <a:t>WHO / UNFPA guidance</a:t>
             </a:r>
+            <a:endParaRPr sz="1600" b="1" i="0">
+              <a:solidFill>
+                <a:srgbClr val="2B2D42"/>
+              </a:solidFill>
+              <a:latin typeface="Calibri" panose="020F0502020204030204"/>
+            </a:endParaRPr>
           </a:p>
         </p:txBody>
       </p:sp>
@@ -7787,10 +8160,16 @@
                 <a:solidFill>
                   <a:srgbClr val="55576B"/>
                 </a:solidFill>
-                <a:latin typeface="Calibri"/>
+                <a:latin typeface="Calibri" panose="020F0502020204030204"/>
               </a:rPr>
               <a:t>•  Tier-1 global authorities</a:t>
             </a:r>
+            <a:endParaRPr sz="1300" b="0" i="0">
+              <a:solidFill>
+                <a:srgbClr val="55576B"/>
+              </a:solidFill>
+              <a:latin typeface="Calibri" panose="020F0502020204030204"/>
+            </a:endParaRPr>
           </a:p>
           <a:p>
             <a:pPr>
@@ -7803,10 +8182,16 @@
                 <a:solidFill>
                   <a:srgbClr val="55576B"/>
                 </a:solidFill>
-                <a:latin typeface="Calibri"/>
+                <a:latin typeface="Calibri" panose="020F0502020204030204"/>
               </a:rPr>
               <a:t>•  Source of every user-facing answer</a:t>
             </a:r>
+            <a:endParaRPr sz="1300" b="0" i="0">
+              <a:solidFill>
+                <a:srgbClr val="55576B"/>
+              </a:solidFill>
+              <a:latin typeface="Calibri" panose="020F0502020204030204"/>
+            </a:endParaRPr>
           </a:p>
           <a:p>
             <a:pPr>
@@ -7819,10 +8204,16 @@
                 <a:solidFill>
                   <a:srgbClr val="55576B"/>
                 </a:solidFill>
-                <a:latin typeface="Calibri"/>
+                <a:latin typeface="Calibri" panose="020F0502020204030204"/>
               </a:rPr>
               <a:t>•  Pre-translated + human-reviewed</a:t>
             </a:r>
+            <a:endParaRPr sz="1300" b="0" i="0">
+              <a:solidFill>
+                <a:srgbClr val="55576B"/>
+              </a:solidFill>
+              <a:latin typeface="Calibri" panose="020F0502020204030204"/>
+            </a:endParaRPr>
           </a:p>
           <a:p>
             <a:pPr>
@@ -7835,10 +8226,16 @@
                 <a:solidFill>
                   <a:srgbClr val="55576B"/>
                 </a:solidFill>
-                <a:latin typeface="Calibri"/>
+                <a:latin typeface="Calibri" panose="020F0502020204030204"/>
               </a:rPr>
               <a:t>•  6 response templates (1 per intent)</a:t>
             </a:r>
+            <a:endParaRPr sz="1300" b="0" i="0">
+              <a:solidFill>
+                <a:srgbClr val="55576B"/>
+              </a:solidFill>
+              <a:latin typeface="Calibri" panose="020F0502020204030204"/>
+            </a:endParaRPr>
           </a:p>
         </p:txBody>
       </p:sp>
@@ -7913,10 +8310,16 @@
                 <a:solidFill>
                   <a:srgbClr val="FFFFFF"/>
                 </a:solidFill>
-                <a:latin typeface="Calibri"/>
+                <a:latin typeface="Calibri" panose="020F0502020204030204"/>
               </a:rPr>
               <a:t>Umubyeyi  ·  Kinyarwanda Maternal Mental-Wellness Chatbot  ·  R. Irutingabo (ALU)</a:t>
             </a:r>
+            <a:endParaRPr sz="900" b="0" i="0">
+              <a:solidFill>
+                <a:srgbClr val="FFFFFF"/>
+              </a:solidFill>
+              <a:latin typeface="Calibri" panose="020F0502020204030204"/>
+            </a:endParaRPr>
           </a:p>
         </p:txBody>
       </p:sp>
@@ -7948,10 +8351,16 @@
                 <a:solidFill>
                   <a:srgbClr val="FFFFFF"/>
                 </a:solidFill>
-                <a:latin typeface="Calibri"/>
+                <a:latin typeface="Calibri" panose="020F0502020204030204"/>
               </a:rPr>
               <a:t>5</a:t>
             </a:r>
+            <a:endParaRPr sz="900" b="0" i="0">
+              <a:solidFill>
+                <a:srgbClr val="FFFFFF"/>
+              </a:solidFill>
+              <a:latin typeface="Calibri" panose="020F0502020204030204"/>
+            </a:endParaRPr>
           </a:p>
         </p:txBody>
       </p:sp>
@@ -7964,7 +8373,7 @@
 </file>
 
 <file path=ppt/slides/slide6.xml><?xml version="1.0" encoding="utf-8"?>
-<p:sld xmlns:a="http://schemas.openxmlformats.org/drawingml/2006/main" xmlns:p="http://schemas.openxmlformats.org/presentationml/2006/main" xmlns:r="http://schemas.openxmlformats.org/officeDocument/2006/relationships">
+<p:sld xmlns:a="http://schemas.openxmlformats.org/drawingml/2006/main" xmlns:r="http://schemas.openxmlformats.org/officeDocument/2006/relationships" xmlns:p="http://schemas.openxmlformats.org/presentationml/2006/main">
   <p:cSld>
     <p:spTree>
       <p:nvGrpSpPr>
@@ -8088,10 +8497,16 @@
                 <a:solidFill>
                   <a:srgbClr val="E76F51"/>
                 </a:solidFill>
-                <a:latin typeface="Calibri"/>
+                <a:latin typeface="Calibri" panose="020F0502020204030204"/>
               </a:rPr>
               <a:t>DATA PREPROCESSING &amp; EXPLORATION</a:t>
             </a:r>
+            <a:endParaRPr sz="1200" b="1" i="0">
+              <a:solidFill>
+                <a:srgbClr val="E76F51"/>
+              </a:solidFill>
+              <a:latin typeface="Calibri" panose="020F0502020204030204"/>
+            </a:endParaRPr>
           </a:p>
         </p:txBody>
       </p:sp>
@@ -8122,10 +8537,16 @@
                 <a:solidFill>
                   <a:srgbClr val="2B2D42"/>
                 </a:solidFill>
-                <a:latin typeface="Calibri"/>
+                <a:latin typeface="Calibri" panose="020F0502020204030204"/>
               </a:rPr>
               <a:t>What the data told us</a:t>
             </a:r>
+            <a:endParaRPr sz="3000" b="1" i="0">
+              <a:solidFill>
+                <a:srgbClr val="2B2D42"/>
+              </a:solidFill>
+              <a:latin typeface="Calibri" panose="020F0502020204030204"/>
+            </a:endParaRPr>
           </a:p>
         </p:txBody>
       </p:sp>
@@ -8208,10 +8629,16 @@
                 <a:solidFill>
                   <a:srgbClr val="2B2D42"/>
                 </a:solidFill>
-                <a:latin typeface="Calibri"/>
+                <a:latin typeface="Calibri" panose="020F0502020204030204"/>
               </a:rPr>
               <a:t>•  Deduplication finding: 3,512 rows collapse to 995 unique questions — 2,517 are the same question answered by different counselors.</a:t>
             </a:r>
+            <a:endParaRPr sz="1500" b="1" i="0">
+              <a:solidFill>
+                <a:srgbClr val="2B2D42"/>
+              </a:solidFill>
+              <a:latin typeface="Calibri" panose="020F0502020204030204"/>
+            </a:endParaRPr>
           </a:p>
           <a:p>
             <a:pPr>
@@ -8227,10 +8654,16 @@
                 <a:solidFill>
                   <a:srgbClr val="2B2D42"/>
                 </a:solidFill>
-                <a:latin typeface="Calibri"/>
+                <a:latin typeface="Calibri" panose="020F0502020204030204"/>
               </a:rPr>
               <a:t>•  Consequence: split on unique questions (GroupShuffleSplit) to avoid leakage and inflated accuracy.</a:t>
             </a:r>
+            <a:endParaRPr sz="1500" b="1" i="0">
+              <a:solidFill>
+                <a:srgbClr val="2B2D42"/>
+              </a:solidFill>
+              <a:latin typeface="Calibri" panose="020F0502020204030204"/>
+            </a:endParaRPr>
           </a:p>
           <a:p>
             <a:pPr>
@@ -8246,10 +8679,16 @@
                 <a:solidFill>
                   <a:srgbClr val="2B2D42"/>
                 </a:solidFill>
-                <a:latin typeface="Calibri"/>
+                <a:latin typeface="Calibri" panose="020F0502020204030204"/>
               </a:rPr>
               <a:t>•  Intents are imbalanced — relationship/support dominates, self-care is scarce.</a:t>
             </a:r>
+            <a:endParaRPr sz="1500" b="1" i="0">
+              <a:solidFill>
+                <a:srgbClr val="2B2D42"/>
+              </a:solidFill>
+              <a:latin typeface="Calibri" panose="020F0502020204030204"/>
+            </a:endParaRPr>
           </a:p>
           <a:p>
             <a:pPr lvl="1">
@@ -8265,10 +8704,16 @@
                 <a:solidFill>
                   <a:srgbClr val="55576B"/>
                 </a:solidFill>
-                <a:latin typeface="Calibri"/>
+                <a:latin typeface="Calibri" panose="020F0502020204030204"/>
               </a:rPr>
               <a:t>    –  This is why we report F1, not just accuracy.</a:t>
             </a:r>
+            <a:endParaRPr sz="1300" b="0" i="0">
+              <a:solidFill>
+                <a:srgbClr val="55576B"/>
+              </a:solidFill>
+              <a:latin typeface="Calibri" panose="020F0502020204030204"/>
+            </a:endParaRPr>
           </a:p>
           <a:p>
             <a:pPr>
@@ -8284,10 +8729,16 @@
                 <a:solidFill>
                   <a:srgbClr val="2B2D42"/>
                 </a:solidFill>
-                <a:latin typeface="Calibri"/>
+                <a:latin typeface="Calibri" panose="020F0502020204030204"/>
               </a:rPr>
               <a:t>•  Cleaning: scope filtering, lowercasing, TF-IDF features.</a:t>
             </a:r>
+            <a:endParaRPr sz="1500" b="1" i="0">
+              <a:solidFill>
+                <a:srgbClr val="2B2D42"/>
+              </a:solidFill>
+              <a:latin typeface="Calibri" panose="020F0502020204030204"/>
+            </a:endParaRPr>
           </a:p>
         </p:txBody>
       </p:sp>
@@ -8300,7 +8751,7 @@
           <p:nvPr/>
         </p:nvPicPr>
         <p:blipFill>
-          <a:blip r:embed="rId2"/>
+          <a:blip r:embed="rId1"/>
           <a:stretch>
             <a:fillRect/>
           </a:stretch>
@@ -8343,10 +8794,16 @@
                 <a:solidFill>
                   <a:srgbClr val="55576B"/>
                 </a:solidFill>
-                <a:latin typeface="Calibri"/>
+                <a:latin typeface="Calibri" panose="020F0502020204030204"/>
               </a:rPr>
               <a:t>Intent coverage across the maternal subset (class imbalance)</a:t>
             </a:r>
+            <a:endParaRPr sz="1000" b="0" i="1">
+              <a:solidFill>
+                <a:srgbClr val="55576B"/>
+              </a:solidFill>
+              <a:latin typeface="Calibri" panose="020F0502020204030204"/>
+            </a:endParaRPr>
           </a:p>
         </p:txBody>
       </p:sp>
@@ -8421,10 +8878,16 @@
                 <a:solidFill>
                   <a:srgbClr val="FFFFFF"/>
                 </a:solidFill>
-                <a:latin typeface="Calibri"/>
+                <a:latin typeface="Calibri" panose="020F0502020204030204"/>
               </a:rPr>
               <a:t>Umubyeyi  ·  Kinyarwanda Maternal Mental-Wellness Chatbot  ·  R. Irutingabo (ALU)</a:t>
             </a:r>
+            <a:endParaRPr sz="900" b="0" i="0">
+              <a:solidFill>
+                <a:srgbClr val="FFFFFF"/>
+              </a:solidFill>
+              <a:latin typeface="Calibri" panose="020F0502020204030204"/>
+            </a:endParaRPr>
           </a:p>
         </p:txBody>
       </p:sp>
@@ -8456,10 +8919,16 @@
                 <a:solidFill>
                   <a:srgbClr val="FFFFFF"/>
                 </a:solidFill>
-                <a:latin typeface="Calibri"/>
+                <a:latin typeface="Calibri" panose="020F0502020204030204"/>
               </a:rPr>
               <a:t>6</a:t>
             </a:r>
+            <a:endParaRPr sz="900" b="0" i="0">
+              <a:solidFill>
+                <a:srgbClr val="FFFFFF"/>
+              </a:solidFill>
+              <a:latin typeface="Calibri" panose="020F0502020204030204"/>
+            </a:endParaRPr>
           </a:p>
         </p:txBody>
       </p:sp>
@@ -8472,7 +8941,7 @@
 </file>
 
 <file path=ppt/slides/slide7.xml><?xml version="1.0" encoding="utf-8"?>
-<p:sld xmlns:a="http://schemas.openxmlformats.org/drawingml/2006/main" xmlns:p="http://schemas.openxmlformats.org/presentationml/2006/main" xmlns:r="http://schemas.openxmlformats.org/officeDocument/2006/relationships">
+<p:sld xmlns:a="http://schemas.openxmlformats.org/drawingml/2006/main" xmlns:r="http://schemas.openxmlformats.org/officeDocument/2006/relationships" xmlns:p="http://schemas.openxmlformats.org/presentationml/2006/main">
   <p:cSld>
     <p:spTree>
       <p:nvGrpSpPr>
@@ -8596,10 +9065,16 @@
                 <a:solidFill>
                   <a:srgbClr val="E76F51"/>
                 </a:solidFill>
-                <a:latin typeface="Calibri"/>
+                <a:latin typeface="Calibri" panose="020F0502020204030204"/>
               </a:rPr>
               <a:t>THE APPROACH (1/2)</a:t>
             </a:r>
+            <a:endParaRPr sz="1200" b="1" i="0">
+              <a:solidFill>
+                <a:srgbClr val="E76F51"/>
+              </a:solidFill>
+              <a:latin typeface="Calibri" panose="020F0502020204030204"/>
+            </a:endParaRPr>
           </a:p>
         </p:txBody>
       </p:sp>
@@ -8630,10 +9105,16 @@
                 <a:solidFill>
                   <a:srgbClr val="2B2D42"/>
                 </a:solidFill>
-                <a:latin typeface="Calibri"/>
+                <a:latin typeface="Calibri" panose="020F0502020204030204"/>
               </a:rPr>
               <a:t>The system pipeline</a:t>
             </a:r>
+            <a:endParaRPr sz="3000" b="1" i="0">
+              <a:solidFill>
+                <a:srgbClr val="2B2D42"/>
+              </a:solidFill>
+              <a:latin typeface="Calibri" panose="020F0502020204030204"/>
+            </a:endParaRPr>
           </a:p>
         </p:txBody>
       </p:sp>
@@ -8690,7 +9171,7 @@
           <p:nvPr/>
         </p:nvPicPr>
         <p:blipFill>
-          <a:blip r:embed="rId2"/>
+          <a:blip r:embed="rId1"/>
           <a:stretch>
             <a:fillRect/>
           </a:stretch>
@@ -8713,7 +9194,7 @@
         </p:nvSpPr>
         <p:spPr>
           <a:xfrm>
-            <a:off x="548640" y="3886200"/>
+            <a:off x="457200" y="4784090"/>
             <a:ext cx="10972800" cy="4480560"/>
           </a:xfrm>
           <a:prstGeom prst="rect">
@@ -8740,10 +9221,16 @@
                 <a:solidFill>
                   <a:srgbClr val="2B2D42"/>
                 </a:solidFill>
-                <a:latin typeface="Calibri"/>
+                <a:latin typeface="Calibri" panose="020F0502020204030204"/>
               </a:rPr>
               <a:t>•  Kinyarwanda in → NLLB-200 translates to English → TF-IDF + ML classifier assigns 1 of 6 intents → return that intent's response template → translate back → display the Kinyarwanda response with a disclaimer.</a:t>
             </a:r>
+            <a:endParaRPr sz="1400" b="1" i="0">
+              <a:solidFill>
+                <a:srgbClr val="2B2D42"/>
+              </a:solidFill>
+              <a:latin typeface="Calibri" panose="020F0502020204030204"/>
+            </a:endParaRPr>
           </a:p>
           <a:p>
             <a:pPr>
@@ -8759,10 +9246,16 @@
                 <a:solidFill>
                   <a:srgbClr val="2B2D42"/>
                 </a:solidFill>
-                <a:latin typeface="Calibri"/>
+                <a:latin typeface="Calibri" panose="020F0502020204030204"/>
               </a:rPr>
               <a:t>•  Two safety gates: (1) confidence gate — low-confidence inputs fall back to general self-care; (2) danger-sign keywords bypass everything → Rwanda helpline escalation.</a:t>
             </a:r>
+            <a:endParaRPr sz="1400" b="1" i="0">
+              <a:solidFill>
+                <a:srgbClr val="2B2D42"/>
+              </a:solidFill>
+              <a:latin typeface="Calibri" panose="020F0502020204030204"/>
+            </a:endParaRPr>
           </a:p>
           <a:p>
             <a:pPr>
@@ -8778,10 +9271,16 @@
                 <a:solidFill>
                   <a:srgbClr val="2B2D42"/>
                 </a:solidFill>
-                <a:latin typeface="Calibri"/>
+                <a:latin typeface="Calibri" panose="020F0502020204030204"/>
               </a:rPr>
               <a:t>•  Deployment MVP built: architecture diagram, web mockup, a Streamlit app and a FastAPI sketch (Swagger UI for testing).</a:t>
             </a:r>
+            <a:endParaRPr sz="1400" b="1" i="0">
+              <a:solidFill>
+                <a:srgbClr val="2B2D42"/>
+              </a:solidFill>
+              <a:latin typeface="Calibri" panose="020F0502020204030204"/>
+            </a:endParaRPr>
           </a:p>
         </p:txBody>
       </p:sp>
@@ -8856,10 +9355,16 @@
                 <a:solidFill>
                   <a:srgbClr val="FFFFFF"/>
                 </a:solidFill>
-                <a:latin typeface="Calibri"/>
+                <a:latin typeface="Calibri" panose="020F0502020204030204"/>
               </a:rPr>
               <a:t>Umubyeyi  ·  Kinyarwanda Maternal Mental-Wellness Chatbot  ·  R. Irutingabo (ALU)</a:t>
             </a:r>
+            <a:endParaRPr sz="900" b="0" i="0">
+              <a:solidFill>
+                <a:srgbClr val="FFFFFF"/>
+              </a:solidFill>
+              <a:latin typeface="Calibri" panose="020F0502020204030204"/>
+            </a:endParaRPr>
           </a:p>
         </p:txBody>
       </p:sp>
@@ -8891,10 +9396,16 @@
                 <a:solidFill>
                   <a:srgbClr val="FFFFFF"/>
                 </a:solidFill>
-                <a:latin typeface="Calibri"/>
+                <a:latin typeface="Calibri" panose="020F0502020204030204"/>
               </a:rPr>
               <a:t>7</a:t>
             </a:r>
+            <a:endParaRPr sz="900" b="0" i="0">
+              <a:solidFill>
+                <a:srgbClr val="FFFFFF"/>
+              </a:solidFill>
+              <a:latin typeface="Calibri" panose="020F0502020204030204"/>
+            </a:endParaRPr>
           </a:p>
         </p:txBody>
       </p:sp>
@@ -8907,7 +9418,7 @@
 </file>
 
 <file path=ppt/slides/slide8.xml><?xml version="1.0" encoding="utf-8"?>
-<p:sld xmlns:a="http://schemas.openxmlformats.org/drawingml/2006/main" xmlns:p="http://schemas.openxmlformats.org/presentationml/2006/main" xmlns:r="http://schemas.openxmlformats.org/officeDocument/2006/relationships">
+<p:sld xmlns:a="http://schemas.openxmlformats.org/drawingml/2006/main" xmlns:r="http://schemas.openxmlformats.org/officeDocument/2006/relationships" xmlns:p="http://schemas.openxmlformats.org/presentationml/2006/main">
   <p:cSld>
     <p:spTree>
       <p:nvGrpSpPr>
@@ -9031,10 +9542,16 @@
                 <a:solidFill>
                   <a:srgbClr val="E76F51"/>
                 </a:solidFill>
-                <a:latin typeface="Calibri"/>
+                <a:latin typeface="Calibri" panose="020F0502020204030204"/>
               </a:rPr>
               <a:t>THE APPROACH (2/2)</a:t>
             </a:r>
+            <a:endParaRPr sz="1200" b="1" i="0">
+              <a:solidFill>
+                <a:srgbClr val="E76F51"/>
+              </a:solidFill>
+              <a:latin typeface="Calibri" panose="020F0502020204030204"/>
+            </a:endParaRPr>
           </a:p>
         </p:txBody>
       </p:sp>
@@ -9047,7 +9564,7 @@
         <p:spPr>
           <a:xfrm>
             <a:off x="457200" y="640080"/>
-            <a:ext cx="11247120" cy="822960"/>
+            <a:ext cx="11247120" cy="553085"/>
           </a:xfrm>
           <a:prstGeom prst="rect">
             <a:avLst/>
@@ -9061,14 +9578,20 @@
           <a:lstStyle/>
           <a:p>
             <a:r>
-              <a:rPr sz="3000" b="1" i="0">
+              <a:rPr lang="en-US" sz="3000" b="1" i="0">
                 <a:solidFill>
                   <a:srgbClr val="2B2D42"/>
                 </a:solidFill>
-                <a:latin typeface="Calibri"/>
-              </a:rPr>
-              <a:t>The model ladder: floor → embeddings → transformer</a:t>
-            </a:r>
+                <a:latin typeface="Calibri" panose="020F0502020204030204"/>
+              </a:rPr>
+              <a:t>Project Implentation</a:t>
+            </a:r>
+            <a:endParaRPr lang="en-US" sz="3000" b="1" i="0">
+              <a:solidFill>
+                <a:srgbClr val="2B2D42"/>
+              </a:solidFill>
+              <a:latin typeface="Calibri" panose="020F0502020204030204"/>
+            </a:endParaRPr>
           </a:p>
         </p:txBody>
       </p:sp>
@@ -9143,10 +9666,16 @@
                 <a:solidFill>
                   <a:srgbClr val="55576B"/>
                 </a:solidFill>
-                <a:latin typeface="Calibri"/>
+                <a:latin typeface="Calibri" panose="020F0502020204030204"/>
               </a:rPr>
               <a:t>Three classifiers on the SAME labels and SAME 80/20 split — each adds exactly one idea and must beat the one below it.</a:t>
             </a:r>
+            <a:endParaRPr sz="1500" b="0" i="1">
+              <a:solidFill>
+                <a:srgbClr val="55576B"/>
+              </a:solidFill>
+              <a:latin typeface="Calibri" panose="020F0502020204030204"/>
+            </a:endParaRPr>
           </a:p>
         </p:txBody>
       </p:sp>
@@ -9266,10 +9795,16 @@
                 <a:solidFill>
                   <a:srgbClr val="FFFFFF"/>
                 </a:solidFill>
-                <a:latin typeface="Calibri"/>
+                <a:latin typeface="Calibri" panose="020F0502020204030204"/>
               </a:rPr>
               <a:t>1</a:t>
             </a:r>
+            <a:endParaRPr sz="3000" b="1" i="0">
+              <a:solidFill>
+                <a:srgbClr val="FFFFFF"/>
+              </a:solidFill>
+              <a:latin typeface="Calibri" panose="020F0502020204030204"/>
+            </a:endParaRPr>
           </a:p>
         </p:txBody>
       </p:sp>
@@ -9300,10 +9835,16 @@
                 <a:solidFill>
                   <a:srgbClr val="2B2D42"/>
                 </a:solidFill>
-                <a:latin typeface="Calibri"/>
+                <a:latin typeface="Calibri" panose="020F0502020204030204"/>
               </a:rPr>
               <a:t>TF-IDF + Logistic Regression   (English)</a:t>
             </a:r>
+            <a:endParaRPr sz="1600" b="1" i="0">
+              <a:solidFill>
+                <a:srgbClr val="2B2D42"/>
+              </a:solidFill>
+              <a:latin typeface="Calibri" panose="020F0502020204030204"/>
+            </a:endParaRPr>
           </a:p>
           <a:p>
             <a:pPr>
@@ -9316,10 +9857,16 @@
                 <a:solidFill>
                   <a:srgbClr val="55576B"/>
                 </a:solidFill>
-                <a:latin typeface="Calibri"/>
+                <a:latin typeface="Calibri" panose="020F0502020204030204"/>
               </a:rPr>
               <a:t>FLOOR — simple, fast, interpretable; the currently deployed path.</a:t>
             </a:r>
+            <a:endParaRPr sz="1200" b="0" i="0">
+              <a:solidFill>
+                <a:srgbClr val="55576B"/>
+              </a:solidFill>
+              <a:latin typeface="Calibri" panose="020F0502020204030204"/>
+            </a:endParaRPr>
           </a:p>
         </p:txBody>
       </p:sp>
@@ -9351,10 +9898,16 @@
                 <a:solidFill>
                   <a:srgbClr val="1A9988"/>
                 </a:solidFill>
-                <a:latin typeface="Calibri"/>
+                <a:latin typeface="Calibri" panose="020F0502020204030204"/>
               </a:rPr>
               <a:t>Done · 0.61 acc / 0.60 F1</a:t>
             </a:r>
+            <a:endParaRPr sz="1300" b="1" i="0">
+              <a:solidFill>
+                <a:srgbClr val="1A9988"/>
+              </a:solidFill>
+              <a:latin typeface="Calibri" panose="020F0502020204030204"/>
+            </a:endParaRPr>
           </a:p>
         </p:txBody>
       </p:sp>
@@ -9474,10 +10027,16 @@
                 <a:solidFill>
                   <a:srgbClr val="FFFFFF"/>
                 </a:solidFill>
-                <a:latin typeface="Calibri"/>
+                <a:latin typeface="Calibri" panose="020F0502020204030204"/>
               </a:rPr>
               <a:t>2</a:t>
             </a:r>
+            <a:endParaRPr sz="3000" b="1" i="0">
+              <a:solidFill>
+                <a:srgbClr val="FFFFFF"/>
+              </a:solidFill>
+              <a:latin typeface="Calibri" panose="020F0502020204030204"/>
+            </a:endParaRPr>
           </a:p>
         </p:txBody>
       </p:sp>
@@ -9508,10 +10067,16 @@
                 <a:solidFill>
                   <a:srgbClr val="2B2D42"/>
                 </a:solidFill>
-                <a:latin typeface="Calibri"/>
+                <a:latin typeface="Calibri" panose="020F0502020204030204"/>
               </a:rPr>
               <a:t>FastText cc.rw.300 + MLP   (Kinyarwanda)</a:t>
             </a:r>
+            <a:endParaRPr sz="1600" b="1" i="0">
+              <a:solidFill>
+                <a:srgbClr val="2B2D42"/>
+              </a:solidFill>
+              <a:latin typeface="Calibri" panose="020F0502020204030204"/>
+            </a:endParaRPr>
           </a:p>
           <a:p>
             <a:pPr>
@@ -9524,10 +10089,16 @@
                 <a:solidFill>
                   <a:srgbClr val="55576B"/>
                 </a:solidFill>
-                <a:latin typeface="Calibri"/>
+                <a:latin typeface="Calibri" panose="020F0502020204030204"/>
               </a:rPr>
               <a:t>EMBEDDINGS — dense subword vectors capture meaning + Kinyarwanda morphology / out-of-vocabulary words.</a:t>
             </a:r>
+            <a:endParaRPr sz="1200" b="0" i="0">
+              <a:solidFill>
+                <a:srgbClr val="55576B"/>
+              </a:solidFill>
+              <a:latin typeface="Calibri" panose="020F0502020204030204"/>
+            </a:endParaRPr>
           </a:p>
         </p:txBody>
       </p:sp>
@@ -9539,8 +10110,8 @@
         </p:nvSpPr>
         <p:spPr>
           <a:xfrm>
-            <a:off x="8412480" y="3456432"/>
-            <a:ext cx="3154680" cy="1143000"/>
+            <a:off x="8412480" y="3882200"/>
+            <a:ext cx="3154680" cy="291465"/>
           </a:xfrm>
           <a:prstGeom prst="rect">
             <a:avLst/>
@@ -9555,14 +10126,21 @@
           <a:p>
             <a:pPr algn="ctr"/>
             <a:r>
-              <a:rPr sz="1300" b="1" i="0">
-                <a:solidFill>
-                  <a:srgbClr val="9B8BC4"/>
-                </a:solidFill>
-                <a:latin typeface="Calibri"/>
-              </a:rPr>
-              <a:t>Coded · pending 4.5 GB vectors</a:t>
-            </a:r>
+              <a:rPr lang="en-US" sz="1300" b="1">
+                <a:solidFill>
+                  <a:srgbClr val="E76F51"/>
+                </a:solidFill>
+                <a:latin typeface="Calibri" panose="020F0502020204030204"/>
+                <a:sym typeface="+mn-ea"/>
+              </a:rPr>
+              <a:t>Pending</a:t>
+            </a:r>
+            <a:endParaRPr sz="1300" b="1" i="0">
+              <a:solidFill>
+                <a:srgbClr val="9B8BC4"/>
+              </a:solidFill>
+              <a:latin typeface="Calibri" panose="020F0502020204030204"/>
+            </a:endParaRPr>
           </a:p>
         </p:txBody>
       </p:sp>
@@ -9682,10 +10260,16 @@
                 <a:solidFill>
                   <a:srgbClr val="FFFFFF"/>
                 </a:solidFill>
-                <a:latin typeface="Calibri"/>
+                <a:latin typeface="Calibri" panose="020F0502020204030204"/>
               </a:rPr>
               <a:t>3</a:t>
             </a:r>
+            <a:endParaRPr sz="3000" b="1" i="0">
+              <a:solidFill>
+                <a:srgbClr val="FFFFFF"/>
+              </a:solidFill>
+              <a:latin typeface="Calibri" panose="020F0502020204030204"/>
+            </a:endParaRPr>
           </a:p>
         </p:txBody>
       </p:sp>
@@ -9716,10 +10300,16 @@
                 <a:solidFill>
                   <a:srgbClr val="2B2D42"/>
                 </a:solidFill>
-                <a:latin typeface="Calibri"/>
+                <a:latin typeface="Calibri" panose="020F0502020204030204"/>
               </a:rPr>
               <a:t>AfroXLMR fine-tune   (Kinyarwanda)</a:t>
             </a:r>
+            <a:endParaRPr sz="1600" b="1" i="0">
+              <a:solidFill>
+                <a:srgbClr val="2B2D42"/>
+              </a:solidFill>
+              <a:latin typeface="Calibri" panose="020F0502020204030204"/>
+            </a:endParaRPr>
           </a:p>
           <a:p>
             <a:pPr>
@@ -9732,10 +10322,16 @@
                 <a:solidFill>
                   <a:srgbClr val="55576B"/>
                 </a:solidFill>
-                <a:latin typeface="Calibri"/>
+                <a:latin typeface="Calibri" panose="020F0502020204030204"/>
               </a:rPr>
               <a:t>CEILING — contextual transformer pretrained on Kinyarwanda; classifies directly, no translate-then-classify hop.</a:t>
             </a:r>
+            <a:endParaRPr sz="1200" b="0" i="0">
+              <a:solidFill>
+                <a:srgbClr val="55576B"/>
+              </a:solidFill>
+              <a:latin typeface="Calibri" panose="020F0502020204030204"/>
+            </a:endParaRPr>
           </a:p>
         </p:txBody>
       </p:sp>
@@ -9747,8 +10343,8 @@
         </p:nvSpPr>
         <p:spPr>
           <a:xfrm>
-            <a:off x="8412480" y="4764024"/>
-            <a:ext cx="3154680" cy="1143000"/>
+            <a:off x="8412480" y="5189792"/>
+            <a:ext cx="3154680" cy="291465"/>
           </a:xfrm>
           <a:prstGeom prst="rect">
             <a:avLst/>
@@ -9763,14 +10359,20 @@
           <a:p>
             <a:pPr algn="ctr"/>
             <a:r>
-              <a:rPr sz="1300" b="1" i="0">
+              <a:rPr lang="en-US" sz="1300" b="1" i="0">
                 <a:solidFill>
                   <a:srgbClr val="E76F51"/>
                 </a:solidFill>
-                <a:latin typeface="Calibri"/>
-              </a:rPr>
-              <a:t>Coded · pending GPU run</a:t>
-            </a:r>
+                <a:latin typeface="Calibri" panose="020F0502020204030204"/>
+              </a:rPr>
+              <a:t>Pending</a:t>
+            </a:r>
+            <a:endParaRPr lang="en-US" sz="1300" b="1" i="0">
+              <a:solidFill>
+                <a:srgbClr val="E76F51"/>
+              </a:solidFill>
+              <a:latin typeface="Calibri" panose="020F0502020204030204"/>
+            </a:endParaRPr>
           </a:p>
         </p:txBody>
       </p:sp>
@@ -9845,10 +10447,16 @@
                 <a:solidFill>
                   <a:srgbClr val="FFFFFF"/>
                 </a:solidFill>
-                <a:latin typeface="Calibri"/>
+                <a:latin typeface="Calibri" panose="020F0502020204030204"/>
               </a:rPr>
               <a:t>Umubyeyi  ·  Kinyarwanda Maternal Mental-Wellness Chatbot  ·  R. Irutingabo (ALU)</a:t>
             </a:r>
+            <a:endParaRPr sz="900" b="0" i="0">
+              <a:solidFill>
+                <a:srgbClr val="FFFFFF"/>
+              </a:solidFill>
+              <a:latin typeface="Calibri" panose="020F0502020204030204"/>
+            </a:endParaRPr>
           </a:p>
         </p:txBody>
       </p:sp>
@@ -9880,10 +10488,16 @@
                 <a:solidFill>
                   <a:srgbClr val="FFFFFF"/>
                 </a:solidFill>
-                <a:latin typeface="Calibri"/>
+                <a:latin typeface="Calibri" panose="020F0502020204030204"/>
               </a:rPr>
               <a:t>8</a:t>
             </a:r>
+            <a:endParaRPr sz="900" b="0" i="0">
+              <a:solidFill>
+                <a:srgbClr val="FFFFFF"/>
+              </a:solidFill>
+              <a:latin typeface="Calibri" panose="020F0502020204030204"/>
+            </a:endParaRPr>
           </a:p>
         </p:txBody>
       </p:sp>
@@ -9896,7 +10510,7 @@
 </file>
 
 <file path=ppt/slides/slide9.xml><?xml version="1.0" encoding="utf-8"?>
-<p:sld xmlns:a="http://schemas.openxmlformats.org/drawingml/2006/main" xmlns:p="http://schemas.openxmlformats.org/presentationml/2006/main" xmlns:r="http://schemas.openxmlformats.org/officeDocument/2006/relationships">
+<p:sld xmlns:a="http://schemas.openxmlformats.org/drawingml/2006/main" xmlns:r="http://schemas.openxmlformats.org/officeDocument/2006/relationships" xmlns:p="http://schemas.openxmlformats.org/presentationml/2006/main">
   <p:cSld>
     <p:spTree>
       <p:nvGrpSpPr>
@@ -10020,10 +10634,16 @@
                 <a:solidFill>
                   <a:srgbClr val="E76F51"/>
                 </a:solidFill>
-                <a:latin typeface="Calibri"/>
+                <a:latin typeface="Calibri" panose="020F0502020204030204"/>
               </a:rPr>
               <a:t>RESULTS</a:t>
             </a:r>
+            <a:endParaRPr sz="1200" b="1" i="0">
+              <a:solidFill>
+                <a:srgbClr val="E76F51"/>
+              </a:solidFill>
+              <a:latin typeface="Calibri" panose="020F0502020204030204"/>
+            </a:endParaRPr>
           </a:p>
         </p:txBody>
       </p:sp>
@@ -10036,7 +10656,7 @@
         <p:spPr>
           <a:xfrm>
             <a:off x="457200" y="640080"/>
-            <a:ext cx="11247120" cy="822960"/>
+            <a:ext cx="11247120" cy="553085"/>
           </a:xfrm>
           <a:prstGeom prst="rect">
             <a:avLst/>
@@ -10054,10 +10674,16 @@
                 <a:solidFill>
                   <a:srgbClr val="2B2D42"/>
                 </a:solidFill>
-                <a:latin typeface="Calibri"/>
-              </a:rPr>
-              <a:t>Baseline — the floor model (Model 1)</a:t>
-            </a:r>
+                <a:latin typeface="Calibri" panose="020F0502020204030204"/>
+              </a:rPr>
+              <a:t>Baseline</a:t>
+            </a:r>
+            <a:endParaRPr sz="3000" b="1" i="0">
+              <a:solidFill>
+                <a:srgbClr val="2B2D42"/>
+              </a:solidFill>
+              <a:latin typeface="Calibri" panose="020F0502020204030204"/>
+            </a:endParaRPr>
           </a:p>
         </p:txBody>
       </p:sp>
@@ -10114,7 +10740,7 @@
           <p:nvPr/>
         </p:nvPicPr>
         <p:blipFill>
-          <a:blip r:embed="rId2"/>
+          <a:blip r:embed="rId1"/>
           <a:stretch>
             <a:fillRect/>
           </a:stretch>
@@ -10157,10 +10783,16 @@
                 <a:solidFill>
                   <a:srgbClr val="55576B"/>
                 </a:solidFill>
-                <a:latin typeface="Calibri"/>
+                <a:latin typeface="Calibri" panose="020F0502020204030204"/>
               </a:rPr>
               <a:t>Confusion matrix — TF-IDF + Logistic Regression, 6 intents</a:t>
             </a:r>
+            <a:endParaRPr sz="1000" b="0" i="1">
+              <a:solidFill>
+                <a:srgbClr val="55576B"/>
+              </a:solidFill>
+              <a:latin typeface="Calibri" panose="020F0502020204030204"/>
+            </a:endParaRPr>
           </a:p>
         </p:txBody>
       </p:sp>
@@ -10217,7 +10849,7 @@
         <p:spPr>
           <a:xfrm>
             <a:off x="6903720" y="1965960"/>
-            <a:ext cx="4572000" cy="3886200"/>
+            <a:ext cx="4572000" cy="2922905"/>
           </a:xfrm>
           <a:prstGeom prst="rect">
             <a:avLst/>
@@ -10229,17 +10861,6 @@
             <a:spAutoFit/>
           </a:bodyPr>
           <a:lstStyle/>
-          <a:p>
-            <a:r>
-              <a:rPr sz="1500" b="1" i="0">
-                <a:solidFill>
-                  <a:srgbClr val="E76F51"/>
-                </a:solidFill>
-                <a:latin typeface="Calibri"/>
-              </a:rPr>
-              <a:t>Floor model — established</a:t>
-            </a:r>
-          </a:p>
           <a:p>
             <a:pPr>
               <a:spcBef>
@@ -10251,7 +10872,7 @@
                 <a:solidFill>
                   <a:srgbClr val="2B2D42"/>
                 </a:solidFill>
-                <a:latin typeface="Calibri"/>
+                <a:latin typeface="Calibri" panose="020F0502020204030204"/>
               </a:rPr>
               <a:t>Accuracy:  </a:t>
             </a:r>
@@ -10260,10 +10881,16 @@
                 <a:solidFill>
                   <a:srgbClr val="1A9988"/>
                 </a:solidFill>
-                <a:latin typeface="Calibri"/>
+                <a:latin typeface="Calibri" panose="020F0502020204030204"/>
               </a:rPr>
               <a:t>0.61</a:t>
             </a:r>
+            <a:endParaRPr sz="1400" b="1" i="0">
+              <a:solidFill>
+                <a:srgbClr val="1A9988"/>
+              </a:solidFill>
+              <a:latin typeface="Calibri" panose="020F0502020204030204"/>
+            </a:endParaRPr>
           </a:p>
           <a:p>
             <a:pPr>
@@ -10276,7 +10903,7 @@
                 <a:solidFill>
                   <a:srgbClr val="2B2D42"/>
                 </a:solidFill>
-                <a:latin typeface="Calibri"/>
+                <a:latin typeface="Calibri" panose="020F0502020204030204"/>
               </a:rPr>
               <a:t>F1:  </a:t>
             </a:r>
@@ -10285,10 +10912,16 @@
                 <a:solidFill>
                   <a:srgbClr val="1A9988"/>
                 </a:solidFill>
-                <a:latin typeface="Calibri"/>
+                <a:latin typeface="Calibri" panose="020F0502020204030204"/>
               </a:rPr>
               <a:t>0.60</a:t>
             </a:r>
+            <a:endParaRPr sz="1400" b="1" i="0">
+              <a:solidFill>
+                <a:srgbClr val="1A9988"/>
+              </a:solidFill>
+              <a:latin typeface="Calibri" panose="020F0502020204030204"/>
+            </a:endParaRPr>
           </a:p>
           <a:p>
             <a:pPr>
@@ -10301,7 +10934,7 @@
                 <a:solidFill>
                   <a:srgbClr val="2B2D42"/>
                 </a:solidFill>
-                <a:latin typeface="Calibri"/>
+                <a:latin typeface="Calibri" panose="020F0502020204030204"/>
               </a:rPr>
               <a:t>Precision:  </a:t>
             </a:r>
@@ -10310,10 +10943,16 @@
                 <a:solidFill>
                   <a:srgbClr val="1A9988"/>
                 </a:solidFill>
-                <a:latin typeface="Calibri"/>
+                <a:latin typeface="Calibri" panose="020F0502020204030204"/>
               </a:rPr>
               <a:t>0.63</a:t>
             </a:r>
+            <a:endParaRPr sz="1400" b="1" i="0">
+              <a:solidFill>
+                <a:srgbClr val="1A9988"/>
+              </a:solidFill>
+              <a:latin typeface="Calibri" panose="020F0502020204030204"/>
+            </a:endParaRPr>
           </a:p>
           <a:p>
             <a:pPr>
@@ -10326,7 +10965,7 @@
                 <a:solidFill>
                   <a:srgbClr val="2B2D42"/>
                 </a:solidFill>
-                <a:latin typeface="Calibri"/>
+                <a:latin typeface="Calibri" panose="020F0502020204030204"/>
               </a:rPr>
               <a:t>Recall:  </a:t>
             </a:r>
@@ -10335,10 +10974,16 @@
                 <a:solidFill>
                   <a:srgbClr val="1A9988"/>
                 </a:solidFill>
-                <a:latin typeface="Calibri"/>
+                <a:latin typeface="Calibri" panose="020F0502020204030204"/>
               </a:rPr>
               <a:t>0.59</a:t>
             </a:r>
+            <a:endParaRPr sz="1400" b="1" i="0">
+              <a:solidFill>
+                <a:srgbClr val="1A9988"/>
+              </a:solidFill>
+              <a:latin typeface="Calibri" panose="020F0502020204030204"/>
+            </a:endParaRPr>
           </a:p>
           <a:p>
             <a:pPr>
@@ -10351,10 +10996,16 @@
                 <a:solidFill>
                   <a:srgbClr val="E76F51"/>
                 </a:solidFill>
-                <a:latin typeface="Calibri"/>
+                <a:latin typeface="Calibri" panose="020F0502020204030204"/>
               </a:rPr>
               <a:t>Reading the matrix</a:t>
             </a:r>
+            <a:endParaRPr sz="1300" b="1" i="0">
+              <a:solidFill>
+                <a:srgbClr val="E76F51"/>
+              </a:solidFill>
+              <a:latin typeface="Calibri" panose="020F0502020204030204"/>
+            </a:endParaRPr>
           </a:p>
           <a:p>
             <a:pPr>
@@ -10367,10 +11018,16 @@
                 <a:solidFill>
                   <a:srgbClr val="55576B"/>
                 </a:solidFill>
-                <a:latin typeface="Calibri"/>
+                <a:latin typeface="Calibri" panose="020F0502020204030204"/>
               </a:rPr>
               <a:t>•  Strong on relationship/support &amp; sleep (clear cues).</a:t>
             </a:r>
+            <a:endParaRPr sz="1200" b="0" i="0">
+              <a:solidFill>
+                <a:srgbClr val="55576B"/>
+              </a:solidFill>
+              <a:latin typeface="Calibri" panose="020F0502020204030204"/>
+            </a:endParaRPr>
           </a:p>
           <a:p>
             <a:pPr>
@@ -10383,10 +11040,16 @@
                 <a:solidFill>
                   <a:srgbClr val="55576B"/>
                 </a:solidFill>
-                <a:latin typeface="Calibri"/>
+                <a:latin typeface="Calibri" panose="020F0502020204030204"/>
               </a:rPr>
               <a:t>•  Confusion: overwhelmed ↔ relationship &amp; sadness — overlapping language, the hard intents.</a:t>
             </a:r>
+            <a:endParaRPr sz="1200" b="0" i="0">
+              <a:solidFill>
+                <a:srgbClr val="55576B"/>
+              </a:solidFill>
+              <a:latin typeface="Calibri" panose="020F0502020204030204"/>
+            </a:endParaRPr>
           </a:p>
           <a:p>
             <a:pPr>
@@ -10399,10 +11062,16 @@
                 <a:solidFill>
                   <a:srgbClr val="55576B"/>
                 </a:solidFill>
-                <a:latin typeface="Calibri"/>
+                <a:latin typeface="Calibri" panose="020F0502020204030204"/>
               </a:rPr>
               <a:t>•  F1 &lt; accuracy → the minority intents are where the work is.</a:t>
             </a:r>
+            <a:endParaRPr sz="1200" b="0" i="0">
+              <a:solidFill>
+                <a:srgbClr val="55576B"/>
+              </a:solidFill>
+              <a:latin typeface="Calibri" panose="020F0502020204030204"/>
+            </a:endParaRPr>
           </a:p>
           <a:p>
             <a:pPr>
@@ -10415,10 +11084,16 @@
                 <a:solidFill>
                   <a:srgbClr val="55576B"/>
                 </a:solidFill>
-                <a:latin typeface="Calibri"/>
+                <a:latin typeface="Calibri" panose="020F0502020204030204"/>
               </a:rPr>
               <a:t>Honest INITIAL baseline. Models 2 &amp; 3 (FastText, AfroXLMR) are coded and pending compute.</a:t>
             </a:r>
+            <a:endParaRPr sz="1100" b="0" i="1">
+              <a:solidFill>
+                <a:srgbClr val="55576B"/>
+              </a:solidFill>
+              <a:latin typeface="Calibri" panose="020F0502020204030204"/>
+            </a:endParaRPr>
           </a:p>
         </p:txBody>
       </p:sp>
@@ -10493,10 +11168,16 @@
                 <a:solidFill>
                   <a:srgbClr val="FFFFFF"/>
                 </a:solidFill>
-                <a:latin typeface="Calibri"/>
+                <a:latin typeface="Calibri" panose="020F0502020204030204"/>
               </a:rPr>
               <a:t>Umubyeyi  ·  Kinyarwanda Maternal Mental-Wellness Chatbot  ·  R. Irutingabo (ALU)</a:t>
             </a:r>
+            <a:endParaRPr sz="900" b="0" i="0">
+              <a:solidFill>
+                <a:srgbClr val="FFFFFF"/>
+              </a:solidFill>
+              <a:latin typeface="Calibri" panose="020F0502020204030204"/>
+            </a:endParaRPr>
           </a:p>
         </p:txBody>
       </p:sp>
@@ -10528,10 +11209,16 @@
                 <a:solidFill>
                   <a:srgbClr val="FFFFFF"/>
                 </a:solidFill>
-                <a:latin typeface="Calibri"/>
+                <a:latin typeface="Calibri" panose="020F0502020204030204"/>
               </a:rPr>
               <a:t>9</a:t>
             </a:r>
+            <a:endParaRPr sz="900" b="0" i="0">
+              <a:solidFill>
+                <a:srgbClr val="FFFFFF"/>
+              </a:solidFill>
+              <a:latin typeface="Calibri" panose="020F0502020204030204"/>
+            </a:endParaRPr>
           </a:p>
         </p:txBody>
       </p:sp>
@@ -10859,6 +11546,10 @@
       </a:style>
     </a:lnDef>
   </a:objectDefaults>
-  <a:extraClrSchemeLst/>
+  <a:extLst>
+    <a:ext uri="{05A4C25C-085E-4340-85A3-A5531E510DB2}">
+      <thm15:themeFamily xmlns:thm15="http://schemas.microsoft.com/office/thememl/2012/main" name="Office Theme" id="{62F939B6-93AF-4DB8-9C6B-D6C7DFDC589F}" vid="{4A3C46E8-61CC-4603-A589-7422A47A8E4A}"/>
+    </a:ext>
+  </a:extLst>
 </a:theme>
 </file>
</xml_diff>

<commit_message>
Remove MOTHER dataset from project: delete data files, scrub references from README/slides/SOURCES; regenerate deck (2 data sources)
</commit_message>
<xml_diff>
--- a/docs/Umubyeyi_Presentation.pptx
+++ b/docs/Umubyeyi_Presentation.pptx
@@ -1,25 +1,25 @@
 
 <file path=ppt/presentation.xml><?xml version="1.0" encoding="utf-8"?>
-<p:presentation xmlns:a="http://schemas.openxmlformats.org/drawingml/2006/main" xmlns:r="http://schemas.openxmlformats.org/officeDocument/2006/relationships" xmlns:p="http://schemas.openxmlformats.org/presentationml/2006/main" autoCompressPictures="0">
+<p:presentation xmlns:a="http://schemas.openxmlformats.org/drawingml/2006/main" xmlns:r="http://schemas.openxmlformats.org/officeDocument/2006/relationships" xmlns:p="http://schemas.openxmlformats.org/presentationml/2006/main" saveSubsetFonts="1" autoCompressPictures="0">
   <p:sldMasterIdLst>
     <p:sldMasterId id="2147483648" r:id="rId1"/>
   </p:sldMasterIdLst>
   <p:sldIdLst>
-    <p:sldId id="256" r:id="rId3"/>
-    <p:sldId id="257" r:id="rId4"/>
-    <p:sldId id="258" r:id="rId5"/>
-    <p:sldId id="259" r:id="rId6"/>
-    <p:sldId id="260" r:id="rId7"/>
-    <p:sldId id="261" r:id="rId8"/>
-    <p:sldId id="262" r:id="rId9"/>
-    <p:sldId id="263" r:id="rId10"/>
-    <p:sldId id="264" r:id="rId11"/>
-    <p:sldId id="265" r:id="rId12"/>
-    <p:sldId id="266" r:id="rId13"/>
-    <p:sldId id="267" r:id="rId14"/>
-    <p:sldId id="268" r:id="rId15"/>
+    <p:sldId id="256" r:id="rId7"/>
+    <p:sldId id="257" r:id="rId8"/>
+    <p:sldId id="258" r:id="rId9"/>
+    <p:sldId id="259" r:id="rId10"/>
+    <p:sldId id="260" r:id="rId11"/>
+    <p:sldId id="261" r:id="rId12"/>
+    <p:sldId id="262" r:id="rId13"/>
+    <p:sldId id="263" r:id="rId14"/>
+    <p:sldId id="264" r:id="rId15"/>
+    <p:sldId id="265" r:id="rId16"/>
+    <p:sldId id="266" r:id="rId17"/>
+    <p:sldId id="267" r:id="rId18"/>
+    <p:sldId id="268" r:id="rId19"/>
   </p:sldIdLst>
-  <p:sldSz cx="12191365" cy="6858000" type="screen4x3"/>
+  <p:sldSz cx="12191695" cy="6858000" type="screen4x3"/>
   <p:notesSz cx="6858000" cy="9144000"/>
   <p:defaultTextStyle>
     <a:defPPr>
@@ -116,22 +116,6 @@
       </a:defRPr>
     </a:lvl9pPr>
   </p:defaultTextStyle>
-  <p:extLst>
-    <p:ext uri="{EFAFB233-063F-42B5-8137-9DF3F51BA10A}">
-      <p15:sldGuideLst xmlns:p15="http://schemas.microsoft.com/office/powerpoint/2012/main">
-        <p15:guide id="1" orient="horz" pos="2160" userDrawn="1">
-          <p15:clr>
-            <a:srgbClr val="A4A3A4"/>
-          </p15:clr>
-        </p15:guide>
-        <p15:guide id="2" pos="2880" userDrawn="1">
-          <p15:clr>
-            <a:srgbClr val="A4A3A4"/>
-          </p15:clr>
-        </p15:guide>
-      </p15:sldGuideLst>
-    </p:ext>
-  </p:extLst>
 </p:presentation>
 </file>
 
@@ -316,6 +300,7 @@
           <a:p>
             <a:fld id="{5BCAD085-E8A6-8845-BD4E-CB4CCA059FC4}" type="datetimeFigureOut">
               <a:rPr lang="en-US" smtClean="0"/>
+              <a:t>1/27/13</a:t>
             </a:fld>
             <a:endParaRPr lang="en-US"/>
           </a:p>
@@ -357,12 +342,18 @@
           <a:p>
             <a:fld id="{C1FF6DA9-008F-8B48-92A6-B652298478BF}" type="slidenum">
               <a:rPr lang="en-US" smtClean="0"/>
+              <a:t>‹#›</a:t>
             </a:fld>
             <a:endParaRPr lang="en-US"/>
           </a:p>
         </p:txBody>
       </p:sp>
     </p:spTree>
+    <p:extLst>
+      <p:ext uri="{BB962C8B-B14F-4D97-AF65-F5344CB8AC3E}">
+        <p14:creationId xmlns:p14="http://schemas.microsoft.com/office/powerpoint/2010/main" val="3168075583"/>
+      </p:ext>
+    </p:extLst>
   </p:cSld>
   <p:clrMapOvr>
     <a:masterClrMapping/>
@@ -430,7 +421,6 @@
               <a:rPr lang="en-US" smtClean="0"/>
               <a:t>Click to edit Master text styles</a:t>
             </a:r>
-            <a:endParaRPr lang="en-US" smtClean="0"/>
           </a:p>
           <a:p>
             <a:pPr lvl="1"/>
@@ -438,7 +428,6 @@
               <a:rPr lang="en-US" smtClean="0"/>
               <a:t>Second level</a:t>
             </a:r>
-            <a:endParaRPr lang="en-US" smtClean="0"/>
           </a:p>
           <a:p>
             <a:pPr lvl="2"/>
@@ -446,7 +435,6 @@
               <a:rPr lang="en-US" smtClean="0"/>
               <a:t>Third level</a:t>
             </a:r>
-            <a:endParaRPr lang="en-US" smtClean="0"/>
           </a:p>
           <a:p>
             <a:pPr lvl="3"/>
@@ -454,7 +442,6 @@
               <a:rPr lang="en-US" smtClean="0"/>
               <a:t>Fourth level</a:t>
             </a:r>
-            <a:endParaRPr lang="en-US" smtClean="0"/>
           </a:p>
           <a:p>
             <a:pPr lvl="4"/>
@@ -483,6 +470,7 @@
           <a:p>
             <a:fld id="{5BCAD085-E8A6-8845-BD4E-CB4CCA059FC4}" type="datetimeFigureOut">
               <a:rPr lang="en-US" smtClean="0"/>
+              <a:t>1/27/13</a:t>
             </a:fld>
             <a:endParaRPr lang="en-US"/>
           </a:p>
@@ -524,12 +512,18 @@
           <a:p>
             <a:fld id="{C1FF6DA9-008F-8B48-92A6-B652298478BF}" type="slidenum">
               <a:rPr lang="en-US" smtClean="0"/>
+              <a:t>‹#›</a:t>
             </a:fld>
             <a:endParaRPr lang="en-US"/>
           </a:p>
         </p:txBody>
       </p:sp>
     </p:spTree>
+    <p:extLst>
+      <p:ext uri="{BB962C8B-B14F-4D97-AF65-F5344CB8AC3E}">
+        <p14:creationId xmlns:p14="http://schemas.microsoft.com/office/powerpoint/2010/main" val="2910927964"/>
+      </p:ext>
+    </p:extLst>
   </p:cSld>
   <p:clrMapOvr>
     <a:masterClrMapping/>
@@ -607,7 +601,6 @@
               <a:rPr lang="en-US" smtClean="0"/>
               <a:t>Click to edit Master text styles</a:t>
             </a:r>
-            <a:endParaRPr lang="en-US" smtClean="0"/>
           </a:p>
           <a:p>
             <a:pPr lvl="1"/>
@@ -615,7 +608,6 @@
               <a:rPr lang="en-US" smtClean="0"/>
               <a:t>Second level</a:t>
             </a:r>
-            <a:endParaRPr lang="en-US" smtClean="0"/>
           </a:p>
           <a:p>
             <a:pPr lvl="2"/>
@@ -623,7 +615,6 @@
               <a:rPr lang="en-US" smtClean="0"/>
               <a:t>Third level</a:t>
             </a:r>
-            <a:endParaRPr lang="en-US" smtClean="0"/>
           </a:p>
           <a:p>
             <a:pPr lvl="3"/>
@@ -631,7 +622,6 @@
               <a:rPr lang="en-US" smtClean="0"/>
               <a:t>Fourth level</a:t>
             </a:r>
-            <a:endParaRPr lang="en-US" smtClean="0"/>
           </a:p>
           <a:p>
             <a:pPr lvl="4"/>
@@ -660,6 +650,7 @@
           <a:p>
             <a:fld id="{5BCAD085-E8A6-8845-BD4E-CB4CCA059FC4}" type="datetimeFigureOut">
               <a:rPr lang="en-US" smtClean="0"/>
+              <a:t>1/27/13</a:t>
             </a:fld>
             <a:endParaRPr lang="en-US"/>
           </a:p>
@@ -701,12 +692,18 @@
           <a:p>
             <a:fld id="{C1FF6DA9-008F-8B48-92A6-B652298478BF}" type="slidenum">
               <a:rPr lang="en-US" smtClean="0"/>
+              <a:t>‹#›</a:t>
             </a:fld>
             <a:endParaRPr lang="en-US"/>
           </a:p>
         </p:txBody>
       </p:sp>
     </p:spTree>
+    <p:extLst>
+      <p:ext uri="{BB962C8B-B14F-4D97-AF65-F5344CB8AC3E}">
+        <p14:creationId xmlns:p14="http://schemas.microsoft.com/office/powerpoint/2010/main" val="3612223792"/>
+      </p:ext>
+    </p:extLst>
   </p:cSld>
   <p:clrMapOvr>
     <a:masterClrMapping/>
@@ -774,7 +771,6 @@
               <a:rPr lang="en-US" smtClean="0"/>
               <a:t>Click to edit Master text styles</a:t>
             </a:r>
-            <a:endParaRPr lang="en-US" smtClean="0"/>
           </a:p>
           <a:p>
             <a:pPr lvl="1"/>
@@ -782,7 +778,6 @@
               <a:rPr lang="en-US" smtClean="0"/>
               <a:t>Second level</a:t>
             </a:r>
-            <a:endParaRPr lang="en-US" smtClean="0"/>
           </a:p>
           <a:p>
             <a:pPr lvl="2"/>
@@ -790,7 +785,6 @@
               <a:rPr lang="en-US" smtClean="0"/>
               <a:t>Third level</a:t>
             </a:r>
-            <a:endParaRPr lang="en-US" smtClean="0"/>
           </a:p>
           <a:p>
             <a:pPr lvl="3"/>
@@ -798,7 +792,6 @@
               <a:rPr lang="en-US" smtClean="0"/>
               <a:t>Fourth level</a:t>
             </a:r>
-            <a:endParaRPr lang="en-US" smtClean="0"/>
           </a:p>
           <a:p>
             <a:pPr lvl="4"/>
@@ -827,6 +820,7 @@
           <a:p>
             <a:fld id="{5BCAD085-E8A6-8845-BD4E-CB4CCA059FC4}" type="datetimeFigureOut">
               <a:rPr lang="en-US" smtClean="0"/>
+              <a:t>1/27/13</a:t>
             </a:fld>
             <a:endParaRPr lang="en-US"/>
           </a:p>
@@ -868,12 +862,18 @@
           <a:p>
             <a:fld id="{C1FF6DA9-008F-8B48-92A6-B652298478BF}" type="slidenum">
               <a:rPr lang="en-US" smtClean="0"/>
+              <a:t>‹#›</a:t>
             </a:fld>
             <a:endParaRPr lang="en-US"/>
           </a:p>
         </p:txBody>
       </p:sp>
     </p:spTree>
+    <p:extLst>
+      <p:ext uri="{BB962C8B-B14F-4D97-AF65-F5344CB8AC3E}">
+        <p14:creationId xmlns:p14="http://schemas.microsoft.com/office/powerpoint/2010/main" val="2614314258"/>
+      </p:ext>
+    </p:extLst>
   </p:cSld>
   <p:clrMapOvr>
     <a:masterClrMapping/>
@@ -1046,7 +1046,6 @@
               <a:rPr lang="en-US" smtClean="0"/>
               <a:t>Click to edit Master text styles</a:t>
             </a:r>
-            <a:endParaRPr lang="en-US" smtClean="0"/>
           </a:p>
         </p:txBody>
       </p:sp>
@@ -1067,6 +1066,7 @@
           <a:p>
             <a:fld id="{5BCAD085-E8A6-8845-BD4E-CB4CCA059FC4}" type="datetimeFigureOut">
               <a:rPr lang="en-US" smtClean="0"/>
+              <a:t>1/27/13</a:t>
             </a:fld>
             <a:endParaRPr lang="en-US"/>
           </a:p>
@@ -1108,12 +1108,18 @@
           <a:p>
             <a:fld id="{C1FF6DA9-008F-8B48-92A6-B652298478BF}" type="slidenum">
               <a:rPr lang="en-US" smtClean="0"/>
+              <a:t>‹#›</a:t>
             </a:fld>
             <a:endParaRPr lang="en-US"/>
           </a:p>
         </p:txBody>
       </p:sp>
     </p:spTree>
+    <p:extLst>
+      <p:ext uri="{BB962C8B-B14F-4D97-AF65-F5344CB8AC3E}">
+        <p14:creationId xmlns:p14="http://schemas.microsoft.com/office/powerpoint/2010/main" val="960648375"/>
+      </p:ext>
+    </p:extLst>
   </p:cSld>
   <p:clrMapOvr>
     <a:masterClrMapping/>
@@ -1214,7 +1220,6 @@
               <a:rPr lang="en-US" smtClean="0"/>
               <a:t>Click to edit Master text styles</a:t>
             </a:r>
-            <a:endParaRPr lang="en-US" smtClean="0"/>
           </a:p>
           <a:p>
             <a:pPr lvl="1"/>
@@ -1222,7 +1227,6 @@
               <a:rPr lang="en-US" smtClean="0"/>
               <a:t>Second level</a:t>
             </a:r>
-            <a:endParaRPr lang="en-US" smtClean="0"/>
           </a:p>
           <a:p>
             <a:pPr lvl="2"/>
@@ -1230,7 +1234,6 @@
               <a:rPr lang="en-US" smtClean="0"/>
               <a:t>Third level</a:t>
             </a:r>
-            <a:endParaRPr lang="en-US" smtClean="0"/>
           </a:p>
           <a:p>
             <a:pPr lvl="3"/>
@@ -1238,7 +1241,6 @@
               <a:rPr lang="en-US" smtClean="0"/>
               <a:t>Fourth level</a:t>
             </a:r>
-            <a:endParaRPr lang="en-US" smtClean="0"/>
           </a:p>
           <a:p>
             <a:pPr lvl="4"/>
@@ -1303,7 +1305,6 @@
               <a:rPr lang="en-US" smtClean="0"/>
               <a:t>Click to edit Master text styles</a:t>
             </a:r>
-            <a:endParaRPr lang="en-US" smtClean="0"/>
           </a:p>
           <a:p>
             <a:pPr lvl="1"/>
@@ -1311,7 +1312,6 @@
               <a:rPr lang="en-US" smtClean="0"/>
               <a:t>Second level</a:t>
             </a:r>
-            <a:endParaRPr lang="en-US" smtClean="0"/>
           </a:p>
           <a:p>
             <a:pPr lvl="2"/>
@@ -1319,7 +1319,6 @@
               <a:rPr lang="en-US" smtClean="0"/>
               <a:t>Third level</a:t>
             </a:r>
-            <a:endParaRPr lang="en-US" smtClean="0"/>
           </a:p>
           <a:p>
             <a:pPr lvl="3"/>
@@ -1327,7 +1326,6 @@
               <a:rPr lang="en-US" smtClean="0"/>
               <a:t>Fourth level</a:t>
             </a:r>
-            <a:endParaRPr lang="en-US" smtClean="0"/>
           </a:p>
           <a:p>
             <a:pPr lvl="4"/>
@@ -1356,6 +1354,7 @@
           <a:p>
             <a:fld id="{5BCAD085-E8A6-8845-BD4E-CB4CCA059FC4}" type="datetimeFigureOut">
               <a:rPr lang="en-US" smtClean="0"/>
+              <a:t>1/27/13</a:t>
             </a:fld>
             <a:endParaRPr lang="en-US"/>
           </a:p>
@@ -1397,12 +1396,18 @@
           <a:p>
             <a:fld id="{C1FF6DA9-008F-8B48-92A6-B652298478BF}" type="slidenum">
               <a:rPr lang="en-US" smtClean="0"/>
+              <a:t>‹#›</a:t>
             </a:fld>
             <a:endParaRPr lang="en-US"/>
           </a:p>
         </p:txBody>
       </p:sp>
     </p:spTree>
+    <p:extLst>
+      <p:ext uri="{BB962C8B-B14F-4D97-AF65-F5344CB8AC3E}">
+        <p14:creationId xmlns:p14="http://schemas.microsoft.com/office/powerpoint/2010/main" val="2782244947"/>
+      </p:ext>
+    </p:extLst>
   </p:cSld>
   <p:clrMapOvr>
     <a:masterClrMapping/>
@@ -1516,7 +1521,6 @@
               <a:rPr lang="en-US" smtClean="0"/>
               <a:t>Click to edit Master text styles</a:t>
             </a:r>
-            <a:endParaRPr lang="en-US" smtClean="0"/>
           </a:p>
         </p:txBody>
       </p:sp>
@@ -1573,7 +1577,6 @@
               <a:rPr lang="en-US" smtClean="0"/>
               <a:t>Click to edit Master text styles</a:t>
             </a:r>
-            <a:endParaRPr lang="en-US" smtClean="0"/>
           </a:p>
           <a:p>
             <a:pPr lvl="1"/>
@@ -1581,7 +1584,6 @@
               <a:rPr lang="en-US" smtClean="0"/>
               <a:t>Second level</a:t>
             </a:r>
-            <a:endParaRPr lang="en-US" smtClean="0"/>
           </a:p>
           <a:p>
             <a:pPr lvl="2"/>
@@ -1589,7 +1591,6 @@
               <a:rPr lang="en-US" smtClean="0"/>
               <a:t>Third level</a:t>
             </a:r>
-            <a:endParaRPr lang="en-US" smtClean="0"/>
           </a:p>
           <a:p>
             <a:pPr lvl="3"/>
@@ -1597,7 +1598,6 @@
               <a:rPr lang="en-US" smtClean="0"/>
               <a:t>Fourth level</a:t>
             </a:r>
-            <a:endParaRPr lang="en-US" smtClean="0"/>
           </a:p>
           <a:p>
             <a:pPr lvl="4"/>
@@ -1671,7 +1671,6 @@
               <a:rPr lang="en-US" smtClean="0"/>
               <a:t>Click to edit Master text styles</a:t>
             </a:r>
-            <a:endParaRPr lang="en-US" smtClean="0"/>
           </a:p>
         </p:txBody>
       </p:sp>
@@ -1728,7 +1727,6 @@
               <a:rPr lang="en-US" smtClean="0"/>
               <a:t>Click to edit Master text styles</a:t>
             </a:r>
-            <a:endParaRPr lang="en-US" smtClean="0"/>
           </a:p>
           <a:p>
             <a:pPr lvl="1"/>
@@ -1736,7 +1734,6 @@
               <a:rPr lang="en-US" smtClean="0"/>
               <a:t>Second level</a:t>
             </a:r>
-            <a:endParaRPr lang="en-US" smtClean="0"/>
           </a:p>
           <a:p>
             <a:pPr lvl="2"/>
@@ -1744,7 +1741,6 @@
               <a:rPr lang="en-US" smtClean="0"/>
               <a:t>Third level</a:t>
             </a:r>
-            <a:endParaRPr lang="en-US" smtClean="0"/>
           </a:p>
           <a:p>
             <a:pPr lvl="3"/>
@@ -1752,7 +1748,6 @@
               <a:rPr lang="en-US" smtClean="0"/>
               <a:t>Fourth level</a:t>
             </a:r>
-            <a:endParaRPr lang="en-US" smtClean="0"/>
           </a:p>
           <a:p>
             <a:pPr lvl="4"/>
@@ -1781,6 +1776,7 @@
           <a:p>
             <a:fld id="{5BCAD085-E8A6-8845-BD4E-CB4CCA059FC4}" type="datetimeFigureOut">
               <a:rPr lang="en-US" smtClean="0"/>
+              <a:t>1/27/13</a:t>
             </a:fld>
             <a:endParaRPr lang="en-US"/>
           </a:p>
@@ -1822,12 +1818,18 @@
           <a:p>
             <a:fld id="{C1FF6DA9-008F-8B48-92A6-B652298478BF}" type="slidenum">
               <a:rPr lang="en-US" smtClean="0"/>
+              <a:t>‹#›</a:t>
             </a:fld>
             <a:endParaRPr lang="en-US"/>
           </a:p>
         </p:txBody>
       </p:sp>
     </p:spTree>
+    <p:extLst>
+      <p:ext uri="{BB962C8B-B14F-4D97-AF65-F5344CB8AC3E}">
+        <p14:creationId xmlns:p14="http://schemas.microsoft.com/office/powerpoint/2010/main" val="990158736"/>
+      </p:ext>
+    </p:extLst>
   </p:cSld>
   <p:clrMapOvr>
     <a:masterClrMapping/>
@@ -1892,6 +1894,7 @@
           <a:p>
             <a:fld id="{5BCAD085-E8A6-8845-BD4E-CB4CCA059FC4}" type="datetimeFigureOut">
               <a:rPr lang="en-US" smtClean="0"/>
+              <a:t>1/27/13</a:t>
             </a:fld>
             <a:endParaRPr lang="en-US"/>
           </a:p>
@@ -1933,12 +1936,18 @@
           <a:p>
             <a:fld id="{C1FF6DA9-008F-8B48-92A6-B652298478BF}" type="slidenum">
               <a:rPr lang="en-US" smtClean="0"/>
+              <a:t>‹#›</a:t>
             </a:fld>
             <a:endParaRPr lang="en-US"/>
           </a:p>
         </p:txBody>
       </p:sp>
     </p:spTree>
+    <p:extLst>
+      <p:ext uri="{BB962C8B-B14F-4D97-AF65-F5344CB8AC3E}">
+        <p14:creationId xmlns:p14="http://schemas.microsoft.com/office/powerpoint/2010/main" val="727027711"/>
+      </p:ext>
+    </p:extLst>
   </p:cSld>
   <p:clrMapOvr>
     <a:masterClrMapping/>
@@ -1980,6 +1989,7 @@
           <a:p>
             <a:fld id="{5BCAD085-E8A6-8845-BD4E-CB4CCA059FC4}" type="datetimeFigureOut">
               <a:rPr lang="en-US" smtClean="0"/>
+              <a:t>1/27/13</a:t>
             </a:fld>
             <a:endParaRPr lang="en-US"/>
           </a:p>
@@ -2021,12 +2031,18 @@
           <a:p>
             <a:fld id="{C1FF6DA9-008F-8B48-92A6-B652298478BF}" type="slidenum">
               <a:rPr lang="en-US" smtClean="0"/>
+              <a:t>‹#›</a:t>
             </a:fld>
             <a:endParaRPr lang="en-US"/>
           </a:p>
         </p:txBody>
       </p:sp>
     </p:spTree>
+    <p:extLst>
+      <p:ext uri="{BB962C8B-B14F-4D97-AF65-F5344CB8AC3E}">
+        <p14:creationId xmlns:p14="http://schemas.microsoft.com/office/powerpoint/2010/main" val="1212999818"/>
+      </p:ext>
+    </p:extLst>
   </p:cSld>
   <p:clrMapOvr>
     <a:masterClrMapping/>
@@ -2136,7 +2152,6 @@
               <a:rPr lang="en-US" smtClean="0"/>
               <a:t>Click to edit Master text styles</a:t>
             </a:r>
-            <a:endParaRPr lang="en-US" smtClean="0"/>
           </a:p>
           <a:p>
             <a:pPr lvl="1"/>
@@ -2144,7 +2159,6 @@
               <a:rPr lang="en-US" smtClean="0"/>
               <a:t>Second level</a:t>
             </a:r>
-            <a:endParaRPr lang="en-US" smtClean="0"/>
           </a:p>
           <a:p>
             <a:pPr lvl="2"/>
@@ -2152,7 +2166,6 @@
               <a:rPr lang="en-US" smtClean="0"/>
               <a:t>Third level</a:t>
             </a:r>
-            <a:endParaRPr lang="en-US" smtClean="0"/>
           </a:p>
           <a:p>
             <a:pPr lvl="3"/>
@@ -2160,7 +2173,6 @@
               <a:rPr lang="en-US" smtClean="0"/>
               <a:t>Fourth level</a:t>
             </a:r>
-            <a:endParaRPr lang="en-US" smtClean="0"/>
           </a:p>
           <a:p>
             <a:pPr lvl="4"/>
@@ -2234,7 +2246,6 @@
               <a:rPr lang="en-US" smtClean="0"/>
               <a:t>Click to edit Master text styles</a:t>
             </a:r>
-            <a:endParaRPr lang="en-US" smtClean="0"/>
           </a:p>
         </p:txBody>
       </p:sp>
@@ -2255,6 +2266,7 @@
           <a:p>
             <a:fld id="{5BCAD085-E8A6-8845-BD4E-CB4CCA059FC4}" type="datetimeFigureOut">
               <a:rPr lang="en-US" smtClean="0"/>
+              <a:t>1/27/13</a:t>
             </a:fld>
             <a:endParaRPr lang="en-US"/>
           </a:p>
@@ -2296,12 +2308,18 @@
           <a:p>
             <a:fld id="{C1FF6DA9-008F-8B48-92A6-B652298478BF}" type="slidenum">
               <a:rPr lang="en-US" smtClean="0"/>
+              <a:t>‹#›</a:t>
             </a:fld>
             <a:endParaRPr lang="en-US"/>
           </a:p>
         </p:txBody>
       </p:sp>
     </p:spTree>
+    <p:extLst>
+      <p:ext uri="{BB962C8B-B14F-4D97-AF65-F5344CB8AC3E}">
+        <p14:creationId xmlns:p14="http://schemas.microsoft.com/office/powerpoint/2010/main" val="1840726560"/>
+      </p:ext>
+    </p:extLst>
   </p:cSld>
   <p:clrMapOvr>
     <a:masterClrMapping/>
@@ -2481,7 +2499,6 @@
               <a:rPr lang="en-US" smtClean="0"/>
               <a:t>Click to edit Master text styles</a:t>
             </a:r>
-            <a:endParaRPr lang="en-US" smtClean="0"/>
           </a:p>
         </p:txBody>
       </p:sp>
@@ -2502,6 +2519,7 @@
           <a:p>
             <a:fld id="{5BCAD085-E8A6-8845-BD4E-CB4CCA059FC4}" type="datetimeFigureOut">
               <a:rPr lang="en-US" smtClean="0"/>
+              <a:t>1/27/13</a:t>
             </a:fld>
             <a:endParaRPr lang="en-US"/>
           </a:p>
@@ -2543,12 +2561,18 @@
           <a:p>
             <a:fld id="{C1FF6DA9-008F-8B48-92A6-B652298478BF}" type="slidenum">
               <a:rPr lang="en-US" smtClean="0"/>
+              <a:t>‹#›</a:t>
             </a:fld>
             <a:endParaRPr lang="en-US"/>
           </a:p>
         </p:txBody>
       </p:sp>
     </p:spTree>
+    <p:extLst>
+      <p:ext uri="{BB962C8B-B14F-4D97-AF65-F5344CB8AC3E}">
+        <p14:creationId xmlns:p14="http://schemas.microsoft.com/office/powerpoint/2010/main" val="3889236939"/>
+      </p:ext>
+    </p:extLst>
   </p:cSld>
   <p:clrMapOvr>
     <a:masterClrMapping/>
@@ -2641,7 +2665,6 @@
               <a:rPr lang="en-US" smtClean="0"/>
               <a:t>Click to edit Master text styles</a:t>
             </a:r>
-            <a:endParaRPr lang="en-US" smtClean="0"/>
           </a:p>
           <a:p>
             <a:pPr lvl="1"/>
@@ -2649,7 +2672,6 @@
               <a:rPr lang="en-US" smtClean="0"/>
               <a:t>Second level</a:t>
             </a:r>
-            <a:endParaRPr lang="en-US" smtClean="0"/>
           </a:p>
           <a:p>
             <a:pPr lvl="2"/>
@@ -2657,7 +2679,6 @@
               <a:rPr lang="en-US" smtClean="0"/>
               <a:t>Third level</a:t>
             </a:r>
-            <a:endParaRPr lang="en-US" smtClean="0"/>
           </a:p>
           <a:p>
             <a:pPr lvl="3"/>
@@ -2665,7 +2686,6 @@
               <a:rPr lang="en-US" smtClean="0"/>
               <a:t>Fourth level</a:t>
             </a:r>
-            <a:endParaRPr lang="en-US" smtClean="0"/>
           </a:p>
           <a:p>
             <a:pPr lvl="4"/>
@@ -2712,6 +2732,7 @@
           <a:p>
             <a:fld id="{5BCAD085-E8A6-8845-BD4E-CB4CCA059FC4}" type="datetimeFigureOut">
               <a:rPr lang="en-US" smtClean="0"/>
+              <a:t>1/27/13</a:t>
             </a:fld>
             <a:endParaRPr lang="en-US"/>
           </a:p>
@@ -2789,12 +2810,18 @@
           <a:p>
             <a:fld id="{C1FF6DA9-008F-8B48-92A6-B652298478BF}" type="slidenum">
               <a:rPr lang="en-US" smtClean="0"/>
+              <a:t>‹#›</a:t>
             </a:fld>
             <a:endParaRPr lang="en-US"/>
           </a:p>
         </p:txBody>
       </p:sp>
     </p:spTree>
+    <p:extLst>
+      <p:ext uri="{BB962C8B-B14F-4D97-AF65-F5344CB8AC3E}">
+        <p14:creationId xmlns:p14="http://schemas.microsoft.com/office/powerpoint/2010/main" val="2209977519"/>
+      </p:ext>
+    </p:extLst>
   </p:cSld>
   <p:clrMap bg1="lt1" tx1="dk1" bg2="lt2" tx2="dk2" accent1="accent1" accent2="accent2" accent3="accent3" accent4="accent4" accent5="accent5" accent6="accent6" hlink="hlink" folHlink="folHlink"/>
   <p:sldLayoutIdLst>
@@ -2832,7 +2859,7 @@
         <a:spcBef>
           <a:spcPct val="20000"/>
         </a:spcBef>
-        <a:buFont typeface="Arial" panose="020B0604020202020204"/>
+        <a:buFont typeface="Arial"/>
         <a:buChar char="•"/>
         <a:defRPr sz="3200" kern="1200">
           <a:solidFill>
@@ -2847,7 +2874,7 @@
         <a:spcBef>
           <a:spcPct val="20000"/>
         </a:spcBef>
-        <a:buFont typeface="Arial" panose="020B0604020202020204"/>
+        <a:buFont typeface="Arial"/>
         <a:buChar char="–"/>
         <a:defRPr sz="2800" kern="1200">
           <a:solidFill>
@@ -2862,7 +2889,7 @@
         <a:spcBef>
           <a:spcPct val="20000"/>
         </a:spcBef>
-        <a:buFont typeface="Arial" panose="020B0604020202020204"/>
+        <a:buFont typeface="Arial"/>
         <a:buChar char="•"/>
         <a:defRPr sz="2400" kern="1200">
           <a:solidFill>
@@ -2877,7 +2904,7 @@
         <a:spcBef>
           <a:spcPct val="20000"/>
         </a:spcBef>
-        <a:buFont typeface="Arial" panose="020B0604020202020204"/>
+        <a:buFont typeface="Arial"/>
         <a:buChar char="–"/>
         <a:defRPr sz="2000" kern="1200">
           <a:solidFill>
@@ -2892,7 +2919,7 @@
         <a:spcBef>
           <a:spcPct val="20000"/>
         </a:spcBef>
-        <a:buFont typeface="Arial" panose="020B0604020202020204"/>
+        <a:buFont typeface="Arial"/>
         <a:buChar char="»"/>
         <a:defRPr sz="2000" kern="1200">
           <a:solidFill>
@@ -2907,7 +2934,7 @@
         <a:spcBef>
           <a:spcPct val="20000"/>
         </a:spcBef>
-        <a:buFont typeface="Arial" panose="020B0604020202020204"/>
+        <a:buFont typeface="Arial"/>
         <a:buChar char="•"/>
         <a:defRPr sz="2000" kern="1200">
           <a:solidFill>
@@ -2922,7 +2949,7 @@
         <a:spcBef>
           <a:spcPct val="20000"/>
         </a:spcBef>
-        <a:buFont typeface="Arial" panose="020B0604020202020204"/>
+        <a:buFont typeface="Arial"/>
         <a:buChar char="•"/>
         <a:defRPr sz="2000" kern="1200">
           <a:solidFill>
@@ -2937,7 +2964,7 @@
         <a:spcBef>
           <a:spcPct val="20000"/>
         </a:spcBef>
-        <a:buFont typeface="Arial" panose="020B0604020202020204"/>
+        <a:buFont typeface="Arial"/>
         <a:buChar char="•"/>
         <a:defRPr sz="2000" kern="1200">
           <a:solidFill>
@@ -2952,7 +2979,7 @@
         <a:spcBef>
           <a:spcPct val="20000"/>
         </a:spcBef>
-        <a:buFont typeface="Arial" panose="020B0604020202020204"/>
+        <a:buFont typeface="Arial"/>
         <a:buChar char="•"/>
         <a:defRPr sz="2000" kern="1200">
           <a:solidFill>
@@ -3064,7 +3091,7 @@
 </file>
 
 <file path=ppt/slides/slide1.xml><?xml version="1.0" encoding="utf-8"?>
-<p:sld xmlns:a="http://schemas.openxmlformats.org/drawingml/2006/main" xmlns:r="http://schemas.openxmlformats.org/officeDocument/2006/relationships" xmlns:p="http://schemas.openxmlformats.org/presentationml/2006/main">
+<p:sld xmlns:a="http://schemas.openxmlformats.org/drawingml/2006/main" xmlns:p="http://schemas.openxmlformats.org/presentationml/2006/main" xmlns:r="http://schemas.openxmlformats.org/officeDocument/2006/relationships">
   <p:cSld>
     <p:spTree>
       <p:nvGrpSpPr>
@@ -3232,16 +3259,10 @@
                 <a:solidFill>
                   <a:srgbClr val="9B8BC4"/>
                 </a:solidFill>
-                <a:latin typeface="Calibri" panose="020F0502020204030204"/>
+                <a:latin typeface="Calibri"/>
               </a:rPr>
               <a:t>BSc Software Engineering Capstone — Progress Review</a:t>
             </a:r>
-            <a:endParaRPr sz="1600" b="1" i="0">
-              <a:solidFill>
-                <a:srgbClr val="9B8BC4"/>
-              </a:solidFill>
-              <a:latin typeface="Calibri" panose="020F0502020204030204"/>
-            </a:endParaRPr>
           </a:p>
         </p:txBody>
       </p:sp>
@@ -3272,16 +3293,10 @@
                 <a:solidFill>
                   <a:srgbClr val="FFFFFF"/>
                 </a:solidFill>
-                <a:latin typeface="Calibri" panose="020F0502020204030204"/>
+                <a:latin typeface="Calibri"/>
               </a:rPr>
               <a:t>Umubyeyi</a:t>
             </a:r>
-            <a:endParaRPr sz="5400" b="1" i="0">
-              <a:solidFill>
-                <a:srgbClr val="FFFFFF"/>
-              </a:solidFill>
-              <a:latin typeface="Calibri" panose="020F0502020204030204"/>
-            </a:endParaRPr>
           </a:p>
         </p:txBody>
       </p:sp>
@@ -3312,16 +3327,10 @@
                 <a:solidFill>
                   <a:srgbClr val="FFFFFF"/>
                 </a:solidFill>
-                <a:latin typeface="Calibri" panose="020F0502020204030204"/>
+                <a:latin typeface="Calibri"/>
               </a:rPr>
               <a:t>A Kinyarwanda-Language AI Chatbot for Maternal Mental Wellness in the Postpartum Window</a:t>
             </a:r>
-            <a:endParaRPr sz="2400" b="0" i="0">
-              <a:solidFill>
-                <a:srgbClr val="FFFFFF"/>
-              </a:solidFill>
-              <a:latin typeface="Calibri" panose="020F0502020204030204"/>
-            </a:endParaRPr>
           </a:p>
         </p:txBody>
       </p:sp>
@@ -3352,16 +3361,10 @@
                 <a:solidFill>
                   <a:srgbClr val="FFFFFF"/>
                 </a:solidFill>
-                <a:latin typeface="Calibri" panose="020F0502020204030204"/>
+                <a:latin typeface="Calibri"/>
               </a:rPr>
               <a:t>Raissa Irutingabo  ·  African Leadership University</a:t>
             </a:r>
-            <a:endParaRPr sz="1500" b="1" i="0">
-              <a:solidFill>
-                <a:srgbClr val="FFFFFF"/>
-              </a:solidFill>
-              <a:latin typeface="Calibri" panose="020F0502020204030204"/>
-            </a:endParaRPr>
           </a:p>
           <a:p>
             <a:r>
@@ -3369,16 +3372,10 @@
                 <a:solidFill>
                   <a:srgbClr val="9B8BC4"/>
                 </a:solidFill>
-                <a:latin typeface="Calibri" panose="020F0502020204030204"/>
+                <a:latin typeface="Calibri"/>
               </a:rPr>
               <a:t>Supervisor: Samiratu Ntohsi</a:t>
             </a:r>
-            <a:endParaRPr sz="1500" b="0" i="0">
-              <a:solidFill>
-                <a:srgbClr val="9B8BC4"/>
-              </a:solidFill>
-              <a:latin typeface="Calibri" panose="020F0502020204030204"/>
-            </a:endParaRPr>
           </a:p>
           <a:p>
             <a:r>
@@ -3386,16 +3383,10 @@
                 <a:solidFill>
                   <a:srgbClr val="55576B"/>
                 </a:solidFill>
-                <a:latin typeface="Calibri" panose="020F0502020204030204"/>
+                <a:latin typeface="Calibri"/>
               </a:rPr>
               <a:t>Progress presentation — June 2026</a:t>
             </a:r>
-            <a:endParaRPr sz="1500" b="0" i="0">
-              <a:solidFill>
-                <a:srgbClr val="55576B"/>
-              </a:solidFill>
-              <a:latin typeface="Calibri" panose="020F0502020204030204"/>
-            </a:endParaRPr>
           </a:p>
         </p:txBody>
       </p:sp>
@@ -3408,7 +3399,7 @@
 </file>
 
 <file path=ppt/slides/slide10.xml><?xml version="1.0" encoding="utf-8"?>
-<p:sld xmlns:a="http://schemas.openxmlformats.org/drawingml/2006/main" xmlns:r="http://schemas.openxmlformats.org/officeDocument/2006/relationships" xmlns:p="http://schemas.openxmlformats.org/presentationml/2006/main">
+<p:sld xmlns:a="http://schemas.openxmlformats.org/drawingml/2006/main" xmlns:p="http://schemas.openxmlformats.org/presentationml/2006/main" xmlns:r="http://schemas.openxmlformats.org/officeDocument/2006/relationships">
   <p:cSld>
     <p:spTree>
       <p:nvGrpSpPr>
@@ -3532,16 +3523,10 @@
                 <a:solidFill>
                   <a:srgbClr val="E76F51"/>
                 </a:solidFill>
-                <a:latin typeface="Calibri" panose="020F0502020204030204"/>
+                <a:latin typeface="Calibri"/>
               </a:rPr>
               <a:t>RESULTS</a:t>
             </a:r>
-            <a:endParaRPr sz="1200" b="1" i="0">
-              <a:solidFill>
-                <a:srgbClr val="E76F51"/>
-              </a:solidFill>
-              <a:latin typeface="Calibri" panose="020F0502020204030204"/>
-            </a:endParaRPr>
           </a:p>
         </p:txBody>
       </p:sp>
@@ -3572,16 +3557,10 @@
                 <a:solidFill>
                   <a:srgbClr val="2B2D42"/>
                 </a:solidFill>
-                <a:latin typeface="Calibri" panose="020F0502020204030204"/>
+                <a:latin typeface="Calibri"/>
               </a:rPr>
               <a:t>The core scientific contribution</a:t>
             </a:r>
-            <a:endParaRPr sz="3000" b="1" i="0">
-              <a:solidFill>
-                <a:srgbClr val="2B2D42"/>
-              </a:solidFill>
-              <a:latin typeface="Calibri" panose="020F0502020204030204"/>
-            </a:endParaRPr>
           </a:p>
         </p:txBody>
       </p:sp>
@@ -3664,16 +3643,10 @@
                 <a:solidFill>
                   <a:srgbClr val="2B2D42"/>
                 </a:solidFill>
-                <a:latin typeface="Calibri" panose="020F0502020204030204"/>
+                <a:latin typeface="Calibri"/>
               </a:rPr>
               <a:t>•  Central research question: how much accuracy do we lose to translation?</a:t>
             </a:r>
-            <a:endParaRPr sz="1500" b="1" i="0">
-              <a:solidFill>
-                <a:srgbClr val="2B2D42"/>
-              </a:solidFill>
-              <a:latin typeface="Calibri" panose="020F0502020204030204"/>
-            </a:endParaRPr>
           </a:p>
           <a:p>
             <a:pPr>
@@ -3689,16 +3662,10 @@
                 <a:solidFill>
                   <a:srgbClr val="2B2D42"/>
                 </a:solidFill>
-                <a:latin typeface="Calibri" panose="020F0502020204030204"/>
+                <a:latin typeface="Calibri"/>
               </a:rPr>
               <a:t>•  Method: classify the English test set directly vs. after an EN→Kinyarwanda→EN round-trip through NLLB-200 — the gap is the degradation coefficient.</a:t>
             </a:r>
-            <a:endParaRPr sz="1500" b="1" i="0">
-              <a:solidFill>
-                <a:srgbClr val="2B2D42"/>
-              </a:solidFill>
-              <a:latin typeface="Calibri" panose="020F0502020204030204"/>
-            </a:endParaRPr>
           </a:p>
           <a:p>
             <a:pPr>
@@ -3714,16 +3681,10 @@
                 <a:solidFill>
                   <a:srgbClr val="2B2D42"/>
                 </a:solidFill>
-                <a:latin typeface="Calibri" panose="020F0502020204030204"/>
+                <a:latin typeface="Calibri"/>
               </a:rPr>
               <a:t>•  This would be the first published Kinyarwanda mental-wellness classification benchmark.</a:t>
             </a:r>
-            <a:endParaRPr sz="1500" b="1" i="0">
-              <a:solidFill>
-                <a:srgbClr val="2B2D42"/>
-              </a:solidFill>
-              <a:latin typeface="Calibri" panose="020F0502020204030204"/>
-            </a:endParaRPr>
           </a:p>
         </p:txBody>
       </p:sp>
@@ -3798,16 +3759,10 @@
                 <a:solidFill>
                   <a:srgbClr val="E76F51"/>
                 </a:solidFill>
-                <a:latin typeface="Calibri" panose="020F0502020204030204"/>
+                <a:latin typeface="Calibri"/>
               </a:rPr>
               <a:t>Live demo finding</a:t>
             </a:r>
-            <a:endParaRPr sz="1400" b="1" i="0">
-              <a:solidFill>
-                <a:srgbClr val="E76F51"/>
-              </a:solidFill>
-              <a:latin typeface="Calibri" panose="020F0502020204030204"/>
-            </a:endParaRPr>
           </a:p>
           <a:p>
             <a:pPr>
@@ -3820,16 +3775,10 @@
                 <a:solidFill>
                   <a:srgbClr val="9B8BC4"/>
                 </a:solidFill>
-                <a:latin typeface="Calibri" panose="020F0502020204030204"/>
+                <a:latin typeface="Calibri"/>
               </a:rPr>
               <a:t>Input (Kinyarwanda):</a:t>
             </a:r>
-            <a:endParaRPr sz="1200" b="1" i="0">
-              <a:solidFill>
-                <a:srgbClr val="9B8BC4"/>
-              </a:solidFill>
-              <a:latin typeface="Calibri" panose="020F0502020204030204"/>
-            </a:endParaRPr>
           </a:p>
           <a:p>
             <a:r>
@@ -3837,16 +3786,10 @@
                 <a:solidFill>
                   <a:srgbClr val="FFFFFF"/>
                 </a:solidFill>
-                <a:latin typeface="Calibri" panose="020F0502020204030204"/>
+                <a:latin typeface="Calibri"/>
               </a:rPr>
               <a:t>“umugabo wanjye ntamfasha”  (my husband does NOT help me)</a:t>
             </a:r>
-            <a:endParaRPr sz="1300" b="0" i="1">
-              <a:solidFill>
-                <a:srgbClr val="FFFFFF"/>
-              </a:solidFill>
-              <a:latin typeface="Calibri" panose="020F0502020204030204"/>
-            </a:endParaRPr>
           </a:p>
           <a:p>
             <a:pPr>
@@ -3859,16 +3802,10 @@
                 <a:solidFill>
                   <a:srgbClr val="9B8BC4"/>
                 </a:solidFill>
-                <a:latin typeface="Calibri" panose="020F0502020204030204"/>
+                <a:latin typeface="Calibri"/>
               </a:rPr>
               <a:t>NLLB dropped the negation →</a:t>
             </a:r>
-            <a:endParaRPr sz="1200" b="1" i="0">
-              <a:solidFill>
-                <a:srgbClr val="9B8BC4"/>
-              </a:solidFill>
-              <a:latin typeface="Calibri" panose="020F0502020204030204"/>
-            </a:endParaRPr>
           </a:p>
           <a:p>
             <a:r>
@@ -3876,16 +3813,10 @@
                 <a:solidFill>
                   <a:srgbClr val="FFFFFF"/>
                 </a:solidFill>
-                <a:latin typeface="Calibri" panose="020F0502020204030204"/>
+                <a:latin typeface="Calibri"/>
               </a:rPr>
               <a:t>“my husband is helping me”  — meaning inverted</a:t>
             </a:r>
-            <a:endParaRPr sz="1300" b="0" i="1">
-              <a:solidFill>
-                <a:srgbClr val="FFFFFF"/>
-              </a:solidFill>
-              <a:latin typeface="Calibri" panose="020F0502020204030204"/>
-            </a:endParaRPr>
           </a:p>
           <a:p>
             <a:pPr>
@@ -3898,16 +3829,10 @@
                 <a:solidFill>
                   <a:srgbClr val="FFFFFF"/>
                 </a:solidFill>
-                <a:latin typeface="Calibri" panose="020F0502020204030204"/>
+                <a:latin typeface="Calibri"/>
               </a:rPr>
               <a:t>Confidence fell to 0.31 → the safety gate caught it → safe fallback. Live proof of both the risk AND the mitigation.</a:t>
             </a:r>
-            <a:endParaRPr sz="1300" b="0" i="0">
-              <a:solidFill>
-                <a:srgbClr val="FFFFFF"/>
-              </a:solidFill>
-              <a:latin typeface="Calibri" panose="020F0502020204030204"/>
-            </a:endParaRPr>
           </a:p>
         </p:txBody>
       </p:sp>
@@ -3982,16 +3907,10 @@
                 <a:solidFill>
                   <a:srgbClr val="FFFFFF"/>
                 </a:solidFill>
-                <a:latin typeface="Calibri" panose="020F0502020204030204"/>
+                <a:latin typeface="Calibri"/>
               </a:rPr>
               <a:t>Umubyeyi  ·  Kinyarwanda Maternal Mental-Wellness Chatbot  ·  R. Irutingabo (ALU)</a:t>
             </a:r>
-            <a:endParaRPr sz="900" b="0" i="0">
-              <a:solidFill>
-                <a:srgbClr val="FFFFFF"/>
-              </a:solidFill>
-              <a:latin typeface="Calibri" panose="020F0502020204030204"/>
-            </a:endParaRPr>
           </a:p>
         </p:txBody>
       </p:sp>
@@ -4023,16 +3942,10 @@
                 <a:solidFill>
                   <a:srgbClr val="FFFFFF"/>
                 </a:solidFill>
-                <a:latin typeface="Calibri" panose="020F0502020204030204"/>
+                <a:latin typeface="Calibri"/>
               </a:rPr>
               <a:t>10</a:t>
             </a:r>
-            <a:endParaRPr sz="900" b="0" i="0">
-              <a:solidFill>
-                <a:srgbClr val="FFFFFF"/>
-              </a:solidFill>
-              <a:latin typeface="Calibri" panose="020F0502020204030204"/>
-            </a:endParaRPr>
           </a:p>
         </p:txBody>
       </p:sp>
@@ -4045,7 +3958,7 @@
 </file>
 
 <file path=ppt/slides/slide11.xml><?xml version="1.0" encoding="utf-8"?>
-<p:sld xmlns:a="http://schemas.openxmlformats.org/drawingml/2006/main" xmlns:r="http://schemas.openxmlformats.org/officeDocument/2006/relationships" xmlns:p="http://schemas.openxmlformats.org/presentationml/2006/main">
+<p:sld xmlns:a="http://schemas.openxmlformats.org/drawingml/2006/main" xmlns:p="http://schemas.openxmlformats.org/presentationml/2006/main" xmlns:r="http://schemas.openxmlformats.org/officeDocument/2006/relationships">
   <p:cSld>
     <p:spTree>
       <p:nvGrpSpPr>
@@ -4169,16 +4082,10 @@
                 <a:solidFill>
                   <a:srgbClr val="E76F51"/>
                 </a:solidFill>
-                <a:latin typeface="Calibri" panose="020F0502020204030204"/>
+                <a:latin typeface="Calibri"/>
               </a:rPr>
               <a:t>DISCUSSION</a:t>
             </a:r>
-            <a:endParaRPr sz="1200" b="1" i="0">
-              <a:solidFill>
-                <a:srgbClr val="E76F51"/>
-              </a:solidFill>
-              <a:latin typeface="Calibri" panose="020F0502020204030204"/>
-            </a:endParaRPr>
           </a:p>
         </p:txBody>
       </p:sp>
@@ -4209,16 +4116,10 @@
                 <a:solidFill>
                   <a:srgbClr val="2B2D42"/>
                 </a:solidFill>
-                <a:latin typeface="Calibri" panose="020F0502020204030204"/>
+                <a:latin typeface="Calibri"/>
               </a:rPr>
               <a:t>Discussion</a:t>
             </a:r>
-            <a:endParaRPr sz="3000" b="1" i="0">
-              <a:solidFill>
-                <a:srgbClr val="2B2D42"/>
-              </a:solidFill>
-              <a:latin typeface="Calibri" panose="020F0502020204030204"/>
-            </a:endParaRPr>
           </a:p>
         </p:txBody>
       </p:sp>
@@ -4301,16 +4202,10 @@
                 <a:solidFill>
                   <a:srgbClr val="2B2D42"/>
                 </a:solidFill>
-                <a:latin typeface="Calibri" panose="020F0502020204030204"/>
+                <a:latin typeface="Calibri"/>
               </a:rPr>
               <a:t>•  Translation hallucination is the real risk — not classifier accuracy. Dropped negations can invert meaning.</a:t>
             </a:r>
-            <a:endParaRPr sz="1600" b="1" i="0">
-              <a:solidFill>
-                <a:srgbClr val="2B2D42"/>
-              </a:solidFill>
-              <a:latin typeface="Calibri" panose="020F0502020204030204"/>
-            </a:endParaRPr>
           </a:p>
           <a:p>
             <a:pPr>
@@ -4326,16 +4221,10 @@
                 <a:solidFill>
                   <a:srgbClr val="2B2D42"/>
                 </a:solidFill>
-                <a:latin typeface="Calibri" panose="020F0502020204030204"/>
+                <a:latin typeface="Calibri"/>
               </a:rPr>
               <a:t>•  The two-gate design (calibrated confidence + danger-sign override) turns that risk into a controlled, safe fallback rather than a wrong answer.</a:t>
             </a:r>
-            <a:endParaRPr sz="1600" b="1" i="0">
-              <a:solidFill>
-                <a:srgbClr val="2B2D42"/>
-              </a:solidFill>
-              <a:latin typeface="Calibri" panose="020F0502020204030204"/>
-            </a:endParaRPr>
           </a:p>
           <a:p>
             <a:pPr>
@@ -4351,16 +4240,10 @@
                 <a:solidFill>
                   <a:srgbClr val="2B2D42"/>
                 </a:solidFill>
-                <a:latin typeface="Calibri" panose="020F0502020204030204"/>
+                <a:latin typeface="Calibri"/>
               </a:rPr>
               <a:t>•  Open finding: the proposed fixed 0.40 confidence threshold abstains ~88% of the time — it needs empirical tuning, not assumption.</a:t>
             </a:r>
-            <a:endParaRPr sz="1600" b="1" i="0">
-              <a:solidFill>
-                <a:srgbClr val="2B2D42"/>
-              </a:solidFill>
-              <a:latin typeface="Calibri" panose="020F0502020204030204"/>
-            </a:endParaRPr>
           </a:p>
           <a:p>
             <a:pPr>
@@ -4376,16 +4259,10 @@
                 <a:solidFill>
                   <a:srgbClr val="2B2D42"/>
                 </a:solidFill>
-                <a:latin typeface="Calibri" panose="020F0502020204030204"/>
+                <a:latin typeface="Calibri"/>
               </a:rPr>
               <a:t>•  “Strong ML” here = rigor + a genuinely novel measurement, not model size. Classical models are the right call for low-resource deployment.</a:t>
             </a:r>
-            <a:endParaRPr sz="1600" b="1" i="0">
-              <a:solidFill>
-                <a:srgbClr val="2B2D42"/>
-              </a:solidFill>
-              <a:latin typeface="Calibri" panose="020F0502020204030204"/>
-            </a:endParaRPr>
           </a:p>
         </p:txBody>
       </p:sp>
@@ -4460,16 +4337,10 @@
                 <a:solidFill>
                   <a:srgbClr val="FFFFFF"/>
                 </a:solidFill>
-                <a:latin typeface="Calibri" panose="020F0502020204030204"/>
+                <a:latin typeface="Calibri"/>
               </a:rPr>
               <a:t>Umubyeyi  ·  Kinyarwanda Maternal Mental-Wellness Chatbot  ·  R. Irutingabo (ALU)</a:t>
             </a:r>
-            <a:endParaRPr sz="900" b="0" i="0">
-              <a:solidFill>
-                <a:srgbClr val="FFFFFF"/>
-              </a:solidFill>
-              <a:latin typeface="Calibri" panose="020F0502020204030204"/>
-            </a:endParaRPr>
           </a:p>
         </p:txBody>
       </p:sp>
@@ -4501,16 +4372,10 @@
                 <a:solidFill>
                   <a:srgbClr val="FFFFFF"/>
                 </a:solidFill>
-                <a:latin typeface="Calibri" panose="020F0502020204030204"/>
+                <a:latin typeface="Calibri"/>
               </a:rPr>
               <a:t>11</a:t>
             </a:r>
-            <a:endParaRPr sz="900" b="0" i="0">
-              <a:solidFill>
-                <a:srgbClr val="FFFFFF"/>
-              </a:solidFill>
-              <a:latin typeface="Calibri" panose="020F0502020204030204"/>
-            </a:endParaRPr>
           </a:p>
         </p:txBody>
       </p:sp>
@@ -4523,7 +4388,7 @@
 </file>
 
 <file path=ppt/slides/slide12.xml><?xml version="1.0" encoding="utf-8"?>
-<p:sld xmlns:a="http://schemas.openxmlformats.org/drawingml/2006/main" xmlns:r="http://schemas.openxmlformats.org/officeDocument/2006/relationships" xmlns:p="http://schemas.openxmlformats.org/presentationml/2006/main">
+<p:sld xmlns:a="http://schemas.openxmlformats.org/drawingml/2006/main" xmlns:p="http://schemas.openxmlformats.org/presentationml/2006/main" xmlns:r="http://schemas.openxmlformats.org/officeDocument/2006/relationships">
   <p:cSld>
     <p:spTree>
       <p:nvGrpSpPr>
@@ -4647,16 +4512,10 @@
                 <a:solidFill>
                   <a:srgbClr val="E76F51"/>
                 </a:solidFill>
-                <a:latin typeface="Calibri" panose="020F0502020204030204"/>
+                <a:latin typeface="Calibri"/>
               </a:rPr>
               <a:t>CONCLUSIONS</a:t>
             </a:r>
-            <a:endParaRPr sz="1200" b="1" i="0">
-              <a:solidFill>
-                <a:srgbClr val="E76F51"/>
-              </a:solidFill>
-              <a:latin typeface="Calibri" panose="020F0502020204030204"/>
-            </a:endParaRPr>
           </a:p>
         </p:txBody>
       </p:sp>
@@ -4687,16 +4546,10 @@
                 <a:solidFill>
                   <a:srgbClr val="2B2D42"/>
                 </a:solidFill>
-                <a:latin typeface="Calibri" panose="020F0502020204030204"/>
+                <a:latin typeface="Calibri"/>
               </a:rPr>
               <a:t>Conclusions &amp; Next Steps</a:t>
             </a:r>
-            <a:endParaRPr sz="3000" b="1" i="0">
-              <a:solidFill>
-                <a:srgbClr val="2B2D42"/>
-              </a:solidFill>
-              <a:latin typeface="Calibri" panose="020F0502020204030204"/>
-            </a:endParaRPr>
           </a:p>
         </p:txBody>
       </p:sp>
@@ -4771,16 +4624,10 @@
                 <a:solidFill>
                   <a:srgbClr val="1A9988"/>
                 </a:solidFill>
-                <a:latin typeface="Calibri" panose="020F0502020204030204"/>
+                <a:latin typeface="Calibri"/>
               </a:rPr>
               <a:t>Where we are</a:t>
             </a:r>
-            <a:endParaRPr sz="1600" b="1" i="0">
-              <a:solidFill>
-                <a:srgbClr val="1A9988"/>
-              </a:solidFill>
-              <a:latin typeface="Calibri" panose="020F0502020204030204"/>
-            </a:endParaRPr>
           </a:p>
         </p:txBody>
       </p:sp>
@@ -4793,7 +4640,7 @@
         <p:spPr>
           <a:xfrm>
             <a:off x="548640" y="2103120"/>
-            <a:ext cx="5486400" cy="1260475"/>
+            <a:ext cx="5486400" cy="4480560"/>
           </a:xfrm>
           <a:prstGeom prst="rect">
             <a:avLst/>
@@ -4819,16 +4666,10 @@
                 <a:solidFill>
                   <a:srgbClr val="2B2D42"/>
                 </a:solidFill>
-                <a:latin typeface="Calibri" panose="020F0502020204030204"/>
+                <a:latin typeface="Calibri"/>
               </a:rPr>
               <a:t>•  End-to-end Kinyarwanda pipeline works (NLLB + classifier + response templates + safety).</a:t>
             </a:r>
-            <a:endParaRPr sz="1400" b="1" i="0">
-              <a:solidFill>
-                <a:srgbClr val="2B2D42"/>
-              </a:solidFill>
-              <a:latin typeface="Calibri" panose="020F0502020204030204"/>
-            </a:endParaRPr>
           </a:p>
           <a:p>
             <a:pPr>
@@ -4844,16 +4685,10 @@
                 <a:solidFill>
                   <a:srgbClr val="2B2D42"/>
                 </a:solidFill>
-                <a:latin typeface="Calibri" panose="020F0502020204030204"/>
+                <a:latin typeface="Calibri"/>
               </a:rPr>
               <a:t>•  Floor baseline established: 0.61 acc / 0.60 F1 (Model 1).</a:t>
             </a:r>
-            <a:endParaRPr sz="1400" b="1" i="0">
-              <a:solidFill>
-                <a:srgbClr val="2B2D42"/>
-              </a:solidFill>
-              <a:latin typeface="Calibri" panose="020F0502020204030204"/>
-            </a:endParaRPr>
           </a:p>
           <a:p>
             <a:pPr>
@@ -4869,80 +4704,11 @@
                 <a:solidFill>
                   <a:srgbClr val="2B2D42"/>
                 </a:solidFill>
-                <a:latin typeface="Calibri" panose="020F0502020204030204"/>
-              </a:rPr>
-              <a:t>.</a:t>
-            </a:r>
-            <a:endParaRPr sz="1400" b="1" i="0">
-              <a:solidFill>
-                <a:srgbClr val="2B2D42"/>
-              </a:solidFill>
-              <a:latin typeface="Calibri" panose="020F0502020204030204"/>
-            </a:endParaRPr>
-          </a:p>
-        </p:txBody>
-      </p:sp>
-      <p:sp>
-        <p:nvSpPr>
-          <p:cNvPr id="9" name="TextBox 8"/>
-          <p:cNvSpPr txBox="1"/>
-          <p:nvPr/>
-        </p:nvSpPr>
-        <p:spPr>
-          <a:xfrm>
-            <a:off x="6309360" y="1691640"/>
-            <a:ext cx="5486400" cy="457200"/>
-          </a:xfrm>
-          <a:prstGeom prst="rect">
-            <a:avLst/>
-          </a:prstGeom>
-          <a:noFill/>
-        </p:spPr>
-        <p:txBody>
-          <a:bodyPr wrap="square" anchor="t">
-            <a:spAutoFit/>
-          </a:bodyPr>
-          <a:lstStyle/>
-          <a:p>
-            <a:r>
-              <a:rPr sz="1600" b="1" i="0">
-                <a:solidFill>
-                  <a:srgbClr val="E76F51"/>
-                </a:solidFill>
-                <a:latin typeface="Calibri" panose="020F0502020204030204"/>
-              </a:rPr>
-              <a:t>Next steps</a:t>
-            </a:r>
-            <a:endParaRPr sz="1600" b="1" i="0">
-              <a:solidFill>
-                <a:srgbClr val="E76F51"/>
-              </a:solidFill>
-              <a:latin typeface="Calibri" panose="020F0502020204030204"/>
-            </a:endParaRPr>
-          </a:p>
-        </p:txBody>
-      </p:sp>
-      <p:sp>
-        <p:nvSpPr>
-          <p:cNvPr id="10" name="TextBox 9"/>
-          <p:cNvSpPr txBox="1"/>
-          <p:nvPr/>
-        </p:nvSpPr>
-        <p:spPr>
-          <a:xfrm>
-            <a:off x="6309360" y="2103120"/>
-            <a:ext cx="5486400" cy="675640"/>
-          </a:xfrm>
-          <a:prstGeom prst="rect">
-            <a:avLst/>
-          </a:prstGeom>
-          <a:noFill/>
-        </p:spPr>
-        <p:txBody>
-          <a:bodyPr wrap="square" anchor="t">
-            <a:spAutoFit/>
-          </a:bodyPr>
-          <a:lstStyle/>
+                <a:latin typeface="Calibri"/>
+              </a:rPr>
+              <a:t>•  Principled model ladder designed; embedding + transformer arms coded.</a:t>
+            </a:r>
+          </a:p>
           <a:p>
             <a:pPr>
               <a:spcBef>
@@ -4957,17 +4723,68 @@
                 <a:solidFill>
                   <a:srgbClr val="2B2D42"/>
                 </a:solidFill>
-                <a:latin typeface="Calibri" panose="020F0502020204030204"/>
-              </a:rPr>
-              <a:t>•  Measure the cross-lingual degradation coefficient.</a:t>
-            </a:r>
-            <a:endParaRPr sz="1400" b="1" i="0">
-              <a:solidFill>
-                <a:srgbClr val="2B2D42"/>
-              </a:solidFill>
-              <a:latin typeface="Calibri" panose="020F0502020204030204"/>
-            </a:endParaRPr>
-          </a:p>
+                <a:latin typeface="Calibri"/>
+              </a:rPr>
+              <a:t>•  Translation-risk demonstrated live, and contained by the safety gate.</a:t>
+            </a:r>
+          </a:p>
+        </p:txBody>
+      </p:sp>
+      <p:sp>
+        <p:nvSpPr>
+          <p:cNvPr id="9" name="TextBox 8"/>
+          <p:cNvSpPr txBox="1"/>
+          <p:nvPr/>
+        </p:nvSpPr>
+        <p:spPr>
+          <a:xfrm>
+            <a:off x="6309360" y="1691640"/>
+            <a:ext cx="5486400" cy="457200"/>
+          </a:xfrm>
+          <a:prstGeom prst="rect">
+            <a:avLst/>
+          </a:prstGeom>
+          <a:noFill/>
+        </p:spPr>
+        <p:txBody>
+          <a:bodyPr wrap="square" anchor="t">
+            <a:spAutoFit/>
+          </a:bodyPr>
+          <a:lstStyle/>
+          <a:p>
+            <a:r>
+              <a:rPr sz="1600" b="1" i="0">
+                <a:solidFill>
+                  <a:srgbClr val="E76F51"/>
+                </a:solidFill>
+                <a:latin typeface="Calibri"/>
+              </a:rPr>
+              <a:t>Next steps</a:t>
+            </a:r>
+          </a:p>
+        </p:txBody>
+      </p:sp>
+      <p:sp>
+        <p:nvSpPr>
+          <p:cNvPr id="10" name="TextBox 9"/>
+          <p:cNvSpPr txBox="1"/>
+          <p:nvPr/>
+        </p:nvSpPr>
+        <p:spPr>
+          <a:xfrm>
+            <a:off x="6309360" y="2103120"/>
+            <a:ext cx="5486400" cy="4480560"/>
+          </a:xfrm>
+          <a:prstGeom prst="rect">
+            <a:avLst/>
+          </a:prstGeom>
+          <a:noFill/>
+        </p:spPr>
+        <p:txBody>
+          <a:bodyPr wrap="square" anchor="t">
+            <a:spAutoFit/>
+          </a:bodyPr>
+          <a:lstStyle/>
           <a:p>
             <a:pPr>
               <a:spcBef>
@@ -4982,16 +4799,67 @@
                 <a:solidFill>
                   <a:srgbClr val="2B2D42"/>
                 </a:solidFill>
-                <a:latin typeface="Calibri" panose="020F0502020204030204"/>
+                <a:latin typeface="Calibri"/>
+              </a:rPr>
+              <a:t>•  Measure the cross-lingual degradation coefficient.</a:t>
+            </a:r>
+          </a:p>
+          <a:p>
+            <a:pPr>
+              <a:spcBef>
+                <a:spcPts val="200"/>
+              </a:spcBef>
+              <a:spcAft>
+                <a:spcPts val="1000"/>
+              </a:spcAft>
+            </a:pPr>
+            <a:r>
+              <a:rPr sz="1400" b="1" i="0">
+                <a:solidFill>
+                  <a:srgbClr val="2B2D42"/>
+                </a:solidFill>
+                <a:latin typeface="Calibri"/>
               </a:rPr>
               <a:t>•  AfroXLMR fine-tune as a comparison arm.</a:t>
             </a:r>
-            <a:endParaRPr sz="1400" b="1" i="0">
-              <a:solidFill>
-                <a:srgbClr val="2B2D42"/>
-              </a:solidFill>
-              <a:latin typeface="Calibri" panose="020F0502020204030204"/>
-            </a:endParaRPr>
+          </a:p>
+          <a:p>
+            <a:pPr>
+              <a:spcBef>
+                <a:spcPts val="200"/>
+              </a:spcBef>
+              <a:spcAft>
+                <a:spcPts val="1000"/>
+              </a:spcAft>
+            </a:pPr>
+            <a:r>
+              <a:rPr sz="1400" b="1" i="0">
+                <a:solidFill>
+                  <a:srgbClr val="2B2D42"/>
+                </a:solidFill>
+                <a:latin typeface="Calibri"/>
+              </a:rPr>
+              <a:t>•  Future: build a true evidence-sourced retrieval KB (beyond the 6 templates).</a:t>
+            </a:r>
+          </a:p>
+          <a:p>
+            <a:pPr>
+              <a:spcBef>
+                <a:spcPts val="200"/>
+              </a:spcBef>
+              <a:spcAft>
+                <a:spcPts val="1000"/>
+              </a:spcAft>
+            </a:pPr>
+            <a:r>
+              <a:rPr sz="1400" b="1" i="0">
+                <a:solidFill>
+                  <a:srgbClr val="2B2D42"/>
+                </a:solidFill>
+                <a:latin typeface="Calibri"/>
+              </a:rPr>
+              <a:t>•  SUS usability study with 10 proxy users (target &gt; 70).</a:t>
+            </a:r>
           </a:p>
         </p:txBody>
       </p:sp>
@@ -5003,7 +4871,7 @@
         </p:nvSpPr>
         <p:spPr>
           <a:xfrm>
-            <a:off x="457200" y="4241800"/>
+            <a:off x="548640" y="5349240"/>
             <a:ext cx="11155680" cy="594360"/>
           </a:xfrm>
           <a:prstGeom prst="rect">
@@ -5047,7 +4915,7 @@
         </p:nvSpPr>
         <p:spPr>
           <a:xfrm>
-            <a:off x="579120" y="4241800"/>
+            <a:off x="777240" y="5394960"/>
             <a:ext cx="10698480" cy="502920"/>
           </a:xfrm>
           <a:prstGeom prst="rect">
@@ -5066,16 +4934,10 @@
                 <a:solidFill>
                   <a:srgbClr val="FFFFFF"/>
                 </a:solidFill>
-                <a:latin typeface="Calibri" panose="020F0502020204030204"/>
+                <a:latin typeface="Calibri"/>
               </a:rPr>
               <a:t>Contribution: the first Kinyarwanda maternal mental-wellness classifier + a quantified benchmark of what translation costs.</a:t>
             </a:r>
-            <a:endParaRPr sz="1500" b="1" i="0">
-              <a:solidFill>
-                <a:srgbClr val="FFFFFF"/>
-              </a:solidFill>
-              <a:latin typeface="Calibri" panose="020F0502020204030204"/>
-            </a:endParaRPr>
           </a:p>
         </p:txBody>
       </p:sp>
@@ -5150,16 +5012,10 @@
                 <a:solidFill>
                   <a:srgbClr val="FFFFFF"/>
                 </a:solidFill>
-                <a:latin typeface="Calibri" panose="020F0502020204030204"/>
+                <a:latin typeface="Calibri"/>
               </a:rPr>
               <a:t>Umubyeyi  ·  Kinyarwanda Maternal Mental-Wellness Chatbot  ·  R. Irutingabo (ALU)</a:t>
             </a:r>
-            <a:endParaRPr sz="900" b="0" i="0">
-              <a:solidFill>
-                <a:srgbClr val="FFFFFF"/>
-              </a:solidFill>
-              <a:latin typeface="Calibri" panose="020F0502020204030204"/>
-            </a:endParaRPr>
           </a:p>
         </p:txBody>
       </p:sp>
@@ -5191,16 +5047,10 @@
                 <a:solidFill>
                   <a:srgbClr val="FFFFFF"/>
                 </a:solidFill>
-                <a:latin typeface="Calibri" panose="020F0502020204030204"/>
+                <a:latin typeface="Calibri"/>
               </a:rPr>
               <a:t>12</a:t>
             </a:r>
-            <a:endParaRPr sz="900" b="0" i="0">
-              <a:solidFill>
-                <a:srgbClr val="FFFFFF"/>
-              </a:solidFill>
-              <a:latin typeface="Calibri" panose="020F0502020204030204"/>
-            </a:endParaRPr>
           </a:p>
         </p:txBody>
       </p:sp>
@@ -5213,7 +5063,7 @@
 </file>
 
 <file path=ppt/slides/slide13.xml><?xml version="1.0" encoding="utf-8"?>
-<p:sld xmlns:a="http://schemas.openxmlformats.org/drawingml/2006/main" xmlns:r="http://schemas.openxmlformats.org/officeDocument/2006/relationships" xmlns:p="http://schemas.openxmlformats.org/presentationml/2006/main">
+<p:sld xmlns:a="http://schemas.openxmlformats.org/drawingml/2006/main" xmlns:p="http://schemas.openxmlformats.org/presentationml/2006/main" xmlns:r="http://schemas.openxmlformats.org/officeDocument/2006/relationships">
   <p:cSld>
     <p:spTree>
       <p:nvGrpSpPr>
@@ -5319,7 +5169,7 @@
         <p:spPr>
           <a:xfrm>
             <a:off x="822960" y="2194560"/>
-            <a:ext cx="10515600" cy="768350"/>
+            <a:ext cx="10515600" cy="1097280"/>
           </a:xfrm>
           <a:prstGeom prst="rect">
             <a:avLst/>
@@ -5337,16 +5187,10 @@
                 <a:solidFill>
                   <a:srgbClr val="FFFFFF"/>
                 </a:solidFill>
-                <a:latin typeface="Calibri" panose="020F0502020204030204"/>
-              </a:rPr>
-              <a:t>Murakoze  Thank you</a:t>
-            </a:r>
-            <a:endParaRPr sz="4400" b="1" i="0">
-              <a:solidFill>
-                <a:srgbClr val="FFFFFF"/>
-              </a:solidFill>
-              <a:latin typeface="Calibri" panose="020F0502020204030204"/>
-            </a:endParaRPr>
+                <a:latin typeface="Calibri"/>
+              </a:rPr>
+              <a:t>Murakoze — Thank you</a:t>
+            </a:r>
           </a:p>
         </p:txBody>
       </p:sp>
@@ -5377,16 +5221,10 @@
                 <a:solidFill>
                   <a:srgbClr val="9B8BC4"/>
                 </a:solidFill>
-                <a:latin typeface="Calibri" panose="020F0502020204030204"/>
+                <a:latin typeface="Calibri"/>
               </a:rPr>
               <a:t>Questions &amp; discussion</a:t>
             </a:r>
-            <a:endParaRPr sz="2200" b="0" i="0">
-              <a:solidFill>
-                <a:srgbClr val="9B8BC4"/>
-              </a:solidFill>
-              <a:latin typeface="Calibri" panose="020F0502020204030204"/>
-            </a:endParaRPr>
           </a:p>
         </p:txBody>
       </p:sp>
@@ -5417,16 +5255,10 @@
                 <a:solidFill>
                   <a:srgbClr val="55576B"/>
                 </a:solidFill>
-                <a:latin typeface="Calibri" panose="020F0502020204030204"/>
+                <a:latin typeface="Calibri"/>
               </a:rPr>
               <a:t>Raissa Irutingabo  ·  github.com/IrutingaboRaissa/UMUBYEYI</a:t>
             </a:r>
-            <a:endParaRPr sz="1400" b="0" i="0">
-              <a:solidFill>
-                <a:srgbClr val="55576B"/>
-              </a:solidFill>
-              <a:latin typeface="Calibri" panose="020F0502020204030204"/>
-            </a:endParaRPr>
           </a:p>
         </p:txBody>
       </p:sp>
@@ -5439,7 +5271,7 @@
 </file>
 
 <file path=ppt/slides/slide2.xml><?xml version="1.0" encoding="utf-8"?>
-<p:sld xmlns:a="http://schemas.openxmlformats.org/drawingml/2006/main" xmlns:r="http://schemas.openxmlformats.org/officeDocument/2006/relationships" xmlns:p="http://schemas.openxmlformats.org/presentationml/2006/main">
+<p:sld xmlns:a="http://schemas.openxmlformats.org/drawingml/2006/main" xmlns:p="http://schemas.openxmlformats.org/presentationml/2006/main" xmlns:r="http://schemas.openxmlformats.org/officeDocument/2006/relationships">
   <p:cSld>
     <p:spTree>
       <p:nvGrpSpPr>
@@ -5563,16 +5395,10 @@
                 <a:solidFill>
                   <a:srgbClr val="E76F51"/>
                 </a:solidFill>
-                <a:latin typeface="Calibri" panose="020F0502020204030204"/>
+                <a:latin typeface="Calibri"/>
               </a:rPr>
               <a:t>AGENDA</a:t>
             </a:r>
-            <a:endParaRPr sz="1200" b="1" i="0">
-              <a:solidFill>
-                <a:srgbClr val="E76F51"/>
-              </a:solidFill>
-              <a:latin typeface="Calibri" panose="020F0502020204030204"/>
-            </a:endParaRPr>
           </a:p>
         </p:txBody>
       </p:sp>
@@ -5603,16 +5429,10 @@
                 <a:solidFill>
                   <a:srgbClr val="2B2D42"/>
                 </a:solidFill>
-                <a:latin typeface="Calibri" panose="020F0502020204030204"/>
+                <a:latin typeface="Calibri"/>
               </a:rPr>
               <a:t>Outline</a:t>
             </a:r>
-            <a:endParaRPr sz="3000" b="1" i="0">
-              <a:solidFill>
-                <a:srgbClr val="2B2D42"/>
-              </a:solidFill>
-              <a:latin typeface="Calibri" panose="020F0502020204030204"/>
-            </a:endParaRPr>
           </a:p>
         </p:txBody>
       </p:sp>
@@ -5668,8 +5488,8 @@
         </p:nvSpPr>
         <p:spPr>
           <a:xfrm>
-            <a:off x="502920" y="1705610"/>
-            <a:ext cx="10058400" cy="3384550"/>
+            <a:off x="548640" y="1737360"/>
+            <a:ext cx="10058400" cy="4480560"/>
           </a:xfrm>
           <a:prstGeom prst="rect">
             <a:avLst/>
@@ -5695,16 +5515,10 @@
                 <a:solidFill>
                   <a:srgbClr val="2B2D42"/>
                 </a:solidFill>
-                <a:latin typeface="Calibri" panose="020F0502020204030204"/>
+                <a:latin typeface="Calibri"/>
               </a:rPr>
               <a:t>•  Introduction</a:t>
             </a:r>
-            <a:endParaRPr sz="1800" b="1" i="0">
-              <a:solidFill>
-                <a:srgbClr val="2B2D42"/>
-              </a:solidFill>
-              <a:latin typeface="Calibri" panose="020F0502020204030204"/>
-            </a:endParaRPr>
           </a:p>
           <a:p>
             <a:pPr>
@@ -5720,16 +5534,10 @@
                 <a:solidFill>
                   <a:srgbClr val="2B2D42"/>
                 </a:solidFill>
-                <a:latin typeface="Calibri" panose="020F0502020204030204"/>
+                <a:latin typeface="Calibri"/>
               </a:rPr>
               <a:t>•  The Need</a:t>
             </a:r>
-            <a:endParaRPr sz="1800" b="1" i="0">
-              <a:solidFill>
-                <a:srgbClr val="2B2D42"/>
-              </a:solidFill>
-              <a:latin typeface="Calibri" panose="020F0502020204030204"/>
-            </a:endParaRPr>
           </a:p>
           <a:p>
             <a:pPr>
@@ -5745,16 +5553,29 @@
                 <a:solidFill>
                   <a:srgbClr val="2B2D42"/>
                 </a:solidFill>
-                <a:latin typeface="Calibri" panose="020F0502020204030204"/>
+                <a:latin typeface="Calibri"/>
               </a:rPr>
               <a:t>•  Data</a:t>
             </a:r>
-            <a:endParaRPr sz="1800" b="1" i="0">
-              <a:solidFill>
-                <a:srgbClr val="2B2D42"/>
-              </a:solidFill>
-              <a:latin typeface="Calibri" panose="020F0502020204030204"/>
-            </a:endParaRPr>
+          </a:p>
+          <a:p>
+            <a:pPr lvl="1">
+              <a:spcBef>
+                <a:spcPts val="200"/>
+              </a:spcBef>
+              <a:spcAft>
+                <a:spcPts val="1000"/>
+              </a:spcAft>
+            </a:pPr>
+            <a:r>
+              <a:rPr sz="1600" b="0" i="0">
+                <a:solidFill>
+                  <a:srgbClr val="55576B"/>
+                </a:solidFill>
+                <a:latin typeface="Calibri"/>
+              </a:rPr>
+              <a:t>    –  Training corpus, framing dataset, response templates</a:t>
+            </a:r>
           </a:p>
           <a:p>
             <a:pPr>
@@ -5770,16 +5591,10 @@
                 <a:solidFill>
                   <a:srgbClr val="2B2D42"/>
                 </a:solidFill>
-                <a:latin typeface="Calibri" panose="020F0502020204030204"/>
+                <a:latin typeface="Calibri"/>
               </a:rPr>
               <a:t>•  Data Preprocessing &amp; Exploration</a:t>
             </a:r>
-            <a:endParaRPr sz="1800" b="1" i="0">
-              <a:solidFill>
-                <a:srgbClr val="2B2D42"/>
-              </a:solidFill>
-              <a:latin typeface="Calibri" panose="020F0502020204030204"/>
-            </a:endParaRPr>
           </a:p>
           <a:p>
             <a:pPr>
@@ -5795,16 +5610,29 @@
                 <a:solidFill>
                   <a:srgbClr val="2B2D42"/>
                 </a:solidFill>
-                <a:latin typeface="Calibri" panose="020F0502020204030204"/>
+                <a:latin typeface="Calibri"/>
               </a:rPr>
               <a:t>•  The Approach</a:t>
             </a:r>
-            <a:endParaRPr sz="1800" b="1" i="0">
-              <a:solidFill>
-                <a:srgbClr val="2B2D42"/>
-              </a:solidFill>
-              <a:latin typeface="Calibri" panose="020F0502020204030204"/>
-            </a:endParaRPr>
+          </a:p>
+          <a:p>
+            <a:pPr lvl="1">
+              <a:spcBef>
+                <a:spcPts val="200"/>
+              </a:spcBef>
+              <a:spcAft>
+                <a:spcPts val="1000"/>
+              </a:spcAft>
+            </a:pPr>
+            <a:r>
+              <a:rPr sz="1600" b="0" i="0">
+                <a:solidFill>
+                  <a:srgbClr val="55576B"/>
+                </a:solidFill>
+                <a:latin typeface="Calibri"/>
+              </a:rPr>
+              <a:t>    –  System pipeline + the model ladder (floor → embeddings → transformer)</a:t>
+            </a:r>
           </a:p>
           <a:p>
             <a:pPr>
@@ -5820,16 +5648,29 @@
                 <a:solidFill>
                   <a:srgbClr val="2B2D42"/>
                 </a:solidFill>
-                <a:latin typeface="Calibri" panose="020F0502020204030204"/>
+                <a:latin typeface="Calibri"/>
               </a:rPr>
               <a:t>•  Results</a:t>
             </a:r>
-            <a:endParaRPr sz="1800" b="1" i="0">
-              <a:solidFill>
-                <a:srgbClr val="2B2D42"/>
-              </a:solidFill>
-              <a:latin typeface="Calibri" panose="020F0502020204030204"/>
-            </a:endParaRPr>
+          </a:p>
+          <a:p>
+            <a:pPr lvl="1">
+              <a:spcBef>
+                <a:spcPts val="200"/>
+              </a:spcBef>
+              <a:spcAft>
+                <a:spcPts val="1000"/>
+              </a:spcAft>
+            </a:pPr>
+            <a:r>
+              <a:rPr sz="1600" b="0" i="0">
+                <a:solidFill>
+                  <a:srgbClr val="55576B"/>
+                </a:solidFill>
+                <a:latin typeface="Calibri"/>
+              </a:rPr>
+              <a:t>    –  Baseline &amp; the cross-lingual degradation finding</a:t>
+            </a:r>
           </a:p>
           <a:p>
             <a:pPr>
@@ -5845,16 +5686,10 @@
                 <a:solidFill>
                   <a:srgbClr val="2B2D42"/>
                 </a:solidFill>
-                <a:latin typeface="Calibri" panose="020F0502020204030204"/>
+                <a:latin typeface="Calibri"/>
               </a:rPr>
               <a:t>•  Discussion</a:t>
             </a:r>
-            <a:endParaRPr sz="1800" b="1" i="0">
-              <a:solidFill>
-                <a:srgbClr val="2B2D42"/>
-              </a:solidFill>
-              <a:latin typeface="Calibri" panose="020F0502020204030204"/>
-            </a:endParaRPr>
           </a:p>
           <a:p>
             <a:pPr>
@@ -5870,16 +5705,10 @@
                 <a:solidFill>
                   <a:srgbClr val="2B2D42"/>
                 </a:solidFill>
-                <a:latin typeface="Calibri" panose="020F0502020204030204"/>
+                <a:latin typeface="Calibri"/>
               </a:rPr>
               <a:t>•  Conclusions &amp; Next Steps</a:t>
             </a:r>
-            <a:endParaRPr sz="1800" b="1" i="0">
-              <a:solidFill>
-                <a:srgbClr val="2B2D42"/>
-              </a:solidFill>
-              <a:latin typeface="Calibri" panose="020F0502020204030204"/>
-            </a:endParaRPr>
           </a:p>
         </p:txBody>
       </p:sp>
@@ -5954,16 +5783,10 @@
                 <a:solidFill>
                   <a:srgbClr val="FFFFFF"/>
                 </a:solidFill>
-                <a:latin typeface="Calibri" panose="020F0502020204030204"/>
+                <a:latin typeface="Calibri"/>
               </a:rPr>
               <a:t>Umubyeyi  ·  Kinyarwanda Maternal Mental-Wellness Chatbot  ·  R. Irutingabo (ALU)</a:t>
             </a:r>
-            <a:endParaRPr sz="900" b="0" i="0">
-              <a:solidFill>
-                <a:srgbClr val="FFFFFF"/>
-              </a:solidFill>
-              <a:latin typeface="Calibri" panose="020F0502020204030204"/>
-            </a:endParaRPr>
           </a:p>
         </p:txBody>
       </p:sp>
@@ -5995,16 +5818,10 @@
                 <a:solidFill>
                   <a:srgbClr val="FFFFFF"/>
                 </a:solidFill>
-                <a:latin typeface="Calibri" panose="020F0502020204030204"/>
+                <a:latin typeface="Calibri"/>
               </a:rPr>
               <a:t>2</a:t>
             </a:r>
-            <a:endParaRPr sz="900" b="0" i="0">
-              <a:solidFill>
-                <a:srgbClr val="FFFFFF"/>
-              </a:solidFill>
-              <a:latin typeface="Calibri" panose="020F0502020204030204"/>
-            </a:endParaRPr>
           </a:p>
         </p:txBody>
       </p:sp>
@@ -6017,7 +5834,7 @@
 </file>
 
 <file path=ppt/slides/slide3.xml><?xml version="1.0" encoding="utf-8"?>
-<p:sld xmlns:a="http://schemas.openxmlformats.org/drawingml/2006/main" xmlns:r="http://schemas.openxmlformats.org/officeDocument/2006/relationships" xmlns:p="http://schemas.openxmlformats.org/presentationml/2006/main">
+<p:sld xmlns:a="http://schemas.openxmlformats.org/drawingml/2006/main" xmlns:p="http://schemas.openxmlformats.org/presentationml/2006/main" xmlns:r="http://schemas.openxmlformats.org/officeDocument/2006/relationships">
   <p:cSld>
     <p:spTree>
       <p:nvGrpSpPr>
@@ -6141,16 +5958,10 @@
                 <a:solidFill>
                   <a:srgbClr val="E76F51"/>
                 </a:solidFill>
-                <a:latin typeface="Calibri" panose="020F0502020204030204"/>
+                <a:latin typeface="Calibri"/>
               </a:rPr>
               <a:t>INTRODUCTION</a:t>
             </a:r>
-            <a:endParaRPr sz="1200" b="1" i="0">
-              <a:solidFill>
-                <a:srgbClr val="E76F51"/>
-              </a:solidFill>
-              <a:latin typeface="Calibri" panose="020F0502020204030204"/>
-            </a:endParaRPr>
           </a:p>
         </p:txBody>
       </p:sp>
@@ -6181,16 +5992,10 @@
                 <a:solidFill>
                   <a:srgbClr val="2B2D42"/>
                 </a:solidFill>
-                <a:latin typeface="Calibri" panose="020F0502020204030204"/>
+                <a:latin typeface="Calibri"/>
               </a:rPr>
               <a:t>What is Umubyeyi?</a:t>
             </a:r>
-            <a:endParaRPr sz="3000" b="1" i="0">
-              <a:solidFill>
-                <a:srgbClr val="2B2D42"/>
-              </a:solidFill>
-              <a:latin typeface="Calibri" panose="020F0502020204030204"/>
-            </a:endParaRPr>
           </a:p>
         </p:txBody>
       </p:sp>
@@ -6247,7 +6052,7 @@
         <p:spPr>
           <a:xfrm>
             <a:off x="548640" y="1783080"/>
-            <a:ext cx="6675120" cy="2384425"/>
+            <a:ext cx="6675120" cy="4480560"/>
           </a:xfrm>
           <a:prstGeom prst="rect">
             <a:avLst/>
@@ -6273,16 +6078,10 @@
                 <a:solidFill>
                   <a:srgbClr val="2B2D42"/>
                 </a:solidFill>
-                <a:latin typeface="Calibri" panose="020F0502020204030204"/>
+                <a:latin typeface="Calibri"/>
               </a:rPr>
               <a:t>•  A browser-based chatbot that talks to first-time Rwandan mothers in Kinyarwanda about their mental wellbeing.</a:t>
             </a:r>
-            <a:endParaRPr sz="1700" b="1" i="0">
-              <a:solidFill>
-                <a:srgbClr val="2B2D42"/>
-              </a:solidFill>
-              <a:latin typeface="Calibri" panose="020F0502020204030204"/>
-            </a:endParaRPr>
           </a:p>
           <a:p>
             <a:pPr>
@@ -6298,16 +6097,10 @@
                 <a:solidFill>
                   <a:srgbClr val="2B2D42"/>
                 </a:solidFill>
-                <a:latin typeface="Calibri" panose="020F0502020204030204"/>
-              </a:rPr>
-              <a:t>•  Scope: the 0–6 month postpartum window </a:t>
-            </a:r>
-            <a:endParaRPr sz="1700" b="1" i="0">
-              <a:solidFill>
-                <a:srgbClr val="2B2D42"/>
-              </a:solidFill>
-              <a:latin typeface="Calibri" panose="020F0502020204030204"/>
-            </a:endParaRPr>
+                <a:latin typeface="Calibri"/>
+              </a:rPr>
+              <a:t>•  Scope: the 0–6 month postpartum window — when low mood, anxiety and feeling overwhelmed peak.</a:t>
+            </a:r>
           </a:p>
           <a:p>
             <a:pPr>
@@ -6323,34 +6116,10 @@
                 <a:solidFill>
                   <a:srgbClr val="2B2D42"/>
                 </a:solidFill>
-                <a:latin typeface="Calibri" panose="020F0502020204030204"/>
-              </a:rPr>
-              <a:t>•  Informational and supportive</a:t>
-            </a:r>
-            <a:r>
-              <a:rPr lang="en-US" sz="1700" b="1" i="0">
-                <a:solidFill>
-                  <a:srgbClr val="2B2D42"/>
-                </a:solidFill>
-                <a:latin typeface="Calibri" panose="020F0502020204030204"/>
-              </a:rPr>
-              <a:t> </a:t>
-            </a:r>
-            <a:r>
-              <a:rPr sz="1700" b="1" i="0">
-                <a:solidFill>
-                  <a:srgbClr val="2B2D42"/>
-                </a:solidFill>
-                <a:latin typeface="Calibri" panose="020F0502020204030204"/>
-              </a:rPr>
-              <a:t>never diagnostic. Every reply carries a disclaimer and a safety pathway.</a:t>
-            </a:r>
-            <a:endParaRPr sz="1700" b="1" i="0">
-              <a:solidFill>
-                <a:srgbClr val="2B2D42"/>
-              </a:solidFill>
-              <a:latin typeface="Calibri" panose="020F0502020204030204"/>
-            </a:endParaRPr>
+                <a:latin typeface="Calibri"/>
+              </a:rPr>
+              <a:t>•  Informational and supportive — never diagnostic. Every reply carries a disclaimer and a safety pathway.</a:t>
+            </a:r>
           </a:p>
           <a:p>
             <a:pPr>
@@ -6366,16 +6135,29 @@
                 <a:solidFill>
                   <a:srgbClr val="2B2D42"/>
                 </a:solidFill>
-                <a:latin typeface="Calibri" panose="020F0502020204030204"/>
+                <a:latin typeface="Calibri"/>
               </a:rPr>
               <a:t>•  Template-based, not generative: each intent maps to one guideline-sourced, human-reviewed response template (avoids LLM hallucination).</a:t>
             </a:r>
-            <a:endParaRPr sz="1700" b="1" i="0">
-              <a:solidFill>
-                <a:srgbClr val="2B2D42"/>
-              </a:solidFill>
-              <a:latin typeface="Calibri" panose="020F0502020204030204"/>
-            </a:endParaRPr>
+          </a:p>
+          <a:p>
+            <a:pPr>
+              <a:spcBef>
+                <a:spcPts val="200"/>
+              </a:spcBef>
+              <a:spcAft>
+                <a:spcPts val="1000"/>
+              </a:spcAft>
+            </a:pPr>
+            <a:r>
+              <a:rPr sz="1700" b="1" i="0">
+                <a:solidFill>
+                  <a:srgbClr val="2B2D42"/>
+                </a:solidFill>
+                <a:latin typeface="Calibri"/>
+              </a:rPr>
+              <a:t>•  Designed for low-resource deployment — classical ML, no GPU at inference, runs on Streamlit Community Cloud.</a:t>
+            </a:r>
           </a:p>
         </p:txBody>
       </p:sp>
@@ -6450,16 +6232,10 @@
                 <a:solidFill>
                   <a:srgbClr val="E76F51"/>
                 </a:solidFill>
-                <a:latin typeface="Calibri" panose="020F0502020204030204"/>
+                <a:latin typeface="Calibri"/>
               </a:rPr>
               <a:t>In one sentence</a:t>
             </a:r>
-            <a:endParaRPr sz="1400" b="1" i="0">
-              <a:solidFill>
-                <a:srgbClr val="E76F51"/>
-              </a:solidFill>
-              <a:latin typeface="Calibri" panose="020F0502020204030204"/>
-            </a:endParaRPr>
           </a:p>
           <a:p>
             <a:pPr>
@@ -6472,16 +6248,10 @@
                 <a:solidFill>
                   <a:srgbClr val="2B2D42"/>
                 </a:solidFill>
-                <a:latin typeface="Calibri" panose="020F0502020204030204"/>
+                <a:latin typeface="Calibri"/>
               </a:rPr>
               <a:t>“Meet mothers in their own language, route them to safe, expert-validated guidance, and measure exactly what translation costs us along the way.”</a:t>
             </a:r>
-            <a:endParaRPr sz="1600" b="0" i="1">
-              <a:solidFill>
-                <a:srgbClr val="2B2D42"/>
-              </a:solidFill>
-              <a:latin typeface="Calibri" panose="020F0502020204030204"/>
-            </a:endParaRPr>
           </a:p>
         </p:txBody>
       </p:sp>
@@ -6556,16 +6326,10 @@
                 <a:solidFill>
                   <a:srgbClr val="FFFFFF"/>
                 </a:solidFill>
-                <a:latin typeface="Calibri" panose="020F0502020204030204"/>
+                <a:latin typeface="Calibri"/>
               </a:rPr>
               <a:t>Umubyeyi  ·  Kinyarwanda Maternal Mental-Wellness Chatbot  ·  R. Irutingabo (ALU)</a:t>
             </a:r>
-            <a:endParaRPr sz="900" b="0" i="0">
-              <a:solidFill>
-                <a:srgbClr val="FFFFFF"/>
-              </a:solidFill>
-              <a:latin typeface="Calibri" panose="020F0502020204030204"/>
-            </a:endParaRPr>
           </a:p>
         </p:txBody>
       </p:sp>
@@ -6597,16 +6361,10 @@
                 <a:solidFill>
                   <a:srgbClr val="FFFFFF"/>
                 </a:solidFill>
-                <a:latin typeface="Calibri" panose="020F0502020204030204"/>
+                <a:latin typeface="Calibri"/>
               </a:rPr>
               <a:t>3</a:t>
             </a:r>
-            <a:endParaRPr sz="900" b="0" i="0">
-              <a:solidFill>
-                <a:srgbClr val="FFFFFF"/>
-              </a:solidFill>
-              <a:latin typeface="Calibri" panose="020F0502020204030204"/>
-            </a:endParaRPr>
           </a:p>
         </p:txBody>
       </p:sp>
@@ -6619,7 +6377,7 @@
 </file>
 
 <file path=ppt/slides/slide4.xml><?xml version="1.0" encoding="utf-8"?>
-<p:sld xmlns:a="http://schemas.openxmlformats.org/drawingml/2006/main" xmlns:r="http://schemas.openxmlformats.org/officeDocument/2006/relationships" xmlns:p="http://schemas.openxmlformats.org/presentationml/2006/main">
+<p:sld xmlns:a="http://schemas.openxmlformats.org/drawingml/2006/main" xmlns:p="http://schemas.openxmlformats.org/presentationml/2006/main" xmlns:r="http://schemas.openxmlformats.org/officeDocument/2006/relationships">
   <p:cSld>
     <p:spTree>
       <p:nvGrpSpPr>
@@ -6743,16 +6501,10 @@
                 <a:solidFill>
                   <a:srgbClr val="E76F51"/>
                 </a:solidFill>
-                <a:latin typeface="Calibri" panose="020F0502020204030204"/>
+                <a:latin typeface="Calibri"/>
               </a:rPr>
               <a:t>THE NEED</a:t>
             </a:r>
-            <a:endParaRPr sz="1200" b="1" i="0">
-              <a:solidFill>
-                <a:srgbClr val="E76F51"/>
-              </a:solidFill>
-              <a:latin typeface="Calibri" panose="020F0502020204030204"/>
-            </a:endParaRPr>
           </a:p>
         </p:txBody>
       </p:sp>
@@ -6783,16 +6535,10 @@
                 <a:solidFill>
                   <a:srgbClr val="2B2D42"/>
                 </a:solidFill>
-                <a:latin typeface="Calibri" panose="020F0502020204030204"/>
+                <a:latin typeface="Calibri"/>
               </a:rPr>
               <a:t>Why this matters</a:t>
             </a:r>
-            <a:endParaRPr sz="3000" b="1" i="0">
-              <a:solidFill>
-                <a:srgbClr val="2B2D42"/>
-              </a:solidFill>
-              <a:latin typeface="Calibri" panose="020F0502020204030204"/>
-            </a:endParaRPr>
           </a:p>
         </p:txBody>
       </p:sp>
@@ -6849,7 +6595,7 @@
         <p:spPr>
           <a:xfrm>
             <a:off x="548640" y="1783080"/>
-            <a:ext cx="10515600" cy="2122805"/>
+            <a:ext cx="10515600" cy="4480560"/>
           </a:xfrm>
           <a:prstGeom prst="rect">
             <a:avLst/>
@@ -6875,16 +6621,10 @@
                 <a:solidFill>
                   <a:srgbClr val="2B2D42"/>
                 </a:solidFill>
-                <a:latin typeface="Calibri" panose="020F0502020204030204"/>
+                <a:latin typeface="Calibri"/>
               </a:rPr>
               <a:t>•  Perinatal mental-health conditions are common and under-served in sub-Saharan Africa, yet rarely screened in routine postpartum care.</a:t>
             </a:r>
-            <a:endParaRPr sz="1700" b="1" i="0">
-              <a:solidFill>
-                <a:srgbClr val="2B2D42"/>
-              </a:solidFill>
-              <a:latin typeface="Calibri" panose="020F0502020204030204"/>
-            </a:endParaRPr>
           </a:p>
           <a:p>
             <a:pPr>
@@ -6900,16 +6640,10 @@
                 <a:solidFill>
                   <a:srgbClr val="2B2D42"/>
                 </a:solidFill>
-                <a:latin typeface="Calibri" panose="020F0502020204030204"/>
+                <a:latin typeface="Calibri"/>
               </a:rPr>
               <a:t>•  First-time mothers face the steepest adjustment, often in isolation and without a safe, private place to ask questions.</a:t>
             </a:r>
-            <a:endParaRPr sz="1700" b="1" i="0">
-              <a:solidFill>
-                <a:srgbClr val="2B2D42"/>
-              </a:solidFill>
-              <a:latin typeface="Calibri" panose="020F0502020204030204"/>
-            </a:endParaRPr>
           </a:p>
           <a:p>
             <a:pPr>
@@ -6925,16 +6659,10 @@
                 <a:solidFill>
                   <a:srgbClr val="2B2D42"/>
                 </a:solidFill>
-                <a:latin typeface="Calibri" panose="020F0502020204030204"/>
+                <a:latin typeface="Calibri"/>
               </a:rPr>
               <a:t>•  Language is the barrier: almost all digital maternal-health tools are English-only.</a:t>
             </a:r>
-            <a:endParaRPr sz="1700" b="1" i="0">
-              <a:solidFill>
-                <a:srgbClr val="2B2D42"/>
-              </a:solidFill>
-              <a:latin typeface="Calibri" panose="020F0502020204030204"/>
-            </a:endParaRPr>
           </a:p>
           <a:p>
             <a:pPr>
@@ -6950,16 +6678,29 @@
                 <a:solidFill>
                   <a:srgbClr val="2B2D42"/>
                 </a:solidFill>
-                <a:latin typeface="Calibri" panose="020F0502020204030204"/>
-              </a:rPr>
-              <a:t>.</a:t>
-            </a:r>
-            <a:endParaRPr sz="1700" b="1" i="0">
-              <a:solidFill>
-                <a:srgbClr val="2B2D42"/>
-              </a:solidFill>
-              <a:latin typeface="Calibri" panose="020F0502020204030204"/>
-            </a:endParaRPr>
+                <a:latin typeface="Calibri"/>
+              </a:rPr>
+              <a:t>•  Kinyarwanda is severely under-resourced in NLP — no public mental-wellness intent dataset exists.</a:t>
+            </a:r>
+          </a:p>
+          <a:p>
+            <a:pPr>
+              <a:spcBef>
+                <a:spcPts val="200"/>
+              </a:spcBef>
+              <a:spcAft>
+                <a:spcPts val="1000"/>
+              </a:spcAft>
+            </a:pPr>
+            <a:r>
+              <a:rPr sz="1700" b="1" i="0">
+                <a:solidFill>
+                  <a:srgbClr val="2B2D42"/>
+                </a:solidFill>
+                <a:latin typeface="Calibri"/>
+              </a:rPr>
+              <a:t>•  Existing maternal-health chatbots are English-only and physical-health focused, and name translation as an unsolved limitation.</a:t>
+            </a:r>
           </a:p>
         </p:txBody>
       </p:sp>
@@ -7034,16 +6775,10 @@
                 <a:solidFill>
                   <a:srgbClr val="FFFFFF"/>
                 </a:solidFill>
-                <a:latin typeface="Calibri" panose="020F0502020204030204"/>
+                <a:latin typeface="Calibri"/>
               </a:rPr>
               <a:t>The gap = Kinyarwanda  ×  mental wellness  ×  Rwanda  —  exactly where Umubyeyi sits.</a:t>
             </a:r>
-            <a:endParaRPr sz="1600" b="1" i="0">
-              <a:solidFill>
-                <a:srgbClr val="FFFFFF"/>
-              </a:solidFill>
-              <a:latin typeface="Calibri" panose="020F0502020204030204"/>
-            </a:endParaRPr>
           </a:p>
         </p:txBody>
       </p:sp>
@@ -7118,16 +6853,10 @@
                 <a:solidFill>
                   <a:srgbClr val="FFFFFF"/>
                 </a:solidFill>
-                <a:latin typeface="Calibri" panose="020F0502020204030204"/>
+                <a:latin typeface="Calibri"/>
               </a:rPr>
               <a:t>Umubyeyi  ·  Kinyarwanda Maternal Mental-Wellness Chatbot  ·  R. Irutingabo (ALU)</a:t>
             </a:r>
-            <a:endParaRPr sz="900" b="0" i="0">
-              <a:solidFill>
-                <a:srgbClr val="FFFFFF"/>
-              </a:solidFill>
-              <a:latin typeface="Calibri" panose="020F0502020204030204"/>
-            </a:endParaRPr>
           </a:p>
         </p:txBody>
       </p:sp>
@@ -7159,16 +6888,10 @@
                 <a:solidFill>
                   <a:srgbClr val="FFFFFF"/>
                 </a:solidFill>
-                <a:latin typeface="Calibri" panose="020F0502020204030204"/>
+                <a:latin typeface="Calibri"/>
               </a:rPr>
               <a:t>4</a:t>
             </a:r>
-            <a:endParaRPr sz="900" b="0" i="0">
-              <a:solidFill>
-                <a:srgbClr val="FFFFFF"/>
-              </a:solidFill>
-              <a:latin typeface="Calibri" panose="020F0502020204030204"/>
-            </a:endParaRPr>
           </a:p>
         </p:txBody>
       </p:sp>
@@ -7181,7 +6904,7 @@
 </file>
 
 <file path=ppt/slides/slide5.xml><?xml version="1.0" encoding="utf-8"?>
-<p:sld xmlns:a="http://schemas.openxmlformats.org/drawingml/2006/main" xmlns:r="http://schemas.openxmlformats.org/officeDocument/2006/relationships" xmlns:p="http://schemas.openxmlformats.org/presentationml/2006/main">
+<p:sld xmlns:a="http://schemas.openxmlformats.org/drawingml/2006/main" xmlns:p="http://schemas.openxmlformats.org/presentationml/2006/main" xmlns:r="http://schemas.openxmlformats.org/officeDocument/2006/relationships">
   <p:cSld>
     <p:spTree>
       <p:nvGrpSpPr>
@@ -7305,16 +7028,10 @@
                 <a:solidFill>
                   <a:srgbClr val="E76F51"/>
                 </a:solidFill>
-                <a:latin typeface="Calibri" panose="020F0502020204030204"/>
+                <a:latin typeface="Calibri"/>
               </a:rPr>
               <a:t>DATA</a:t>
             </a:r>
-            <a:endParaRPr sz="1200" b="1" i="0">
-              <a:solidFill>
-                <a:srgbClr val="E76F51"/>
-              </a:solidFill>
-              <a:latin typeface="Calibri" panose="020F0502020204030204"/>
-            </a:endParaRPr>
           </a:p>
         </p:txBody>
       </p:sp>
@@ -7345,16 +7062,10 @@
                 <a:solidFill>
                   <a:srgbClr val="2B2D42"/>
                 </a:solidFill>
-                <a:latin typeface="Calibri" panose="020F0502020204030204"/>
-              </a:rPr>
-              <a:t>Three data sources, three distinct roles</a:t>
-            </a:r>
-            <a:endParaRPr sz="3000" b="1" i="0">
-              <a:solidFill>
-                <a:srgbClr val="2B2D42"/>
-              </a:solidFill>
-              <a:latin typeface="Calibri" panose="020F0502020204030204"/>
-            </a:endParaRPr>
+                <a:latin typeface="Calibri"/>
+              </a:rPr>
+              <a:t>Two data sources, two distinct roles</a:t>
+            </a:r>
           </a:p>
         </p:txBody>
       </p:sp>
@@ -7517,16 +7228,10 @@
                 <a:solidFill>
                   <a:srgbClr val="FFFFFF"/>
                 </a:solidFill>
-                <a:latin typeface="Calibri" panose="020F0502020204030204"/>
+                <a:latin typeface="Calibri"/>
               </a:rPr>
               <a:t>TRAINING DATA</a:t>
             </a:r>
-            <a:endParaRPr sz="1100" b="1" i="0">
-              <a:solidFill>
-                <a:srgbClr val="FFFFFF"/>
-              </a:solidFill>
-              <a:latin typeface="Calibri" panose="020F0502020204030204"/>
-            </a:endParaRPr>
           </a:p>
         </p:txBody>
       </p:sp>
@@ -7557,16 +7262,10 @@
                 <a:solidFill>
                   <a:srgbClr val="2B2D42"/>
                 </a:solidFill>
-                <a:latin typeface="Calibri" panose="020F0502020204030204"/>
+                <a:latin typeface="Calibri"/>
               </a:rPr>
               <a:t>Amod counseling Q&amp;A</a:t>
             </a:r>
-            <a:endParaRPr sz="1600" b="1" i="0">
-              <a:solidFill>
-                <a:srgbClr val="2B2D42"/>
-              </a:solidFill>
-              <a:latin typeface="Calibri" panose="020F0502020204030204"/>
-            </a:endParaRPr>
           </a:p>
         </p:txBody>
       </p:sp>
@@ -7602,16 +7301,10 @@
                 <a:solidFill>
                   <a:srgbClr val="55576B"/>
                 </a:solidFill>
-                <a:latin typeface="Calibri" panose="020F0502020204030204"/>
+                <a:latin typeface="Calibri"/>
               </a:rPr>
               <a:t>•  3,512 rows of real therapist Q&amp;A</a:t>
             </a:r>
-            <a:endParaRPr sz="1300" b="0" i="0">
-              <a:solidFill>
-                <a:srgbClr val="55576B"/>
-              </a:solidFill>
-              <a:latin typeface="Calibri" panose="020F0502020204030204"/>
-            </a:endParaRPr>
           </a:p>
           <a:p>
             <a:pPr>
@@ -7624,16 +7317,10 @@
                 <a:solidFill>
                   <a:srgbClr val="55576B"/>
                 </a:solidFill>
-                <a:latin typeface="Calibri" panose="020F0502020204030204"/>
+                <a:latin typeface="Calibri"/>
               </a:rPr>
               <a:t>•  995 unique questions (heavy duplication)</a:t>
             </a:r>
-            <a:endParaRPr sz="1300" b="0" i="0">
-              <a:solidFill>
-                <a:srgbClr val="55576B"/>
-              </a:solidFill>
-              <a:latin typeface="Calibri" panose="020F0502020204030204"/>
-            </a:endParaRPr>
           </a:p>
           <a:p>
             <a:pPr>
@@ -7646,16 +7333,10 @@
                 <a:solidFill>
                   <a:srgbClr val="55576B"/>
                 </a:solidFill>
-                <a:latin typeface="Calibri" panose="020F0502020204030204"/>
+                <a:latin typeface="Calibri"/>
               </a:rPr>
               <a:t>•  Filtered to maternal-relevant subset</a:t>
             </a:r>
-            <a:endParaRPr sz="1300" b="0" i="0">
-              <a:solidFill>
-                <a:srgbClr val="55576B"/>
-              </a:solidFill>
-              <a:latin typeface="Calibri" panose="020F0502020204030204"/>
-            </a:endParaRPr>
           </a:p>
           <a:p>
             <a:pPr>
@@ -7668,16 +7349,10 @@
                 <a:solidFill>
                   <a:srgbClr val="55576B"/>
                 </a:solidFill>
-                <a:latin typeface="Calibri" panose="020F0502020204030204"/>
+                <a:latin typeface="Calibri"/>
               </a:rPr>
               <a:t>•  Labeled into 6 wellness intents</a:t>
             </a:r>
-            <a:endParaRPr sz="1300" b="0" i="0">
-              <a:solidFill>
-                <a:srgbClr val="55576B"/>
-              </a:solidFill>
-              <a:latin typeface="Calibri" panose="020F0502020204030204"/>
-            </a:endParaRPr>
           </a:p>
         </p:txBody>
       </p:sp>
@@ -7740,285 +7415,6 @@
             <a:avLst/>
           </a:prstGeom>
           <a:solidFill>
-            <a:srgbClr val="9B8BC4"/>
-          </a:solidFill>
-          <a:ln>
-            <a:noFill/>
-          </a:ln>
-          <a:effectLst/>
-        </p:spPr>
-        <p:style>
-          <a:lnRef idx="1">
-            <a:schemeClr val="accent1"/>
-          </a:lnRef>
-          <a:fillRef idx="3">
-            <a:schemeClr val="accent1"/>
-          </a:fillRef>
-          <a:effectRef idx="2">
-            <a:schemeClr val="accent1"/>
-          </a:effectRef>
-          <a:fontRef idx="minor">
-            <a:schemeClr val="lt1"/>
-          </a:fontRef>
-        </p:style>
-        <p:txBody>
-          <a:bodyPr rtlCol="0" anchor="ctr"/>
-          <a:lstStyle/>
-          <a:p>
-            <a:pPr algn="ctr"/>
-          </a:p>
-        </p:txBody>
-      </p:sp>
-      <p:sp>
-        <p:nvSpPr>
-          <p:cNvPr id="14" name="TextBox 13"/>
-          <p:cNvSpPr txBox="1"/>
-          <p:nvPr/>
-        </p:nvSpPr>
-        <p:spPr>
-          <a:xfrm>
-            <a:off x="4434840" y="1856232"/>
-            <a:ext cx="3337560" cy="457200"/>
-          </a:xfrm>
-          <a:prstGeom prst="rect">
-            <a:avLst/>
-          </a:prstGeom>
-          <a:noFill/>
-        </p:spPr>
-        <p:txBody>
-          <a:bodyPr wrap="square" anchor="ctr">
-            <a:spAutoFit/>
-          </a:bodyPr>
-          <a:lstStyle/>
-          <a:p>
-            <a:r>
-              <a:rPr sz="1100" b="1" i="0">
-                <a:solidFill>
-                  <a:srgbClr val="FFFFFF"/>
-                </a:solidFill>
-                <a:latin typeface="Calibri" panose="020F0502020204030204"/>
-              </a:rPr>
-              <a:t>FRAMING / LIT REVIEW</a:t>
-            </a:r>
-            <a:endParaRPr sz="1100" b="1" i="0">
-              <a:solidFill>
-                <a:srgbClr val="FFFFFF"/>
-              </a:solidFill>
-              <a:latin typeface="Calibri" panose="020F0502020204030204"/>
-            </a:endParaRPr>
-          </a:p>
-        </p:txBody>
-      </p:sp>
-      <p:sp>
-        <p:nvSpPr>
-          <p:cNvPr id="15" name="TextBox 14"/>
-          <p:cNvSpPr txBox="1"/>
-          <p:nvPr/>
-        </p:nvSpPr>
-        <p:spPr>
-          <a:xfrm>
-            <a:off x="4480560" y="2468880"/>
-            <a:ext cx="3246120" cy="640080"/>
-          </a:xfrm>
-          <a:prstGeom prst="rect">
-            <a:avLst/>
-          </a:prstGeom>
-          <a:noFill/>
-        </p:spPr>
-        <p:txBody>
-          <a:bodyPr wrap="square" anchor="t">
-            <a:spAutoFit/>
-          </a:bodyPr>
-          <a:lstStyle/>
-          <a:p>
-            <a:r>
-              <a:rPr sz="1600" b="1" i="0">
-                <a:solidFill>
-                  <a:srgbClr val="2B2D42"/>
-                </a:solidFill>
-                <a:latin typeface="Calibri" panose="020F0502020204030204"/>
-              </a:rPr>
-              <a:t>MOTHER dataset (Uganda)</a:t>
-            </a:r>
-            <a:endParaRPr sz="1600" b="1" i="0">
-              <a:solidFill>
-                <a:srgbClr val="2B2D42"/>
-              </a:solidFill>
-              <a:latin typeface="Calibri" panose="020F0502020204030204"/>
-            </a:endParaRPr>
-          </a:p>
-        </p:txBody>
-      </p:sp>
-      <p:sp>
-        <p:nvSpPr>
-          <p:cNvPr id="16" name="TextBox 15"/>
-          <p:cNvSpPr txBox="1"/>
-          <p:nvPr/>
-        </p:nvSpPr>
-        <p:spPr>
-          <a:xfrm>
-            <a:off x="4480560" y="3154680"/>
-            <a:ext cx="3246120" cy="2560320"/>
-          </a:xfrm>
-          <a:prstGeom prst="rect">
-            <a:avLst/>
-          </a:prstGeom>
-          <a:noFill/>
-        </p:spPr>
-        <p:txBody>
-          <a:bodyPr wrap="square" anchor="t">
-            <a:spAutoFit/>
-          </a:bodyPr>
-          <a:lstStyle/>
-          <a:p>
-            <a:pPr>
-              <a:spcAft>
-                <a:spcPts val="700"/>
-              </a:spcAft>
-            </a:pPr>
-            <a:r>
-              <a:rPr sz="1300" b="0" i="0">
-                <a:solidFill>
-                  <a:srgbClr val="55576B"/>
-                </a:solidFill>
-                <a:latin typeface="Calibri" panose="020F0502020204030204"/>
-              </a:rPr>
-              <a:t>•  503 maternal-health Q&amp;A, CC BY 4.0</a:t>
-            </a:r>
-            <a:endParaRPr sz="1300" b="0" i="0">
-              <a:solidFill>
-                <a:srgbClr val="55576B"/>
-              </a:solidFill>
-              <a:latin typeface="Calibri" panose="020F0502020204030204"/>
-            </a:endParaRPr>
-          </a:p>
-          <a:p>
-            <a:pPr>
-              <a:spcAft>
-                <a:spcPts val="700"/>
-              </a:spcAft>
-            </a:pPr>
-            <a:r>
-              <a:rPr sz="1300" b="0" i="0">
-                <a:solidFill>
-                  <a:srgbClr val="55576B"/>
-                </a:solidFill>
-                <a:latin typeface="Calibri" panose="020F0502020204030204"/>
-              </a:rPr>
-              <a:t>•  English-only, physical health only</a:t>
-            </a:r>
-            <a:endParaRPr sz="1300" b="0" i="0">
-              <a:solidFill>
-                <a:srgbClr val="55576B"/>
-              </a:solidFill>
-              <a:latin typeface="Calibri" panose="020F0502020204030204"/>
-            </a:endParaRPr>
-          </a:p>
-          <a:p>
-            <a:pPr>
-              <a:spcAft>
-                <a:spcPts val="700"/>
-              </a:spcAft>
-            </a:pPr>
-            <a:r>
-              <a:rPr sz="1300" b="0" i="0">
-                <a:solidFill>
-                  <a:srgbClr val="55576B"/>
-                </a:solidFill>
-                <a:latin typeface="Calibri" panose="020F0502020204030204"/>
-              </a:rPr>
-              <a:t>•  Cited to frame the research gap</a:t>
-            </a:r>
-            <a:endParaRPr sz="1300" b="0" i="0">
-              <a:solidFill>
-                <a:srgbClr val="55576B"/>
-              </a:solidFill>
-              <a:latin typeface="Calibri" panose="020F0502020204030204"/>
-            </a:endParaRPr>
-          </a:p>
-          <a:p>
-            <a:pPr>
-              <a:spcAft>
-                <a:spcPts val="700"/>
-              </a:spcAft>
-            </a:pPr>
-            <a:r>
-              <a:rPr sz="1300" b="0" i="0">
-                <a:solidFill>
-                  <a:srgbClr val="55576B"/>
-                </a:solidFill>
-                <a:latin typeface="Calibri" panose="020F0502020204030204"/>
-              </a:rPr>
-              <a:t>•  NOT used for training or the KB</a:t>
-            </a:r>
-            <a:endParaRPr sz="1300" b="0" i="0">
-              <a:solidFill>
-                <a:srgbClr val="55576B"/>
-              </a:solidFill>
-              <a:latin typeface="Calibri" panose="020F0502020204030204"/>
-            </a:endParaRPr>
-          </a:p>
-        </p:txBody>
-      </p:sp>
-      <p:sp>
-        <p:nvSpPr>
-          <p:cNvPr id="17" name="Rectangle 16"/>
-          <p:cNvSpPr/>
-          <p:nvPr/>
-        </p:nvSpPr>
-        <p:spPr>
-          <a:xfrm>
-            <a:off x="8092440" y="1828800"/>
-            <a:ext cx="3611880" cy="4023360"/>
-          </a:xfrm>
-          <a:prstGeom prst="rect">
-            <a:avLst/>
-          </a:prstGeom>
-          <a:solidFill>
-            <a:srgbClr val="F6F5FA"/>
-          </a:solidFill>
-          <a:ln>
-            <a:noFill/>
-          </a:ln>
-          <a:effectLst/>
-        </p:spPr>
-        <p:style>
-          <a:lnRef idx="1">
-            <a:schemeClr val="accent1"/>
-          </a:lnRef>
-          <a:fillRef idx="3">
-            <a:schemeClr val="accent1"/>
-          </a:fillRef>
-          <a:effectRef idx="2">
-            <a:schemeClr val="accent1"/>
-          </a:effectRef>
-          <a:fontRef idx="minor">
-            <a:schemeClr val="lt1"/>
-          </a:fontRef>
-        </p:style>
-        <p:txBody>
-          <a:bodyPr rtlCol="0" anchor="ctr"/>
-          <a:lstStyle/>
-          <a:p>
-            <a:pPr algn="ctr"/>
-          </a:p>
-        </p:txBody>
-      </p:sp>
-      <p:sp>
-        <p:nvSpPr>
-          <p:cNvPr id="18" name="Rectangle 17"/>
-          <p:cNvSpPr/>
-          <p:nvPr/>
-        </p:nvSpPr>
-        <p:spPr>
-          <a:xfrm>
-            <a:off x="8092440" y="1828800"/>
-            <a:ext cx="3611880" cy="502920"/>
-          </a:xfrm>
-          <a:prstGeom prst="rect">
-            <a:avLst/>
-          </a:prstGeom>
-          <a:solidFill>
             <a:srgbClr val="E76F51"/>
           </a:solidFill>
           <a:ln>
@@ -8050,13 +7446,13 @@
       </p:sp>
       <p:sp>
         <p:nvSpPr>
-          <p:cNvPr id="19" name="TextBox 18"/>
+          <p:cNvPr id="14" name="TextBox 13"/>
           <p:cNvSpPr txBox="1"/>
           <p:nvPr/>
         </p:nvSpPr>
         <p:spPr>
           <a:xfrm>
-            <a:off x="8229600" y="1856232"/>
+            <a:off x="4434840" y="1856232"/>
             <a:ext cx="3337560" cy="457200"/>
           </a:xfrm>
           <a:prstGeom prst="rect">
@@ -8075,28 +7471,22 @@
                 <a:solidFill>
                   <a:srgbClr val="FFFFFF"/>
                 </a:solidFill>
-                <a:latin typeface="Calibri" panose="020F0502020204030204"/>
+                <a:latin typeface="Calibri"/>
               </a:rPr>
               <a:t>RESPONSE TEMPLATES</a:t>
             </a:r>
-            <a:endParaRPr sz="1100" b="1" i="0">
-              <a:solidFill>
-                <a:srgbClr val="FFFFFF"/>
-              </a:solidFill>
-              <a:latin typeface="Calibri" panose="020F0502020204030204"/>
-            </a:endParaRPr>
-          </a:p>
-        </p:txBody>
-      </p:sp>
-      <p:sp>
-        <p:nvSpPr>
-          <p:cNvPr id="20" name="TextBox 19"/>
+          </a:p>
+        </p:txBody>
+      </p:sp>
+      <p:sp>
+        <p:nvSpPr>
+          <p:cNvPr id="15" name="TextBox 14"/>
           <p:cNvSpPr txBox="1"/>
           <p:nvPr/>
         </p:nvSpPr>
         <p:spPr>
           <a:xfrm>
-            <a:off x="8275320" y="2468880"/>
+            <a:off x="4480560" y="2468880"/>
             <a:ext cx="3246120" cy="640080"/>
           </a:xfrm>
           <a:prstGeom prst="rect">
@@ -8115,28 +7505,22 @@
                 <a:solidFill>
                   <a:srgbClr val="2B2D42"/>
                 </a:solidFill>
-                <a:latin typeface="Calibri" panose="020F0502020204030204"/>
+                <a:latin typeface="Calibri"/>
               </a:rPr>
               <a:t>WHO / UNFPA guidance</a:t>
             </a:r>
-            <a:endParaRPr sz="1600" b="1" i="0">
-              <a:solidFill>
-                <a:srgbClr val="2B2D42"/>
-              </a:solidFill>
-              <a:latin typeface="Calibri" panose="020F0502020204030204"/>
-            </a:endParaRPr>
-          </a:p>
-        </p:txBody>
-      </p:sp>
-      <p:sp>
-        <p:nvSpPr>
-          <p:cNvPr id="21" name="TextBox 20"/>
+          </a:p>
+        </p:txBody>
+      </p:sp>
+      <p:sp>
+        <p:nvSpPr>
+          <p:cNvPr id="16" name="TextBox 15"/>
           <p:cNvSpPr txBox="1"/>
           <p:nvPr/>
         </p:nvSpPr>
         <p:spPr>
           <a:xfrm>
-            <a:off x="8275320" y="3154680"/>
+            <a:off x="4480560" y="3154680"/>
             <a:ext cx="3246120" cy="2560320"/>
           </a:xfrm>
           <a:prstGeom prst="rect">
@@ -8160,16 +7544,10 @@
                 <a:solidFill>
                   <a:srgbClr val="55576B"/>
                 </a:solidFill>
-                <a:latin typeface="Calibri" panose="020F0502020204030204"/>
+                <a:latin typeface="Calibri"/>
               </a:rPr>
               <a:t>•  Tier-1 global authorities</a:t>
             </a:r>
-            <a:endParaRPr sz="1300" b="0" i="0">
-              <a:solidFill>
-                <a:srgbClr val="55576B"/>
-              </a:solidFill>
-              <a:latin typeface="Calibri" panose="020F0502020204030204"/>
-            </a:endParaRPr>
           </a:p>
           <a:p>
             <a:pPr>
@@ -8182,16 +7560,10 @@
                 <a:solidFill>
                   <a:srgbClr val="55576B"/>
                 </a:solidFill>
-                <a:latin typeface="Calibri" panose="020F0502020204030204"/>
+                <a:latin typeface="Calibri"/>
               </a:rPr>
               <a:t>•  Source of every user-facing answer</a:t>
             </a:r>
-            <a:endParaRPr sz="1300" b="0" i="0">
-              <a:solidFill>
-                <a:srgbClr val="55576B"/>
-              </a:solidFill>
-              <a:latin typeface="Calibri" panose="020F0502020204030204"/>
-            </a:endParaRPr>
           </a:p>
           <a:p>
             <a:pPr>
@@ -8204,16 +7576,10 @@
                 <a:solidFill>
                   <a:srgbClr val="55576B"/>
                 </a:solidFill>
-                <a:latin typeface="Calibri" panose="020F0502020204030204"/>
+                <a:latin typeface="Calibri"/>
               </a:rPr>
               <a:t>•  Pre-translated + human-reviewed</a:t>
             </a:r>
-            <a:endParaRPr sz="1300" b="0" i="0">
-              <a:solidFill>
-                <a:srgbClr val="55576B"/>
-              </a:solidFill>
-              <a:latin typeface="Calibri" panose="020F0502020204030204"/>
-            </a:endParaRPr>
           </a:p>
           <a:p>
             <a:pPr>
@@ -8226,22 +7592,16 @@
                 <a:solidFill>
                   <a:srgbClr val="55576B"/>
                 </a:solidFill>
-                <a:latin typeface="Calibri" panose="020F0502020204030204"/>
+                <a:latin typeface="Calibri"/>
               </a:rPr>
               <a:t>•  6 response templates (1 per intent)</a:t>
             </a:r>
-            <a:endParaRPr sz="1300" b="0" i="0">
-              <a:solidFill>
-                <a:srgbClr val="55576B"/>
-              </a:solidFill>
-              <a:latin typeface="Calibri" panose="020F0502020204030204"/>
-            </a:endParaRPr>
-          </a:p>
-        </p:txBody>
-      </p:sp>
-      <p:sp>
-        <p:nvSpPr>
-          <p:cNvPr id="22" name="Rectangle 21"/>
+          </a:p>
+        </p:txBody>
+      </p:sp>
+      <p:sp>
+        <p:nvSpPr>
+          <p:cNvPr id="17" name="Rectangle 16"/>
           <p:cNvSpPr/>
           <p:nvPr/>
         </p:nvSpPr>
@@ -8285,7 +7645,7 @@
       </p:sp>
       <p:sp>
         <p:nvSpPr>
-          <p:cNvPr id="23" name="TextBox 22"/>
+          <p:cNvPr id="18" name="TextBox 17"/>
           <p:cNvSpPr txBox="1"/>
           <p:nvPr/>
         </p:nvSpPr>
@@ -8310,22 +7670,16 @@
                 <a:solidFill>
                   <a:srgbClr val="FFFFFF"/>
                 </a:solidFill>
-                <a:latin typeface="Calibri" panose="020F0502020204030204"/>
+                <a:latin typeface="Calibri"/>
               </a:rPr>
               <a:t>Umubyeyi  ·  Kinyarwanda Maternal Mental-Wellness Chatbot  ·  R. Irutingabo (ALU)</a:t>
             </a:r>
-            <a:endParaRPr sz="900" b="0" i="0">
-              <a:solidFill>
-                <a:srgbClr val="FFFFFF"/>
-              </a:solidFill>
-              <a:latin typeface="Calibri" panose="020F0502020204030204"/>
-            </a:endParaRPr>
-          </a:p>
-        </p:txBody>
-      </p:sp>
-      <p:sp>
-        <p:nvSpPr>
-          <p:cNvPr id="24" name="TextBox 23"/>
+          </a:p>
+        </p:txBody>
+      </p:sp>
+      <p:sp>
+        <p:nvSpPr>
+          <p:cNvPr id="19" name="TextBox 18"/>
           <p:cNvSpPr txBox="1"/>
           <p:nvPr/>
         </p:nvSpPr>
@@ -8351,16 +7705,10 @@
                 <a:solidFill>
                   <a:srgbClr val="FFFFFF"/>
                 </a:solidFill>
-                <a:latin typeface="Calibri" panose="020F0502020204030204"/>
+                <a:latin typeface="Calibri"/>
               </a:rPr>
               <a:t>5</a:t>
             </a:r>
-            <a:endParaRPr sz="900" b="0" i="0">
-              <a:solidFill>
-                <a:srgbClr val="FFFFFF"/>
-              </a:solidFill>
-              <a:latin typeface="Calibri" panose="020F0502020204030204"/>
-            </a:endParaRPr>
           </a:p>
         </p:txBody>
       </p:sp>
@@ -8373,7 +7721,7 @@
 </file>
 
 <file path=ppt/slides/slide6.xml><?xml version="1.0" encoding="utf-8"?>
-<p:sld xmlns:a="http://schemas.openxmlformats.org/drawingml/2006/main" xmlns:r="http://schemas.openxmlformats.org/officeDocument/2006/relationships" xmlns:p="http://schemas.openxmlformats.org/presentationml/2006/main">
+<p:sld xmlns:a="http://schemas.openxmlformats.org/drawingml/2006/main" xmlns:p="http://schemas.openxmlformats.org/presentationml/2006/main" xmlns:r="http://schemas.openxmlformats.org/officeDocument/2006/relationships">
   <p:cSld>
     <p:spTree>
       <p:nvGrpSpPr>
@@ -8497,16 +7845,10 @@
                 <a:solidFill>
                   <a:srgbClr val="E76F51"/>
                 </a:solidFill>
-                <a:latin typeface="Calibri" panose="020F0502020204030204"/>
+                <a:latin typeface="Calibri"/>
               </a:rPr>
               <a:t>DATA PREPROCESSING &amp; EXPLORATION</a:t>
             </a:r>
-            <a:endParaRPr sz="1200" b="1" i="0">
-              <a:solidFill>
-                <a:srgbClr val="E76F51"/>
-              </a:solidFill>
-              <a:latin typeface="Calibri" panose="020F0502020204030204"/>
-            </a:endParaRPr>
           </a:p>
         </p:txBody>
       </p:sp>
@@ -8537,16 +7879,10 @@
                 <a:solidFill>
                   <a:srgbClr val="2B2D42"/>
                 </a:solidFill>
-                <a:latin typeface="Calibri" panose="020F0502020204030204"/>
+                <a:latin typeface="Calibri"/>
               </a:rPr>
               <a:t>What the data told us</a:t>
             </a:r>
-            <a:endParaRPr sz="3000" b="1" i="0">
-              <a:solidFill>
-                <a:srgbClr val="2B2D42"/>
-              </a:solidFill>
-              <a:latin typeface="Calibri" panose="020F0502020204030204"/>
-            </a:endParaRPr>
           </a:p>
         </p:txBody>
       </p:sp>
@@ -8629,16 +7965,10 @@
                 <a:solidFill>
                   <a:srgbClr val="2B2D42"/>
                 </a:solidFill>
-                <a:latin typeface="Calibri" panose="020F0502020204030204"/>
+                <a:latin typeface="Calibri"/>
               </a:rPr>
               <a:t>•  Deduplication finding: 3,512 rows collapse to 995 unique questions — 2,517 are the same question answered by different counselors.</a:t>
             </a:r>
-            <a:endParaRPr sz="1500" b="1" i="0">
-              <a:solidFill>
-                <a:srgbClr val="2B2D42"/>
-              </a:solidFill>
-              <a:latin typeface="Calibri" panose="020F0502020204030204"/>
-            </a:endParaRPr>
           </a:p>
           <a:p>
             <a:pPr>
@@ -8654,16 +7984,10 @@
                 <a:solidFill>
                   <a:srgbClr val="2B2D42"/>
                 </a:solidFill>
-                <a:latin typeface="Calibri" panose="020F0502020204030204"/>
+                <a:latin typeface="Calibri"/>
               </a:rPr>
               <a:t>•  Consequence: split on unique questions (GroupShuffleSplit) to avoid leakage and inflated accuracy.</a:t>
             </a:r>
-            <a:endParaRPr sz="1500" b="1" i="0">
-              <a:solidFill>
-                <a:srgbClr val="2B2D42"/>
-              </a:solidFill>
-              <a:latin typeface="Calibri" panose="020F0502020204030204"/>
-            </a:endParaRPr>
           </a:p>
           <a:p>
             <a:pPr>
@@ -8679,16 +8003,10 @@
                 <a:solidFill>
                   <a:srgbClr val="2B2D42"/>
                 </a:solidFill>
-                <a:latin typeface="Calibri" panose="020F0502020204030204"/>
+                <a:latin typeface="Calibri"/>
               </a:rPr>
               <a:t>•  Intents are imbalanced — relationship/support dominates, self-care is scarce.</a:t>
             </a:r>
-            <a:endParaRPr sz="1500" b="1" i="0">
-              <a:solidFill>
-                <a:srgbClr val="2B2D42"/>
-              </a:solidFill>
-              <a:latin typeface="Calibri" panose="020F0502020204030204"/>
-            </a:endParaRPr>
           </a:p>
           <a:p>
             <a:pPr lvl="1">
@@ -8704,16 +8022,10 @@
                 <a:solidFill>
                   <a:srgbClr val="55576B"/>
                 </a:solidFill>
-                <a:latin typeface="Calibri" panose="020F0502020204030204"/>
+                <a:latin typeface="Calibri"/>
               </a:rPr>
               <a:t>    –  This is why we report F1, not just accuracy.</a:t>
             </a:r>
-            <a:endParaRPr sz="1300" b="0" i="0">
-              <a:solidFill>
-                <a:srgbClr val="55576B"/>
-              </a:solidFill>
-              <a:latin typeface="Calibri" panose="020F0502020204030204"/>
-            </a:endParaRPr>
           </a:p>
           <a:p>
             <a:pPr>
@@ -8729,16 +8041,10 @@
                 <a:solidFill>
                   <a:srgbClr val="2B2D42"/>
                 </a:solidFill>
-                <a:latin typeface="Calibri" panose="020F0502020204030204"/>
+                <a:latin typeface="Calibri"/>
               </a:rPr>
               <a:t>•  Cleaning: scope filtering, lowercasing, TF-IDF features.</a:t>
             </a:r>
-            <a:endParaRPr sz="1500" b="1" i="0">
-              <a:solidFill>
-                <a:srgbClr val="2B2D42"/>
-              </a:solidFill>
-              <a:latin typeface="Calibri" panose="020F0502020204030204"/>
-            </a:endParaRPr>
           </a:p>
         </p:txBody>
       </p:sp>
@@ -8751,7 +8057,7 @@
           <p:nvPr/>
         </p:nvPicPr>
         <p:blipFill>
-          <a:blip r:embed="rId1"/>
+          <a:blip r:embed="rId2"/>
           <a:stretch>
             <a:fillRect/>
           </a:stretch>
@@ -8794,16 +8100,10 @@
                 <a:solidFill>
                   <a:srgbClr val="55576B"/>
                 </a:solidFill>
-                <a:latin typeface="Calibri" panose="020F0502020204030204"/>
+                <a:latin typeface="Calibri"/>
               </a:rPr>
               <a:t>Intent coverage across the maternal subset (class imbalance)</a:t>
             </a:r>
-            <a:endParaRPr sz="1000" b="0" i="1">
-              <a:solidFill>
-                <a:srgbClr val="55576B"/>
-              </a:solidFill>
-              <a:latin typeface="Calibri" panose="020F0502020204030204"/>
-            </a:endParaRPr>
           </a:p>
         </p:txBody>
       </p:sp>
@@ -8878,16 +8178,10 @@
                 <a:solidFill>
                   <a:srgbClr val="FFFFFF"/>
                 </a:solidFill>
-                <a:latin typeface="Calibri" panose="020F0502020204030204"/>
+                <a:latin typeface="Calibri"/>
               </a:rPr>
               <a:t>Umubyeyi  ·  Kinyarwanda Maternal Mental-Wellness Chatbot  ·  R. Irutingabo (ALU)</a:t>
             </a:r>
-            <a:endParaRPr sz="900" b="0" i="0">
-              <a:solidFill>
-                <a:srgbClr val="FFFFFF"/>
-              </a:solidFill>
-              <a:latin typeface="Calibri" panose="020F0502020204030204"/>
-            </a:endParaRPr>
           </a:p>
         </p:txBody>
       </p:sp>
@@ -8919,16 +8213,10 @@
                 <a:solidFill>
                   <a:srgbClr val="FFFFFF"/>
                 </a:solidFill>
-                <a:latin typeface="Calibri" panose="020F0502020204030204"/>
+                <a:latin typeface="Calibri"/>
               </a:rPr>
               <a:t>6</a:t>
             </a:r>
-            <a:endParaRPr sz="900" b="0" i="0">
-              <a:solidFill>
-                <a:srgbClr val="FFFFFF"/>
-              </a:solidFill>
-              <a:latin typeface="Calibri" panose="020F0502020204030204"/>
-            </a:endParaRPr>
           </a:p>
         </p:txBody>
       </p:sp>
@@ -8941,7 +8229,7 @@
 </file>
 
 <file path=ppt/slides/slide7.xml><?xml version="1.0" encoding="utf-8"?>
-<p:sld xmlns:a="http://schemas.openxmlformats.org/drawingml/2006/main" xmlns:r="http://schemas.openxmlformats.org/officeDocument/2006/relationships" xmlns:p="http://schemas.openxmlformats.org/presentationml/2006/main">
+<p:sld xmlns:a="http://schemas.openxmlformats.org/drawingml/2006/main" xmlns:p="http://schemas.openxmlformats.org/presentationml/2006/main" xmlns:r="http://schemas.openxmlformats.org/officeDocument/2006/relationships">
   <p:cSld>
     <p:spTree>
       <p:nvGrpSpPr>
@@ -9065,16 +8353,10 @@
                 <a:solidFill>
                   <a:srgbClr val="E76F51"/>
                 </a:solidFill>
-                <a:latin typeface="Calibri" panose="020F0502020204030204"/>
+                <a:latin typeface="Calibri"/>
               </a:rPr>
               <a:t>THE APPROACH (1/2)</a:t>
             </a:r>
-            <a:endParaRPr sz="1200" b="1" i="0">
-              <a:solidFill>
-                <a:srgbClr val="E76F51"/>
-              </a:solidFill>
-              <a:latin typeface="Calibri" panose="020F0502020204030204"/>
-            </a:endParaRPr>
           </a:p>
         </p:txBody>
       </p:sp>
@@ -9105,16 +8387,10 @@
                 <a:solidFill>
                   <a:srgbClr val="2B2D42"/>
                 </a:solidFill>
-                <a:latin typeface="Calibri" panose="020F0502020204030204"/>
+                <a:latin typeface="Calibri"/>
               </a:rPr>
               <a:t>The system pipeline</a:t>
             </a:r>
-            <a:endParaRPr sz="3000" b="1" i="0">
-              <a:solidFill>
-                <a:srgbClr val="2B2D42"/>
-              </a:solidFill>
-              <a:latin typeface="Calibri" panose="020F0502020204030204"/>
-            </a:endParaRPr>
           </a:p>
         </p:txBody>
       </p:sp>
@@ -9171,7 +8447,7 @@
           <p:nvPr/>
         </p:nvPicPr>
         <p:blipFill>
-          <a:blip r:embed="rId1"/>
+          <a:blip r:embed="rId2"/>
           <a:stretch>
             <a:fillRect/>
           </a:stretch>
@@ -9194,7 +8470,7 @@
         </p:nvSpPr>
         <p:spPr>
           <a:xfrm>
-            <a:off x="457200" y="4784090"/>
+            <a:off x="548640" y="3886200"/>
             <a:ext cx="10972800" cy="4480560"/>
           </a:xfrm>
           <a:prstGeom prst="rect">
@@ -9221,16 +8497,10 @@
                 <a:solidFill>
                   <a:srgbClr val="2B2D42"/>
                 </a:solidFill>
-                <a:latin typeface="Calibri" panose="020F0502020204030204"/>
+                <a:latin typeface="Calibri"/>
               </a:rPr>
               <a:t>•  Kinyarwanda in → NLLB-200 translates to English → TF-IDF + ML classifier assigns 1 of 6 intents → return that intent's response template → translate back → display the Kinyarwanda response with a disclaimer.</a:t>
             </a:r>
-            <a:endParaRPr sz="1400" b="1" i="0">
-              <a:solidFill>
-                <a:srgbClr val="2B2D42"/>
-              </a:solidFill>
-              <a:latin typeface="Calibri" panose="020F0502020204030204"/>
-            </a:endParaRPr>
           </a:p>
           <a:p>
             <a:pPr>
@@ -9246,16 +8516,10 @@
                 <a:solidFill>
                   <a:srgbClr val="2B2D42"/>
                 </a:solidFill>
-                <a:latin typeface="Calibri" panose="020F0502020204030204"/>
+                <a:latin typeface="Calibri"/>
               </a:rPr>
               <a:t>•  Two safety gates: (1) confidence gate — low-confidence inputs fall back to general self-care; (2) danger-sign keywords bypass everything → Rwanda helpline escalation.</a:t>
             </a:r>
-            <a:endParaRPr sz="1400" b="1" i="0">
-              <a:solidFill>
-                <a:srgbClr val="2B2D42"/>
-              </a:solidFill>
-              <a:latin typeface="Calibri" panose="020F0502020204030204"/>
-            </a:endParaRPr>
           </a:p>
           <a:p>
             <a:pPr>
@@ -9271,16 +8535,10 @@
                 <a:solidFill>
                   <a:srgbClr val="2B2D42"/>
                 </a:solidFill>
-                <a:latin typeface="Calibri" panose="020F0502020204030204"/>
+                <a:latin typeface="Calibri"/>
               </a:rPr>
               <a:t>•  Deployment MVP built: architecture diagram, web mockup, a Streamlit app and a FastAPI sketch (Swagger UI for testing).</a:t>
             </a:r>
-            <a:endParaRPr sz="1400" b="1" i="0">
-              <a:solidFill>
-                <a:srgbClr val="2B2D42"/>
-              </a:solidFill>
-              <a:latin typeface="Calibri" panose="020F0502020204030204"/>
-            </a:endParaRPr>
           </a:p>
         </p:txBody>
       </p:sp>
@@ -9355,16 +8613,10 @@
                 <a:solidFill>
                   <a:srgbClr val="FFFFFF"/>
                 </a:solidFill>
-                <a:latin typeface="Calibri" panose="020F0502020204030204"/>
+                <a:latin typeface="Calibri"/>
               </a:rPr>
               <a:t>Umubyeyi  ·  Kinyarwanda Maternal Mental-Wellness Chatbot  ·  R. Irutingabo (ALU)</a:t>
             </a:r>
-            <a:endParaRPr sz="900" b="0" i="0">
-              <a:solidFill>
-                <a:srgbClr val="FFFFFF"/>
-              </a:solidFill>
-              <a:latin typeface="Calibri" panose="020F0502020204030204"/>
-            </a:endParaRPr>
           </a:p>
         </p:txBody>
       </p:sp>
@@ -9396,16 +8648,10 @@
                 <a:solidFill>
                   <a:srgbClr val="FFFFFF"/>
                 </a:solidFill>
-                <a:latin typeface="Calibri" panose="020F0502020204030204"/>
+                <a:latin typeface="Calibri"/>
               </a:rPr>
               <a:t>7</a:t>
             </a:r>
-            <a:endParaRPr sz="900" b="0" i="0">
-              <a:solidFill>
-                <a:srgbClr val="FFFFFF"/>
-              </a:solidFill>
-              <a:latin typeface="Calibri" panose="020F0502020204030204"/>
-            </a:endParaRPr>
           </a:p>
         </p:txBody>
       </p:sp>
@@ -9418,7 +8664,7 @@
 </file>
 
 <file path=ppt/slides/slide8.xml><?xml version="1.0" encoding="utf-8"?>
-<p:sld xmlns:a="http://schemas.openxmlformats.org/drawingml/2006/main" xmlns:r="http://schemas.openxmlformats.org/officeDocument/2006/relationships" xmlns:p="http://schemas.openxmlformats.org/presentationml/2006/main">
+<p:sld xmlns:a="http://schemas.openxmlformats.org/drawingml/2006/main" xmlns:p="http://schemas.openxmlformats.org/presentationml/2006/main" xmlns:r="http://schemas.openxmlformats.org/officeDocument/2006/relationships">
   <p:cSld>
     <p:spTree>
       <p:nvGrpSpPr>
@@ -9542,16 +8788,10 @@
                 <a:solidFill>
                   <a:srgbClr val="E76F51"/>
                 </a:solidFill>
-                <a:latin typeface="Calibri" panose="020F0502020204030204"/>
+                <a:latin typeface="Calibri"/>
               </a:rPr>
               <a:t>THE APPROACH (2/2)</a:t>
             </a:r>
-            <a:endParaRPr sz="1200" b="1" i="0">
-              <a:solidFill>
-                <a:srgbClr val="E76F51"/>
-              </a:solidFill>
-              <a:latin typeface="Calibri" panose="020F0502020204030204"/>
-            </a:endParaRPr>
           </a:p>
         </p:txBody>
       </p:sp>
@@ -9564,7 +8804,7 @@
         <p:spPr>
           <a:xfrm>
             <a:off x="457200" y="640080"/>
-            <a:ext cx="11247120" cy="553085"/>
+            <a:ext cx="11247120" cy="822960"/>
           </a:xfrm>
           <a:prstGeom prst="rect">
             <a:avLst/>
@@ -9578,20 +8818,14 @@
           <a:lstStyle/>
           <a:p>
             <a:r>
-              <a:rPr lang="en-US" sz="3000" b="1" i="0">
+              <a:rPr sz="3000" b="1" i="0">
                 <a:solidFill>
                   <a:srgbClr val="2B2D42"/>
                 </a:solidFill>
-                <a:latin typeface="Calibri" panose="020F0502020204030204"/>
-              </a:rPr>
-              <a:t>Project Implentation</a:t>
-            </a:r>
-            <a:endParaRPr lang="en-US" sz="3000" b="1" i="0">
-              <a:solidFill>
-                <a:srgbClr val="2B2D42"/>
-              </a:solidFill>
-              <a:latin typeface="Calibri" panose="020F0502020204030204"/>
-            </a:endParaRPr>
+                <a:latin typeface="Calibri"/>
+              </a:rPr>
+              <a:t>The model ladder: floor → embeddings → transformer</a:t>
+            </a:r>
           </a:p>
         </p:txBody>
       </p:sp>
@@ -9666,16 +8900,10 @@
                 <a:solidFill>
                   <a:srgbClr val="55576B"/>
                 </a:solidFill>
-                <a:latin typeface="Calibri" panose="020F0502020204030204"/>
+                <a:latin typeface="Calibri"/>
               </a:rPr>
               <a:t>Three classifiers on the SAME labels and SAME 80/20 split — each adds exactly one idea and must beat the one below it.</a:t>
             </a:r>
-            <a:endParaRPr sz="1500" b="0" i="1">
-              <a:solidFill>
-                <a:srgbClr val="55576B"/>
-              </a:solidFill>
-              <a:latin typeface="Calibri" panose="020F0502020204030204"/>
-            </a:endParaRPr>
           </a:p>
         </p:txBody>
       </p:sp>
@@ -9795,16 +9023,10 @@
                 <a:solidFill>
                   <a:srgbClr val="FFFFFF"/>
                 </a:solidFill>
-                <a:latin typeface="Calibri" panose="020F0502020204030204"/>
+                <a:latin typeface="Calibri"/>
               </a:rPr>
               <a:t>1</a:t>
             </a:r>
-            <a:endParaRPr sz="3000" b="1" i="0">
-              <a:solidFill>
-                <a:srgbClr val="FFFFFF"/>
-              </a:solidFill>
-              <a:latin typeface="Calibri" panose="020F0502020204030204"/>
-            </a:endParaRPr>
           </a:p>
         </p:txBody>
       </p:sp>
@@ -9835,16 +9057,10 @@
                 <a:solidFill>
                   <a:srgbClr val="2B2D42"/>
                 </a:solidFill>
-                <a:latin typeface="Calibri" panose="020F0502020204030204"/>
+                <a:latin typeface="Calibri"/>
               </a:rPr>
               <a:t>TF-IDF + Logistic Regression   (English)</a:t>
             </a:r>
-            <a:endParaRPr sz="1600" b="1" i="0">
-              <a:solidFill>
-                <a:srgbClr val="2B2D42"/>
-              </a:solidFill>
-              <a:latin typeface="Calibri" panose="020F0502020204030204"/>
-            </a:endParaRPr>
           </a:p>
           <a:p>
             <a:pPr>
@@ -9857,16 +9073,10 @@
                 <a:solidFill>
                   <a:srgbClr val="55576B"/>
                 </a:solidFill>
-                <a:latin typeface="Calibri" panose="020F0502020204030204"/>
+                <a:latin typeface="Calibri"/>
               </a:rPr>
               <a:t>FLOOR — simple, fast, interpretable; the currently deployed path.</a:t>
             </a:r>
-            <a:endParaRPr sz="1200" b="0" i="0">
-              <a:solidFill>
-                <a:srgbClr val="55576B"/>
-              </a:solidFill>
-              <a:latin typeface="Calibri" panose="020F0502020204030204"/>
-            </a:endParaRPr>
           </a:p>
         </p:txBody>
       </p:sp>
@@ -9898,16 +9108,10 @@
                 <a:solidFill>
                   <a:srgbClr val="1A9988"/>
                 </a:solidFill>
-                <a:latin typeface="Calibri" panose="020F0502020204030204"/>
+                <a:latin typeface="Calibri"/>
               </a:rPr>
               <a:t>Done · 0.61 acc / 0.60 F1</a:t>
             </a:r>
-            <a:endParaRPr sz="1300" b="1" i="0">
-              <a:solidFill>
-                <a:srgbClr val="1A9988"/>
-              </a:solidFill>
-              <a:latin typeface="Calibri" panose="020F0502020204030204"/>
-            </a:endParaRPr>
           </a:p>
         </p:txBody>
       </p:sp>
@@ -10027,16 +9231,10 @@
                 <a:solidFill>
                   <a:srgbClr val="FFFFFF"/>
                 </a:solidFill>
-                <a:latin typeface="Calibri" panose="020F0502020204030204"/>
+                <a:latin typeface="Calibri"/>
               </a:rPr>
               <a:t>2</a:t>
             </a:r>
-            <a:endParaRPr sz="3000" b="1" i="0">
-              <a:solidFill>
-                <a:srgbClr val="FFFFFF"/>
-              </a:solidFill>
-              <a:latin typeface="Calibri" panose="020F0502020204030204"/>
-            </a:endParaRPr>
           </a:p>
         </p:txBody>
       </p:sp>
@@ -10067,16 +9265,10 @@
                 <a:solidFill>
                   <a:srgbClr val="2B2D42"/>
                 </a:solidFill>
-                <a:latin typeface="Calibri" panose="020F0502020204030204"/>
+                <a:latin typeface="Calibri"/>
               </a:rPr>
               <a:t>FastText cc.rw.300 + MLP   (Kinyarwanda)</a:t>
             </a:r>
-            <a:endParaRPr sz="1600" b="1" i="0">
-              <a:solidFill>
-                <a:srgbClr val="2B2D42"/>
-              </a:solidFill>
-              <a:latin typeface="Calibri" panose="020F0502020204030204"/>
-            </a:endParaRPr>
           </a:p>
           <a:p>
             <a:pPr>
@@ -10089,16 +9281,10 @@
                 <a:solidFill>
                   <a:srgbClr val="55576B"/>
                 </a:solidFill>
-                <a:latin typeface="Calibri" panose="020F0502020204030204"/>
+                <a:latin typeface="Calibri"/>
               </a:rPr>
               <a:t>EMBEDDINGS — dense subword vectors capture meaning + Kinyarwanda morphology / out-of-vocabulary words.</a:t>
             </a:r>
-            <a:endParaRPr sz="1200" b="0" i="0">
-              <a:solidFill>
-                <a:srgbClr val="55576B"/>
-              </a:solidFill>
-              <a:latin typeface="Calibri" panose="020F0502020204030204"/>
-            </a:endParaRPr>
           </a:p>
         </p:txBody>
       </p:sp>
@@ -10110,8 +9296,8 @@
         </p:nvSpPr>
         <p:spPr>
           <a:xfrm>
-            <a:off x="8412480" y="3882200"/>
-            <a:ext cx="3154680" cy="291465"/>
+            <a:off x="8412480" y="3456432"/>
+            <a:ext cx="3154680" cy="1143000"/>
           </a:xfrm>
           <a:prstGeom prst="rect">
             <a:avLst/>
@@ -10126,21 +9312,14 @@
           <a:p>
             <a:pPr algn="ctr"/>
             <a:r>
-              <a:rPr lang="en-US" sz="1300" b="1">
-                <a:solidFill>
-                  <a:srgbClr val="E76F51"/>
-                </a:solidFill>
-                <a:latin typeface="Calibri" panose="020F0502020204030204"/>
-                <a:sym typeface="+mn-ea"/>
-              </a:rPr>
-              <a:t>Pending</a:t>
-            </a:r>
-            <a:endParaRPr sz="1300" b="1" i="0">
-              <a:solidFill>
-                <a:srgbClr val="9B8BC4"/>
-              </a:solidFill>
-              <a:latin typeface="Calibri" panose="020F0502020204030204"/>
-            </a:endParaRPr>
+              <a:rPr sz="1300" b="1" i="0">
+                <a:solidFill>
+                  <a:srgbClr val="9B8BC4"/>
+                </a:solidFill>
+                <a:latin typeface="Calibri"/>
+              </a:rPr>
+              <a:t>Coded · pending 4.5 GB vectors</a:t>
+            </a:r>
           </a:p>
         </p:txBody>
       </p:sp>
@@ -10260,16 +9439,10 @@
                 <a:solidFill>
                   <a:srgbClr val="FFFFFF"/>
                 </a:solidFill>
-                <a:latin typeface="Calibri" panose="020F0502020204030204"/>
+                <a:latin typeface="Calibri"/>
               </a:rPr>
               <a:t>3</a:t>
             </a:r>
-            <a:endParaRPr sz="3000" b="1" i="0">
-              <a:solidFill>
-                <a:srgbClr val="FFFFFF"/>
-              </a:solidFill>
-              <a:latin typeface="Calibri" panose="020F0502020204030204"/>
-            </a:endParaRPr>
           </a:p>
         </p:txBody>
       </p:sp>
@@ -10300,16 +9473,10 @@
                 <a:solidFill>
                   <a:srgbClr val="2B2D42"/>
                 </a:solidFill>
-                <a:latin typeface="Calibri" panose="020F0502020204030204"/>
+                <a:latin typeface="Calibri"/>
               </a:rPr>
               <a:t>AfroXLMR fine-tune   (Kinyarwanda)</a:t>
             </a:r>
-            <a:endParaRPr sz="1600" b="1" i="0">
-              <a:solidFill>
-                <a:srgbClr val="2B2D42"/>
-              </a:solidFill>
-              <a:latin typeface="Calibri" panose="020F0502020204030204"/>
-            </a:endParaRPr>
           </a:p>
           <a:p>
             <a:pPr>
@@ -10322,16 +9489,10 @@
                 <a:solidFill>
                   <a:srgbClr val="55576B"/>
                 </a:solidFill>
-                <a:latin typeface="Calibri" panose="020F0502020204030204"/>
+                <a:latin typeface="Calibri"/>
               </a:rPr>
               <a:t>CEILING — contextual transformer pretrained on Kinyarwanda; classifies directly, no translate-then-classify hop.</a:t>
             </a:r>
-            <a:endParaRPr sz="1200" b="0" i="0">
-              <a:solidFill>
-                <a:srgbClr val="55576B"/>
-              </a:solidFill>
-              <a:latin typeface="Calibri" panose="020F0502020204030204"/>
-            </a:endParaRPr>
           </a:p>
         </p:txBody>
       </p:sp>
@@ -10343,8 +9504,8 @@
         </p:nvSpPr>
         <p:spPr>
           <a:xfrm>
-            <a:off x="8412480" y="5189792"/>
-            <a:ext cx="3154680" cy="291465"/>
+            <a:off x="8412480" y="4764024"/>
+            <a:ext cx="3154680" cy="1143000"/>
           </a:xfrm>
           <a:prstGeom prst="rect">
             <a:avLst/>
@@ -10359,20 +9520,14 @@
           <a:p>
             <a:pPr algn="ctr"/>
             <a:r>
-              <a:rPr lang="en-US" sz="1300" b="1" i="0">
+              <a:rPr sz="1300" b="1" i="0">
                 <a:solidFill>
                   <a:srgbClr val="E76F51"/>
                 </a:solidFill>
-                <a:latin typeface="Calibri" panose="020F0502020204030204"/>
-              </a:rPr>
-              <a:t>Pending</a:t>
-            </a:r>
-            <a:endParaRPr lang="en-US" sz="1300" b="1" i="0">
-              <a:solidFill>
-                <a:srgbClr val="E76F51"/>
-              </a:solidFill>
-              <a:latin typeface="Calibri" panose="020F0502020204030204"/>
-            </a:endParaRPr>
+                <a:latin typeface="Calibri"/>
+              </a:rPr>
+              <a:t>Coded · pending GPU run</a:t>
+            </a:r>
           </a:p>
         </p:txBody>
       </p:sp>
@@ -10447,16 +9602,10 @@
                 <a:solidFill>
                   <a:srgbClr val="FFFFFF"/>
                 </a:solidFill>
-                <a:latin typeface="Calibri" panose="020F0502020204030204"/>
+                <a:latin typeface="Calibri"/>
               </a:rPr>
               <a:t>Umubyeyi  ·  Kinyarwanda Maternal Mental-Wellness Chatbot  ·  R. Irutingabo (ALU)</a:t>
             </a:r>
-            <a:endParaRPr sz="900" b="0" i="0">
-              <a:solidFill>
-                <a:srgbClr val="FFFFFF"/>
-              </a:solidFill>
-              <a:latin typeface="Calibri" panose="020F0502020204030204"/>
-            </a:endParaRPr>
           </a:p>
         </p:txBody>
       </p:sp>
@@ -10488,16 +9637,10 @@
                 <a:solidFill>
                   <a:srgbClr val="FFFFFF"/>
                 </a:solidFill>
-                <a:latin typeface="Calibri" panose="020F0502020204030204"/>
+                <a:latin typeface="Calibri"/>
               </a:rPr>
               <a:t>8</a:t>
             </a:r>
-            <a:endParaRPr sz="900" b="0" i="0">
-              <a:solidFill>
-                <a:srgbClr val="FFFFFF"/>
-              </a:solidFill>
-              <a:latin typeface="Calibri" panose="020F0502020204030204"/>
-            </a:endParaRPr>
           </a:p>
         </p:txBody>
       </p:sp>
@@ -10510,7 +9653,7 @@
 </file>
 
 <file path=ppt/slides/slide9.xml><?xml version="1.0" encoding="utf-8"?>
-<p:sld xmlns:a="http://schemas.openxmlformats.org/drawingml/2006/main" xmlns:r="http://schemas.openxmlformats.org/officeDocument/2006/relationships" xmlns:p="http://schemas.openxmlformats.org/presentationml/2006/main">
+<p:sld xmlns:a="http://schemas.openxmlformats.org/drawingml/2006/main" xmlns:p="http://schemas.openxmlformats.org/presentationml/2006/main" xmlns:r="http://schemas.openxmlformats.org/officeDocument/2006/relationships">
   <p:cSld>
     <p:spTree>
       <p:nvGrpSpPr>
@@ -10634,16 +9777,10 @@
                 <a:solidFill>
                   <a:srgbClr val="E76F51"/>
                 </a:solidFill>
-                <a:latin typeface="Calibri" panose="020F0502020204030204"/>
+                <a:latin typeface="Calibri"/>
               </a:rPr>
               <a:t>RESULTS</a:t>
             </a:r>
-            <a:endParaRPr sz="1200" b="1" i="0">
-              <a:solidFill>
-                <a:srgbClr val="E76F51"/>
-              </a:solidFill>
-              <a:latin typeface="Calibri" panose="020F0502020204030204"/>
-            </a:endParaRPr>
           </a:p>
         </p:txBody>
       </p:sp>
@@ -10656,7 +9793,7 @@
         <p:spPr>
           <a:xfrm>
             <a:off x="457200" y="640080"/>
-            <a:ext cx="11247120" cy="553085"/>
+            <a:ext cx="11247120" cy="822960"/>
           </a:xfrm>
           <a:prstGeom prst="rect">
             <a:avLst/>
@@ -10674,16 +9811,10 @@
                 <a:solidFill>
                   <a:srgbClr val="2B2D42"/>
                 </a:solidFill>
-                <a:latin typeface="Calibri" panose="020F0502020204030204"/>
-              </a:rPr>
-              <a:t>Baseline</a:t>
-            </a:r>
-            <a:endParaRPr sz="3000" b="1" i="0">
-              <a:solidFill>
-                <a:srgbClr val="2B2D42"/>
-              </a:solidFill>
-              <a:latin typeface="Calibri" panose="020F0502020204030204"/>
-            </a:endParaRPr>
+                <a:latin typeface="Calibri"/>
+              </a:rPr>
+              <a:t>Baseline — the floor model (Model 1)</a:t>
+            </a:r>
           </a:p>
         </p:txBody>
       </p:sp>
@@ -10740,7 +9871,7 @@
           <p:nvPr/>
         </p:nvPicPr>
         <p:blipFill>
-          <a:blip r:embed="rId1"/>
+          <a:blip r:embed="rId2"/>
           <a:stretch>
             <a:fillRect/>
           </a:stretch>
@@ -10783,16 +9914,10 @@
                 <a:solidFill>
                   <a:srgbClr val="55576B"/>
                 </a:solidFill>
-                <a:latin typeface="Calibri" panose="020F0502020204030204"/>
+                <a:latin typeface="Calibri"/>
               </a:rPr>
               <a:t>Confusion matrix — TF-IDF + Logistic Regression, 6 intents</a:t>
             </a:r>
-            <a:endParaRPr sz="1000" b="0" i="1">
-              <a:solidFill>
-                <a:srgbClr val="55576B"/>
-              </a:solidFill>
-              <a:latin typeface="Calibri" panose="020F0502020204030204"/>
-            </a:endParaRPr>
           </a:p>
         </p:txBody>
       </p:sp>
@@ -10849,7 +9974,7 @@
         <p:spPr>
           <a:xfrm>
             <a:off x="6903720" y="1965960"/>
-            <a:ext cx="4572000" cy="2922905"/>
+            <a:ext cx="4572000" cy="3886200"/>
           </a:xfrm>
           <a:prstGeom prst="rect">
             <a:avLst/>
@@ -10861,6 +9986,17 @@
             <a:spAutoFit/>
           </a:bodyPr>
           <a:lstStyle/>
+          <a:p>
+            <a:r>
+              <a:rPr sz="1500" b="1" i="0">
+                <a:solidFill>
+                  <a:srgbClr val="E76F51"/>
+                </a:solidFill>
+                <a:latin typeface="Calibri"/>
+              </a:rPr>
+              <a:t>Floor model — established</a:t>
+            </a:r>
+          </a:p>
           <a:p>
             <a:pPr>
               <a:spcBef>
@@ -10872,7 +10008,7 @@
                 <a:solidFill>
                   <a:srgbClr val="2B2D42"/>
                 </a:solidFill>
-                <a:latin typeface="Calibri" panose="020F0502020204030204"/>
+                <a:latin typeface="Calibri"/>
               </a:rPr>
               <a:t>Accuracy:  </a:t>
             </a:r>
@@ -10881,16 +10017,10 @@
                 <a:solidFill>
                   <a:srgbClr val="1A9988"/>
                 </a:solidFill>
-                <a:latin typeface="Calibri" panose="020F0502020204030204"/>
+                <a:latin typeface="Calibri"/>
               </a:rPr>
               <a:t>0.61</a:t>
             </a:r>
-            <a:endParaRPr sz="1400" b="1" i="0">
-              <a:solidFill>
-                <a:srgbClr val="1A9988"/>
-              </a:solidFill>
-              <a:latin typeface="Calibri" panose="020F0502020204030204"/>
-            </a:endParaRPr>
           </a:p>
           <a:p>
             <a:pPr>
@@ -10903,7 +10033,7 @@
                 <a:solidFill>
                   <a:srgbClr val="2B2D42"/>
                 </a:solidFill>
-                <a:latin typeface="Calibri" panose="020F0502020204030204"/>
+                <a:latin typeface="Calibri"/>
               </a:rPr>
               <a:t>F1:  </a:t>
             </a:r>
@@ -10912,16 +10042,10 @@
                 <a:solidFill>
                   <a:srgbClr val="1A9988"/>
                 </a:solidFill>
-                <a:latin typeface="Calibri" panose="020F0502020204030204"/>
+                <a:latin typeface="Calibri"/>
               </a:rPr>
               <a:t>0.60</a:t>
             </a:r>
-            <a:endParaRPr sz="1400" b="1" i="0">
-              <a:solidFill>
-                <a:srgbClr val="1A9988"/>
-              </a:solidFill>
-              <a:latin typeface="Calibri" panose="020F0502020204030204"/>
-            </a:endParaRPr>
           </a:p>
           <a:p>
             <a:pPr>
@@ -10934,7 +10058,7 @@
                 <a:solidFill>
                   <a:srgbClr val="2B2D42"/>
                 </a:solidFill>
-                <a:latin typeface="Calibri" panose="020F0502020204030204"/>
+                <a:latin typeface="Calibri"/>
               </a:rPr>
               <a:t>Precision:  </a:t>
             </a:r>
@@ -10943,16 +10067,10 @@
                 <a:solidFill>
                   <a:srgbClr val="1A9988"/>
                 </a:solidFill>
-                <a:latin typeface="Calibri" panose="020F0502020204030204"/>
+                <a:latin typeface="Calibri"/>
               </a:rPr>
               <a:t>0.63</a:t>
             </a:r>
-            <a:endParaRPr sz="1400" b="1" i="0">
-              <a:solidFill>
-                <a:srgbClr val="1A9988"/>
-              </a:solidFill>
-              <a:latin typeface="Calibri" panose="020F0502020204030204"/>
-            </a:endParaRPr>
           </a:p>
           <a:p>
             <a:pPr>
@@ -10965,7 +10083,7 @@
                 <a:solidFill>
                   <a:srgbClr val="2B2D42"/>
                 </a:solidFill>
-                <a:latin typeface="Calibri" panose="020F0502020204030204"/>
+                <a:latin typeface="Calibri"/>
               </a:rPr>
               <a:t>Recall:  </a:t>
             </a:r>
@@ -10974,16 +10092,10 @@
                 <a:solidFill>
                   <a:srgbClr val="1A9988"/>
                 </a:solidFill>
-                <a:latin typeface="Calibri" panose="020F0502020204030204"/>
+                <a:latin typeface="Calibri"/>
               </a:rPr>
               <a:t>0.59</a:t>
             </a:r>
-            <a:endParaRPr sz="1400" b="1" i="0">
-              <a:solidFill>
-                <a:srgbClr val="1A9988"/>
-              </a:solidFill>
-              <a:latin typeface="Calibri" panose="020F0502020204030204"/>
-            </a:endParaRPr>
           </a:p>
           <a:p>
             <a:pPr>
@@ -10996,16 +10108,10 @@
                 <a:solidFill>
                   <a:srgbClr val="E76F51"/>
                 </a:solidFill>
-                <a:latin typeface="Calibri" panose="020F0502020204030204"/>
+                <a:latin typeface="Calibri"/>
               </a:rPr>
               <a:t>Reading the matrix</a:t>
             </a:r>
-            <a:endParaRPr sz="1300" b="1" i="0">
-              <a:solidFill>
-                <a:srgbClr val="E76F51"/>
-              </a:solidFill>
-              <a:latin typeface="Calibri" panose="020F0502020204030204"/>
-            </a:endParaRPr>
           </a:p>
           <a:p>
             <a:pPr>
@@ -11018,16 +10124,10 @@
                 <a:solidFill>
                   <a:srgbClr val="55576B"/>
                 </a:solidFill>
-                <a:latin typeface="Calibri" panose="020F0502020204030204"/>
+                <a:latin typeface="Calibri"/>
               </a:rPr>
               <a:t>•  Strong on relationship/support &amp; sleep (clear cues).</a:t>
             </a:r>
-            <a:endParaRPr sz="1200" b="0" i="0">
-              <a:solidFill>
-                <a:srgbClr val="55576B"/>
-              </a:solidFill>
-              <a:latin typeface="Calibri" panose="020F0502020204030204"/>
-            </a:endParaRPr>
           </a:p>
           <a:p>
             <a:pPr>
@@ -11040,16 +10140,10 @@
                 <a:solidFill>
                   <a:srgbClr val="55576B"/>
                 </a:solidFill>
-                <a:latin typeface="Calibri" panose="020F0502020204030204"/>
+                <a:latin typeface="Calibri"/>
               </a:rPr>
               <a:t>•  Confusion: overwhelmed ↔ relationship &amp; sadness — overlapping language, the hard intents.</a:t>
             </a:r>
-            <a:endParaRPr sz="1200" b="0" i="0">
-              <a:solidFill>
-                <a:srgbClr val="55576B"/>
-              </a:solidFill>
-              <a:latin typeface="Calibri" panose="020F0502020204030204"/>
-            </a:endParaRPr>
           </a:p>
           <a:p>
             <a:pPr>
@@ -11062,16 +10156,10 @@
                 <a:solidFill>
                   <a:srgbClr val="55576B"/>
                 </a:solidFill>
-                <a:latin typeface="Calibri" panose="020F0502020204030204"/>
+                <a:latin typeface="Calibri"/>
               </a:rPr>
               <a:t>•  F1 &lt; accuracy → the minority intents are where the work is.</a:t>
             </a:r>
-            <a:endParaRPr sz="1200" b="0" i="0">
-              <a:solidFill>
-                <a:srgbClr val="55576B"/>
-              </a:solidFill>
-              <a:latin typeface="Calibri" panose="020F0502020204030204"/>
-            </a:endParaRPr>
           </a:p>
           <a:p>
             <a:pPr>
@@ -11084,16 +10172,10 @@
                 <a:solidFill>
                   <a:srgbClr val="55576B"/>
                 </a:solidFill>
-                <a:latin typeface="Calibri" panose="020F0502020204030204"/>
+                <a:latin typeface="Calibri"/>
               </a:rPr>
               <a:t>Honest INITIAL baseline. Models 2 &amp; 3 (FastText, AfroXLMR) are coded and pending compute.</a:t>
             </a:r>
-            <a:endParaRPr sz="1100" b="0" i="1">
-              <a:solidFill>
-                <a:srgbClr val="55576B"/>
-              </a:solidFill>
-              <a:latin typeface="Calibri" panose="020F0502020204030204"/>
-            </a:endParaRPr>
           </a:p>
         </p:txBody>
       </p:sp>
@@ -11168,16 +10250,10 @@
                 <a:solidFill>
                   <a:srgbClr val="FFFFFF"/>
                 </a:solidFill>
-                <a:latin typeface="Calibri" panose="020F0502020204030204"/>
+                <a:latin typeface="Calibri"/>
               </a:rPr>
               <a:t>Umubyeyi  ·  Kinyarwanda Maternal Mental-Wellness Chatbot  ·  R. Irutingabo (ALU)</a:t>
             </a:r>
-            <a:endParaRPr sz="900" b="0" i="0">
-              <a:solidFill>
-                <a:srgbClr val="FFFFFF"/>
-              </a:solidFill>
-              <a:latin typeface="Calibri" panose="020F0502020204030204"/>
-            </a:endParaRPr>
           </a:p>
         </p:txBody>
       </p:sp>
@@ -11209,16 +10285,10 @@
                 <a:solidFill>
                   <a:srgbClr val="FFFFFF"/>
                 </a:solidFill>
-                <a:latin typeface="Calibri" panose="020F0502020204030204"/>
+                <a:latin typeface="Calibri"/>
               </a:rPr>
               <a:t>9</a:t>
             </a:r>
-            <a:endParaRPr sz="900" b="0" i="0">
-              <a:solidFill>
-                <a:srgbClr val="FFFFFF"/>
-              </a:solidFill>
-              <a:latin typeface="Calibri" panose="020F0502020204030204"/>
-            </a:endParaRPr>
           </a:p>
         </p:txBody>
       </p:sp>
@@ -11546,10 +10616,6 @@
       </a:style>
     </a:lnDef>
   </a:objectDefaults>
-  <a:extLst>
-    <a:ext uri="{05A4C25C-085E-4340-85A3-A5531E510DB2}">
-      <thm15:themeFamily xmlns:thm15="http://schemas.microsoft.com/office/thememl/2012/main" name="Office Theme" id="{62F939B6-93AF-4DB8-9C6B-D6C7DFDC589F}" vid="{4A3C46E8-61CC-4603-A589-7422A47A8E4A}"/>
-    </a:ext>
-  </a:extLst>
+  <a:extraClrSchemeLst/>
 </a:theme>
 </file>
</xml_diff>